<commit_message>
e2e6m S6: the deck at 27 slides (DRAFT) -- the CF campaign told from the records
Two new main slides -- "Both dials lose to the operating point" (the
gate; the Lyot closed-loop stall; the spacing inversion with its
gap-Fresnel attribution and the measured-shroud annotation) and "The
physics layers at the operating point" (pol benign at 4.4e-13 despite
a 9.5% co-pol imprint; band 1.3x over 20%; layers non-interacting) --
plus the loop slide's toned-series finding (the ~2.5e-7 hold is the
mechanization's own floor).  Records fns cf3b/cf4/cf5 (loud on any
miss); r4() re-pointed at the preserved 3 nm report so its narrative
stays true; style gate run (one wording fix).  DRAFT marker stands
until Dave's pass.

Co-Authored-By: Claude Fable 5 <noreply@anthropic.com>
</commit_message>
<xml_diff>
--- a/mmacos/templates/80_end_to_end/e2e6m_r2/deck_e2e6m_r2.pptx
+++ b/mmacos/templates/80_end_to_end/e2e6m_r2/deck_e2e6m_r2.pptx
@@ -30,6 +30,8 @@
     <p:sldId id="278" r:id="rId29"/>
     <p:sldId id="279" r:id="rId30"/>
     <p:sldId id="280" r:id="rId31"/>
+    <p:sldId id="281" r:id="rId32"/>
+    <p:sldId id="282" r:id="rId33"/>
   </p:sldIdLst>
   <p:sldSz cx="12191695" cy="6858000" type="screen4x3"/>
   <p:notesSz cx="6858000" cy="9144000"/>
@@ -3441,7 +3443,7 @@
                 </a:solidFill>
                 <a:latin typeface="Arial"/>
               </a:rPr>
-              <a:t> classical Lyot 3.50e-06 pre-control, 23% throughput; apodized Lyot 4.37e-07 pre-control, 9% throughput; APLC 2.18e-06 pre-control, 8% throughput (aperture-matched prolate: solver-limited, flag stands); band-limited 1.64e-06 pre-control, 12% throughput; vortex c4 1.64e-05 pre-control, 33% throughput; c6 1.87e-05 pre-control, 33% throughput — the vortex passes the segment-gap light the occulting families block.</a:t>
+              <a:t> classical Lyot 3.50e-06 pre-control, 23% throughput; apodized Lyot 4.37e-07 pre-control, 9% throughput; APLC-as-implemented 2.18e-06 pre-control, 8% throughput (cap-limited prolate, not design-grade on this pupil; family DEFERRED); band-limited 1.64e-06 pre-control, 12% throughput; vortex c4 1.64e-05 pre-control, 33% throughput; c6 1.87e-05 pre-control, 33% throughput — the vortex passes the segment-gap light the occulting families block.</a:t>
             </a:r>
           </a:p>
           <a:p>
@@ -3712,7 +3714,7 @@
                 </a:solidFill>
                 <a:latin typeface="Arial"/>
               </a:rPr>
-              <a:t> classical Lyot 3.5e-06 -&gt; 3.9e-07 | 2.1e-07; apodized Lyot 4.5e-07 -&gt; 1.1e-07 | 1.1e-07 (the campaign floor); APLC 1.1e-06 -&gt; 7.5e-07 | 7.5e-07; band-limited 1.6e-06 -&gt; 1.3e-06 | 7.2e-07; vortex c4 1.6e-05 -&gt; 5.4e-06 | 5.5e-06; c6 1.8e-05 -&gt; 3.9e-06 | 4.7e-06.</a:t>
+              <a:t> classical Lyot 3.5e-06 -&gt; 3.9e-07 | 2.1e-07; apodized Lyot 4.5e-07 -&gt; 1.1e-07 | 1.1e-07 (the campaign floor); APLC-as-implemented 1.1e-06 -&gt; 7.5e-07 | 7.5e-07 (implementation verdict, not family); band-limited 1.6e-06 -&gt; 1.3e-06 | 7.2e-07; vortex c4 1.6e-05 -&gt; 5.4e-06 | 5.5e-06; c6 1.8e-05 -&gt; 3.9e-06 | 4.7e-06.</a:t>
             </a:r>
           </a:p>
           <a:p>
@@ -4128,6 +4130,616 @@
 </file>
 
 <file path=ppt/slides/slide13.xml><?xml version="1.0" encoding="utf-8"?>
+<p:sld xmlns:a="http://schemas.openxmlformats.org/drawingml/2006/main" xmlns:p="http://schemas.openxmlformats.org/presentationml/2006/main" xmlns:r="http://schemas.openxmlformats.org/officeDocument/2006/relationships">
+  <p:cSld>
+    <p:spTree>
+      <p:nvGrpSpPr>
+        <p:cNvPr id="1" name=""/>
+        <p:cNvGrpSpPr/>
+        <p:nvPr/>
+      </p:nvGrpSpPr>
+      <p:grpSpPr/>
+      <p:sp>
+        <p:nvSpPr>
+          <p:cNvPr id="2" name="TextBox 1"/>
+          <p:cNvSpPr txBox="1"/>
+          <p:nvPr/>
+        </p:nvSpPr>
+        <p:spPr>
+          <a:xfrm>
+            <a:off x="411480" y="201168"/>
+            <a:ext cx="11368735" cy="914400"/>
+          </a:xfrm>
+          <a:prstGeom prst="rect">
+            <a:avLst/>
+          </a:prstGeom>
+          <a:noFill/>
+        </p:spPr>
+        <p:txBody>
+          <a:bodyPr wrap="square">
+            <a:spAutoFit/>
+          </a:bodyPr>
+          <a:lstStyle/>
+          <a:p>
+            <a:pPr>
+              <a:spcAft>
+                <a:spcPts val="400"/>
+              </a:spcAft>
+            </a:pPr>
+            <a:r>
+              <a:rPr sz="2400" b="1">
+                <a:solidFill>
+                  <a:srgbClr val="1F4E79"/>
+                </a:solidFill>
+                <a:latin typeface="Arial"/>
+              </a:rPr>
+              <a:t>Both dials lose to the operating point</a:t>
+            </a:r>
+          </a:p>
+          <a:p>
+            <a:pPr>
+              <a:spcAft>
+                <a:spcPts val="0"/>
+              </a:spcAft>
+            </a:pPr>
+            <a:r>
+              <a:rPr sz="1250" b="0">
+                <a:solidFill>
+                  <a:srgbClr val="6E6E6E"/>
+                </a:solidFill>
+                <a:latin typeface="Arial"/>
+              </a:rPr>
+              <a:t>Lyot 0.90 and 0.15 m spacing were confirmed by measurement, not defaulted</a:t>
+            </a:r>
+          </a:p>
+        </p:txBody>
+      </p:sp>
+      <p:sp>
+        <p:nvSpPr>
+          <p:cNvPr id="3" name="Rectangle 2"/>
+          <p:cNvSpPr/>
+          <p:nvPr/>
+        </p:nvSpPr>
+        <p:spPr>
+          <a:xfrm>
+            <a:off x="411480" y="1133856"/>
+            <a:ext cx="11368735" cy="20320"/>
+          </a:xfrm>
+          <a:prstGeom prst="rect">
+            <a:avLst/>
+          </a:prstGeom>
+          <a:solidFill>
+            <a:srgbClr val="B8C6D4"/>
+          </a:solidFill>
+          <a:ln>
+            <a:noFill/>
+          </a:ln>
+          <a:effectLst/>
+        </p:spPr>
+        <p:style>
+          <a:lnRef idx="1">
+            <a:schemeClr val="accent1"/>
+          </a:lnRef>
+          <a:fillRef idx="3">
+            <a:schemeClr val="accent1"/>
+          </a:fillRef>
+          <a:effectRef idx="2">
+            <a:schemeClr val="accent1"/>
+          </a:effectRef>
+          <a:fontRef idx="minor">
+            <a:schemeClr val="lt1"/>
+          </a:fontRef>
+        </p:style>
+        <p:txBody>
+          <a:bodyPr rtlCol="0" anchor="ctr"/>
+          <a:lstStyle/>
+          <a:p>
+            <a:pPr algn="ctr"/>
+          </a:p>
+        </p:txBody>
+      </p:sp>
+      <p:sp>
+        <p:nvSpPr>
+          <p:cNvPr id="4" name="TextBox 3"/>
+          <p:cNvSpPr txBox="1"/>
+          <p:nvPr/>
+        </p:nvSpPr>
+        <p:spPr>
+          <a:xfrm>
+            <a:off x="411480" y="1298448"/>
+            <a:ext cx="5806440" cy="274320"/>
+          </a:xfrm>
+          <a:prstGeom prst="rect">
+            <a:avLst/>
+          </a:prstGeom>
+          <a:noFill/>
+        </p:spPr>
+        <p:txBody>
+          <a:bodyPr wrap="square">
+            <a:spAutoFit/>
+          </a:bodyPr>
+          <a:lstStyle/>
+          <a:p>
+            <a:pPr>
+              <a:spcAft>
+                <a:spcPts val="600"/>
+              </a:spcAft>
+            </a:pPr>
+            <a:r>
+              <a:rPr sz="1200" b="0">
+                <a:solidFill>
+                  <a:srgbClr val="282828"/>
+                </a:solidFill>
+                <a:latin typeface="Arial"/>
+              </a:rPr>
+              <a:t>•  </a:t>
+            </a:r>
+            <a:r>
+              <a:rPr sz="1200" b="1">
+                <a:solidFill>
+                  <a:srgbClr val="282828"/>
+                </a:solidFill>
+                <a:latin typeface="Arial"/>
+              </a:rPr>
+              <a:t>The gate.</a:t>
+            </a:r>
+            <a:r>
+              <a:rPr sz="1200" b="0">
+                <a:solidFill>
+                  <a:srgbClr val="282828"/>
+                </a:solidFill>
+                <a:latin typeface="Arial"/>
+              </a:rPr>
+              <a:t>  The campaign's operating point — apodized Lyot, 1.08e-07 floor at 9.5% throughput, spacing 0.15 m — was put to both of its dials before the physics layers ran.</a:t>
+            </a:r>
+          </a:p>
+          <a:p>
+            <a:pPr>
+              <a:spcAft>
+                <a:spcPts val="600"/>
+              </a:spcAft>
+            </a:pPr>
+            <a:r>
+              <a:rPr sz="1200" b="0">
+                <a:solidFill>
+                  <a:srgbClr val="282828"/>
+                </a:solidFill>
+                <a:latin typeface="Arial"/>
+              </a:rPr>
+              <a:t>•  </a:t>
+            </a:r>
+            <a:r>
+              <a:rPr sz="1200" b="1">
+                <a:solidFill>
+                  <a:srgbClr val="282828"/>
+                </a:solidFill>
+                <a:latin typeface="Arial"/>
+              </a:rPr>
+              <a:t>The Lyot dial stalls closed-loop.</a:t>
+            </a:r>
+            <a:r>
+              <a:rPr sz="1200" b="0">
+                <a:solidFill>
+                  <a:srgbClr val="282828"/>
+                </a:solidFill>
+                <a:latin typeface="Arial"/>
+              </a:rPr>
+              <a:t>  The static dial is flat (previous slide), but at L=0.98 the loop stops in two iterations at 1.58e-07 — 1.46x the contrast for 1.19x the throughput, a net loss in a throughput/contrast merit — and the wide-ladder retry does not dig.  Static-free is not loop-free.</a:t>
+            </a:r>
+          </a:p>
+          <a:p>
+            <a:pPr>
+              <a:spcAft>
+                <a:spcPts val="600"/>
+              </a:spcAft>
+            </a:pPr>
+            <a:r>
+              <a:rPr sz="1200" b="0">
+                <a:solidFill>
+                  <a:srgbClr val="282828"/>
+                </a:solidFill>
+                <a:latin typeface="Arial"/>
+              </a:rPr>
+              <a:t>•  </a:t>
+            </a:r>
+            <a:r>
+              <a:rPr sz="1200" b="1">
+                <a:solidFill>
+                  <a:srgbClr val="282828"/>
+                </a:solidFill>
+                <a:latin typeface="Arial"/>
+              </a:rPr>
+              <a:t>The spacing dial's knee IS the baseline.</a:t>
+            </a:r>
+            <a:r>
+              <a:rPr sz="1200" b="0">
+                <a:solidFill>
+                  <a:srgbClr val="282828"/>
+                </a:solidFill>
+                <a:latin typeface="Arial"/>
+              </a:rPr>
+              <a:t>  Floors 1.08e-07 / 4.98e-07 / 9.67e-07 / 9.00e-07 at 0.15/0.40/0.70/1.10 m: the Talbot expectation INVERTS — wider spacing raises the linear-achievable bound and the loop cannot take it, because the STATIC degrades faster than the authority grows.  Attributed by measurement: the added light is the same amplitude-type gap-Fresnel family (symmetric fraction 0.986 at every spacing), evolved over the longer DM1-to-DM2 leg.  Packaging never discriminates (7.451 m shroud at every point, measured).</a:t>
+            </a:r>
+          </a:p>
+        </p:txBody>
+      </p:sp>
+      <p:pic>
+        <p:nvPicPr>
+          <p:cNvPr id="5" name="Picture 4" descr="cf3b_spacing.png"/>
+          <p:cNvPicPr>
+            <a:picLocks noChangeAspect="1"/>
+          </p:cNvPicPr>
+          <p:nvPr/>
+        </p:nvPicPr>
+        <p:blipFill>
+          <a:blip r:embed="rId2"/>
+          <a:stretch>
+            <a:fillRect/>
+          </a:stretch>
+        </p:blipFill>
+        <p:spPr>
+          <a:xfrm>
+            <a:off x="6798018" y="1298448"/>
+            <a:ext cx="4600523" cy="3629152"/>
+          </a:xfrm>
+          <a:prstGeom prst="rect">
+            <a:avLst/>
+          </a:prstGeom>
+        </p:spPr>
+      </p:pic>
+      <p:sp>
+        <p:nvSpPr>
+          <p:cNvPr id="6" name="TextBox 5"/>
+          <p:cNvSpPr txBox="1"/>
+          <p:nvPr/>
+        </p:nvSpPr>
+        <p:spPr>
+          <a:xfrm>
+            <a:off x="6400800" y="4945888"/>
+            <a:ext cx="5394960" cy="394208"/>
+          </a:xfrm>
+          <a:prstGeom prst="rect">
+            <a:avLst/>
+          </a:prstGeom>
+          <a:noFill/>
+        </p:spPr>
+        <p:txBody>
+          <a:bodyPr wrap="square">
+            <a:spAutoFit/>
+          </a:bodyPr>
+          <a:lstStyle/>
+          <a:p>
+            <a:pPr algn="ctr">
+              <a:spcAft>
+                <a:spcPts val="0"/>
+              </a:spcAft>
+            </a:pPr>
+            <a:r>
+              <a:rPr sz="1000" b="0">
+                <a:solidFill>
+                  <a:srgbClr val="6E6E6E"/>
+                </a:solidFill>
+                <a:latin typeface="Arial"/>
+              </a:rPr>
+              <a:t>The Talbot knob measured: closed-loop floor and linear-achievable vs DM spacing — the bound deepens as the floor worsens.</a:t>
+            </a:r>
+          </a:p>
+        </p:txBody>
+      </p:sp>
+    </p:spTree>
+  </p:cSld>
+  <p:clrMapOvr>
+    <a:masterClrMapping/>
+  </p:clrMapOvr>
+</p:sld>
+</file>
+
+<file path=ppt/slides/slide14.xml><?xml version="1.0" encoding="utf-8"?>
+<p:sld xmlns:a="http://schemas.openxmlformats.org/drawingml/2006/main" xmlns:p="http://schemas.openxmlformats.org/presentationml/2006/main" xmlns:r="http://schemas.openxmlformats.org/officeDocument/2006/relationships">
+  <p:cSld>
+    <p:spTree>
+      <p:nvGrpSpPr>
+        <p:cNvPr id="1" name=""/>
+        <p:cNvGrpSpPr/>
+        <p:nvPr/>
+      </p:nvGrpSpPr>
+      <p:grpSpPr/>
+      <p:sp>
+        <p:nvSpPr>
+          <p:cNvPr id="2" name="TextBox 1"/>
+          <p:cNvSpPr txBox="1"/>
+          <p:nvPr/>
+        </p:nvSpPr>
+        <p:spPr>
+          <a:xfrm>
+            <a:off x="411480" y="201168"/>
+            <a:ext cx="11368735" cy="914400"/>
+          </a:xfrm>
+          <a:prstGeom prst="rect">
+            <a:avLst/>
+          </a:prstGeom>
+          <a:noFill/>
+        </p:spPr>
+        <p:txBody>
+          <a:bodyPr wrap="square">
+            <a:spAutoFit/>
+          </a:bodyPr>
+          <a:lstStyle/>
+          <a:p>
+            <a:pPr>
+              <a:spcAft>
+                <a:spcPts val="400"/>
+              </a:spcAft>
+            </a:pPr>
+            <a:r>
+              <a:rPr sz="2400" b="1">
+                <a:solidFill>
+                  <a:srgbClr val="1F4E79"/>
+                </a:solidFill>
+                <a:latin typeface="Arial"/>
+              </a:rPr>
+              <a:t>The physics layers at the operating point</a:t>
+            </a:r>
+          </a:p>
+          <a:p>
+            <a:pPr>
+              <a:spcAft>
+                <a:spcPts val="0"/>
+              </a:spcAft>
+            </a:pPr>
+            <a:r>
+              <a:rPr sz="1250" b="0">
+                <a:solidFill>
+                  <a:srgbClr val="6E6E6E"/>
+                </a:solidFill>
+                <a:latin typeface="Arial"/>
+              </a:rPr>
+              <a:t>Polarization does not set the floor; the chromatic penalty is 1.3x over a 20% band; the layers do not interact</a:t>
+            </a:r>
+          </a:p>
+        </p:txBody>
+      </p:sp>
+      <p:sp>
+        <p:nvSpPr>
+          <p:cNvPr id="3" name="Rectangle 2"/>
+          <p:cNvSpPr/>
+          <p:nvPr/>
+        </p:nvSpPr>
+        <p:spPr>
+          <a:xfrm>
+            <a:off x="411480" y="1133856"/>
+            <a:ext cx="11368735" cy="20320"/>
+          </a:xfrm>
+          <a:prstGeom prst="rect">
+            <a:avLst/>
+          </a:prstGeom>
+          <a:solidFill>
+            <a:srgbClr val="B8C6D4"/>
+          </a:solidFill>
+          <a:ln>
+            <a:noFill/>
+          </a:ln>
+          <a:effectLst/>
+        </p:spPr>
+        <p:style>
+          <a:lnRef idx="1">
+            <a:schemeClr val="accent1"/>
+          </a:lnRef>
+          <a:fillRef idx="3">
+            <a:schemeClr val="accent1"/>
+          </a:fillRef>
+          <a:effectRef idx="2">
+            <a:schemeClr val="accent1"/>
+          </a:effectRef>
+          <a:fontRef idx="minor">
+            <a:schemeClr val="lt1"/>
+          </a:fontRef>
+        </p:style>
+        <p:txBody>
+          <a:bodyPr rtlCol="0" anchor="ctr"/>
+          <a:lstStyle/>
+          <a:p>
+            <a:pPr algn="ctr"/>
+          </a:p>
+        </p:txBody>
+      </p:sp>
+      <p:sp>
+        <p:nvSpPr>
+          <p:cNvPr id="4" name="TextBox 3"/>
+          <p:cNvSpPr txBox="1"/>
+          <p:nvPr/>
+        </p:nvSpPr>
+        <p:spPr>
+          <a:xfrm>
+            <a:off x="411480" y="1298448"/>
+            <a:ext cx="5806440" cy="274320"/>
+          </a:xfrm>
+          <a:prstGeom prst="rect">
+            <a:avLst/>
+          </a:prstGeom>
+          <a:noFill/>
+        </p:spPr>
+        <p:txBody>
+          <a:bodyPr wrap="square">
+            <a:spAutoFit/>
+          </a:bodyPr>
+          <a:lstStyle/>
+          <a:p>
+            <a:pPr>
+              <a:spcAft>
+                <a:spcPts val="600"/>
+              </a:spcAft>
+            </a:pPr>
+            <a:r>
+              <a:rPr sz="1200" b="0">
+                <a:solidFill>
+                  <a:srgbClr val="282828"/>
+                </a:solidFill>
+                <a:latin typeface="Arial"/>
+              </a:rPr>
+              <a:t>•  </a:t>
+            </a:r>
+            <a:r>
+              <a:rPr sz="1200" b="1">
+                <a:solidFill>
+                  <a:srgbClr val="282828"/>
+                </a:solidFill>
+                <a:latin typeface="Arial"/>
+              </a:rPr>
+              <a:t>Polarization.</a:t>
+            </a:r>
+            <a:r>
+              <a:rPr sz="1200" b="0">
+                <a:solidFill>
+                  <a:srgbClr val="282828"/>
+                </a:solidFill>
+                <a:latin typeface="Arial"/>
+              </a:rPr>
+              <a:t>  All 31 reflectors coated (protected aluminum), Jones-pupil screens at the exit pupil, complex-mean normalized.  The co-polarized imprint is 9.5% — twenty times the CTB's gentle train — yet almost entirely common-mode: the screened floor equals the unscreened one, and the UNCONTROLLABLE polarization floor is 4.4e-13.</a:t>
+            </a:r>
+          </a:p>
+          <a:p>
+            <a:pPr>
+              <a:spcAft>
+                <a:spcPts val="600"/>
+              </a:spcAft>
+            </a:pPr>
+            <a:r>
+              <a:rPr sz="1200" b="0">
+                <a:solidFill>
+                  <a:srgbClr val="282828"/>
+                </a:solidFill>
+                <a:latin typeface="Arial"/>
+              </a:rPr>
+              <a:t>•  </a:t>
+            </a:r>
+            <a:r>
+              <a:rPr sz="1200" b="1">
+                <a:solidFill>
+                  <a:srgbClr val="282828"/>
+                </a:solidFill>
+                <a:latin typeface="Arial"/>
+              </a:rPr>
+              <a:t>Bandwidth.</a:t>
+            </a:r>
+            <a:r>
+              <a:rPr sz="1200" b="0">
+                <a:solidFill>
+                  <a:srgbClr val="282828"/>
+                </a:solidFill>
+                <a:latin typeface="Arial"/>
+              </a:rPr>
+              <a:t>  One 9-color superset Jacobian, per-band block subsets: floors 1.62e-07 / 1.64e-07 / 1.72e-07 / 2.07e-07 at 0/5/10/20% — the floor is gap-speckle-owned, not chromatic (the inverse of the CTB vortex, whose floor was chromaticity).</a:t>
+            </a:r>
+          </a:p>
+          <a:p>
+            <a:pPr>
+              <a:spcAft>
+                <a:spcPts val="600"/>
+              </a:spcAft>
+            </a:pPr>
+            <a:r>
+              <a:rPr sz="1200" b="0">
+                <a:solidFill>
+                  <a:srgbClr val="282828"/>
+                </a:solidFill>
+                <a:latin typeface="Arial"/>
+              </a:rPr>
+              <a:t>•  </a:t>
+            </a:r>
+            <a:r>
+              <a:rPr sz="1200" b="1">
+                <a:solidFill>
+                  <a:srgbClr val="282828"/>
+                </a:solidFill>
+                <a:latin typeface="Arial"/>
+              </a:rPr>
+              <a:t>Together.</a:t>
+            </a:r>
+            <a:r>
+              <a:rPr sz="1200" b="0">
+                <a:solidFill>
+                  <a:srgbClr val="282828"/>
+                </a:solidFill>
+                <a:latin typeface="Arial"/>
+              </a:rPr>
+              <a:t>  10% band + screens: 1.72e-07 — the band-only floor to three digits.  The mask memoization behind the sweep is gated bit-exact (backup).</a:t>
+            </a:r>
+          </a:p>
+        </p:txBody>
+      </p:sp>
+      <p:pic>
+        <p:nvPicPr>
+          <p:cNvPr id="5" name="Picture 4" descr="cf4_physics.png"/>
+          <p:cNvPicPr>
+            <a:picLocks noChangeAspect="1"/>
+          </p:cNvPicPr>
+          <p:nvPr/>
+        </p:nvPicPr>
+        <p:blipFill>
+          <a:blip r:embed="rId2"/>
+          <a:stretch>
+            <a:fillRect/>
+          </a:stretch>
+        </p:blipFill>
+        <p:spPr>
+          <a:xfrm>
+            <a:off x="6654870" y="1298448"/>
+            <a:ext cx="4886819" cy="3629152"/>
+          </a:xfrm>
+          <a:prstGeom prst="rect">
+            <a:avLst/>
+          </a:prstGeom>
+        </p:spPr>
+      </p:pic>
+      <p:sp>
+        <p:nvSpPr>
+          <p:cNvPr id="6" name="TextBox 5"/>
+          <p:cNvSpPr txBox="1"/>
+          <p:nvPr/>
+        </p:nvSpPr>
+        <p:spPr>
+          <a:xfrm>
+            <a:off x="6400800" y="4945888"/>
+            <a:ext cx="5394960" cy="394208"/>
+          </a:xfrm>
+          <a:prstGeom prst="rect">
+            <a:avLst/>
+          </a:prstGeom>
+          <a:noFill/>
+        </p:spPr>
+        <p:txBody>
+          <a:bodyPr wrap="square">
+            <a:spAutoFit/>
+          </a:bodyPr>
+          <a:lstStyle/>
+          <a:p>
+            <a:pPr algn="ctr">
+              <a:spcAft>
+                <a:spcPts val="0"/>
+              </a:spcAft>
+            </a:pPr>
+            <a:r>
+              <a:rPr sz="1000" b="0">
+                <a:solidFill>
+                  <a:srgbClr val="6E6E6E"/>
+                </a:solidFill>
+                <a:latin typeface="Arial"/>
+              </a:rPr>
+              <a:t>The physics ladder at the gate point: polarization, the band ladder, and band+pol together.</a:t>
+            </a:r>
+          </a:p>
+        </p:txBody>
+      </p:sp>
+    </p:spTree>
+  </p:cSld>
+  <p:clrMapOvr>
+    <a:masterClrMapping/>
+  </p:clrMapOvr>
+</p:sld>
+</file>
+
+<file path=ppt/slides/slide15.xml><?xml version="1.0" encoding="utf-8"?>
 <p:sld xmlns:a="http://schemas.openxmlformats.org/drawingml/2006/main" xmlns:p="http://schemas.openxmlformats.org/presentationml/2006/main" xmlns:r="http://schemas.openxmlformats.org/officeDocument/2006/relationships">
   <p:cSld>
     <p:spTree>
@@ -4974,7 +5586,7 @@
 </p:sld>
 </file>
 
-<file path=ppt/slides/slide14.xml><?xml version="1.0" encoding="utf-8"?>
+<file path=ppt/slides/slide16.xml><?xml version="1.0" encoding="utf-8"?>
 <p:sld xmlns:a="http://schemas.openxmlformats.org/drawingml/2006/main" xmlns:p="http://schemas.openxmlformats.org/presentationml/2006/main" xmlns:r="http://schemas.openxmlformats.org/officeDocument/2006/relationships">
   <p:cSld>
     <p:spTree>
@@ -5267,621 +5879,6 @@
                 <a:latin typeface="Arial"/>
               </a:rPr>
               <a:t>The as-built truss: beams from the 19 segments to the hub fiducials; edge sensors on the segment boundaries.</a:t>
-            </a:r>
-          </a:p>
-        </p:txBody>
-      </p:sp>
-    </p:spTree>
-  </p:cSld>
-  <p:clrMapOvr>
-    <a:masterClrMapping/>
-  </p:clrMapOvr>
-</p:sld>
-</file>
-
-<file path=ppt/slides/slide15.xml><?xml version="1.0" encoding="utf-8"?>
-<p:sld xmlns:a="http://schemas.openxmlformats.org/drawingml/2006/main" xmlns:p="http://schemas.openxmlformats.org/presentationml/2006/main" xmlns:r="http://schemas.openxmlformats.org/officeDocument/2006/relationships">
-  <p:cSld>
-    <p:spTree>
-      <p:nvGrpSpPr>
-        <p:cNvPr id="1" name=""/>
-        <p:cNvGrpSpPr/>
-        <p:nvPr/>
-      </p:nvGrpSpPr>
-      <p:grpSpPr/>
-      <p:sp>
-        <p:nvSpPr>
-          <p:cNvPr id="2" name="TextBox 1"/>
-          <p:cNvSpPr txBox="1"/>
-          <p:nvPr/>
-        </p:nvSpPr>
-        <p:spPr>
-          <a:xfrm>
-            <a:off x="411480" y="201168"/>
-            <a:ext cx="11368735" cy="914400"/>
-          </a:xfrm>
-          <a:prstGeom prst="rect">
-            <a:avLst/>
-          </a:prstGeom>
-          <a:noFill/>
-        </p:spPr>
-        <p:txBody>
-          <a:bodyPr wrap="square">
-            <a:spAutoFit/>
-          </a:bodyPr>
-          <a:lstStyle/>
-          <a:p>
-            <a:pPr>
-              <a:spcAft>
-                <a:spcPts val="400"/>
-              </a:spcAft>
-            </a:pPr>
-            <a:r>
-              <a:rPr sz="2400" b="1">
-                <a:solidFill>
-                  <a:srgbClr val="1F4E79"/>
-                </a:solidFill>
-                <a:latin typeface="Arial"/>
-              </a:rPr>
-              <a:t>The loop closes</a:t>
-            </a:r>
-          </a:p>
-          <a:p>
-            <a:pPr>
-              <a:spcAft>
-                <a:spcPts val="0"/>
-              </a:spcAft>
-            </a:pPr>
-            <a:r>
-              <a:rPr sz="1250" b="0">
-                <a:solidFill>
-                  <a:srgbClr val="6E6E6E"/>
-                </a:solidFill>
-                <a:latin typeface="Arial"/>
-              </a:rPr>
-              <a:t>The dark zone held under drift: 2.5e-07 against 1.7e-06 open-loop</a:t>
-            </a:r>
-          </a:p>
-        </p:txBody>
-      </p:sp>
-      <p:sp>
-        <p:nvSpPr>
-          <p:cNvPr id="3" name="Rectangle 2"/>
-          <p:cNvSpPr/>
-          <p:nvPr/>
-        </p:nvSpPr>
-        <p:spPr>
-          <a:xfrm>
-            <a:off x="411480" y="1133856"/>
-            <a:ext cx="11368735" cy="20320"/>
-          </a:xfrm>
-          <a:prstGeom prst="rect">
-            <a:avLst/>
-          </a:prstGeom>
-          <a:solidFill>
-            <a:srgbClr val="B8C6D4"/>
-          </a:solidFill>
-          <a:ln>
-            <a:noFill/>
-          </a:ln>
-          <a:effectLst/>
-        </p:spPr>
-        <p:style>
-          <a:lnRef idx="1">
-            <a:schemeClr val="accent1"/>
-          </a:lnRef>
-          <a:fillRef idx="3">
-            <a:schemeClr val="accent1"/>
-          </a:fillRef>
-          <a:effectRef idx="2">
-            <a:schemeClr val="accent1"/>
-          </a:effectRef>
-          <a:fontRef idx="minor">
-            <a:schemeClr val="lt1"/>
-          </a:fontRef>
-        </p:style>
-        <p:txBody>
-          <a:bodyPr rtlCol="0" anchor="ctr"/>
-          <a:lstStyle/>
-          <a:p>
-            <a:pPr algn="ctr"/>
-          </a:p>
-        </p:txBody>
-      </p:sp>
-      <p:sp>
-        <p:nvSpPr>
-          <p:cNvPr id="4" name="TextBox 3"/>
-          <p:cNvSpPr txBox="1"/>
-          <p:nvPr/>
-        </p:nvSpPr>
-        <p:spPr>
-          <a:xfrm>
-            <a:off x="411480" y="1298448"/>
-            <a:ext cx="5806440" cy="274320"/>
-          </a:xfrm>
-          <a:prstGeom prst="rect">
-            <a:avLst/>
-          </a:prstGeom>
-          <a:noFill/>
-        </p:spPr>
-        <p:txBody>
-          <a:bodyPr wrap="square">
-            <a:spAutoFit/>
-          </a:bodyPr>
-          <a:lstStyle/>
-          <a:p>
-            <a:pPr>
-              <a:spcAft>
-                <a:spcPts val="600"/>
-              </a:spcAft>
-            </a:pPr>
-            <a:r>
-              <a:rPr sz="1200" b="0">
-                <a:solidFill>
-                  <a:srgbClr val="282828"/>
-                </a:solidFill>
-                <a:latin typeface="Arial"/>
-              </a:rPr>
-              <a:t>•  </a:t>
-            </a:r>
-            <a:r>
-              <a:rPr sz="1200" b="1">
-                <a:solidFill>
-                  <a:srgbClr val="282828"/>
-                </a:solidFill>
-                <a:latin typeface="Arial"/>
-              </a:rPr>
-              <a:t>The drift.</a:t>
-            </a:r>
-            <a:r>
-              <a:rPr sz="1200" b="0">
-                <a:solidFill>
-                  <a:srgbClr val="282828"/>
-                </a:solidFill>
-                <a:latin typeface="Arial"/>
-              </a:rPr>
-              <a:t> 41 frames over 7 minutes: random walk plus correlated drift on every freedom of all 19 segments, played through the engine on the full train.</a:t>
-            </a:r>
-          </a:p>
-          <a:p>
-            <a:pPr>
-              <a:spcAft>
-                <a:spcPts val="600"/>
-              </a:spcAft>
-            </a:pPr>
-            <a:r>
-              <a:rPr sz="1200" b="0">
-                <a:solidFill>
-                  <a:srgbClr val="282828"/>
-                </a:solidFill>
-                <a:latin typeface="Arial"/>
-              </a:rPr>
-              <a:t>•  </a:t>
-            </a:r>
-            <a:r>
-              <a:rPr sz="1200" b="1">
-                <a:solidFill>
-                  <a:srgbClr val="282828"/>
-                </a:solidFill>
-                <a:latin typeface="Arial"/>
-              </a:rPr>
-              <a:t>The rigid-body loop.</a:t>
-            </a:r>
-            <a:r>
-              <a:rPr sz="1200" b="0">
-                <a:solidFill>
-                  <a:srgbClr val="282828"/>
-                </a:solidFill>
-                <a:latin typeface="Arial"/>
-              </a:rPr>
-              <a:t> Edge and gauge readings, a weighted least-squares estimate, an integrating controller on all six freedoms of every segment: the state residual holds at 0.36 nm while the open-loop drift grows to 2.9 nm.</a:t>
-            </a:r>
-          </a:p>
-          <a:p>
-            <a:pPr>
-              <a:spcAft>
-                <a:spcPts val="600"/>
-              </a:spcAft>
-            </a:pPr>
-            <a:r>
-              <a:rPr sz="1200" b="0">
-                <a:solidFill>
-                  <a:srgbClr val="282828"/>
-                </a:solidFill>
-                <a:latin typeface="Arial"/>
-              </a:rPr>
-              <a:t>•  </a:t>
-            </a:r>
-            <a:r>
-              <a:rPr sz="1200" b="1">
-                <a:solidFill>
-                  <a:srgbClr val="282828"/>
-                </a:solidFill>
-                <a:latin typeface="Arial"/>
-              </a:rPr>
-              <a:t>The DM loop.</a:t>
-            </a:r>
-            <a:r>
-              <a:rPr sz="1200" b="0">
-                <a:solidFill>
-                  <a:srgbClr val="282828"/>
-                </a:solidFill>
-                <a:latin typeface="Arial"/>
-              </a:rPr>
-              <a:t> The measured actuator Jacobian digs the dark zone 4.6e-07 → 1.9e-07, then a damped re-solve at each scored frame holds it: 1.91e-07 → 2.46e-07 closed, against 4.65e-07 → 1.72e-06 open.</a:t>
-            </a:r>
-          </a:p>
-          <a:p>
-            <a:pPr>
-              <a:spcAft>
-                <a:spcPts val="600"/>
-              </a:spcAft>
-            </a:pPr>
-            <a:r>
-              <a:rPr sz="1200" b="0">
-                <a:solidFill>
-                  <a:srgbClr val="282828"/>
-                </a:solidFill>
-                <a:latin typeface="Arial"/>
-              </a:rPr>
-              <a:t>•  </a:t>
-            </a:r>
-            <a:r>
-              <a:rPr sz="1200" b="1">
-                <a:solidFill>
-                  <a:srgbClr val="282828"/>
-                </a:solidFill>
-                <a:latin typeface="Arial"/>
-              </a:rPr>
-              <a:t>The honest line.</a:t>
-            </a:r>
-            <a:r>
-              <a:rPr sz="1200" b="0">
-                <a:solidFill>
-                  <a:srgbClr val="282828"/>
-                </a:solidFill>
-                <a:latin typeface="Arial"/>
-              </a:rPr>
-              <a:t> Closed-loop pupil wavefront is larger than uncorrected — that is the DM stroke the contrast is bought with, and the figure labels it as such.</a:t>
-            </a:r>
-          </a:p>
-        </p:txBody>
-      </p:sp>
-      <p:pic>
-        <p:nvPicPr>
-          <p:cNvPr id="5" name="Picture 4" descr="r4_series.png"/>
-          <p:cNvPicPr>
-            <a:picLocks noChangeAspect="1"/>
-          </p:cNvPicPr>
-          <p:nvPr/>
-        </p:nvPicPr>
-        <p:blipFill>
-          <a:blip r:embed="rId2"/>
-          <a:stretch>
-            <a:fillRect/>
-          </a:stretch>
-        </p:blipFill>
-        <p:spPr>
-          <a:xfrm>
-            <a:off x="7066277" y="1298448"/>
-            <a:ext cx="4064004" cy="3903472"/>
-          </a:xfrm>
-          <a:prstGeom prst="rect">
-            <a:avLst/>
-          </a:prstGeom>
-        </p:spPr>
-      </p:pic>
-      <p:sp>
-        <p:nvSpPr>
-          <p:cNvPr id="6" name="TextBox 5"/>
-          <p:cNvSpPr txBox="1"/>
-          <p:nvPr/>
-        </p:nvSpPr>
-        <p:spPr>
-          <a:xfrm>
-            <a:off x="6400800" y="5220208"/>
-            <a:ext cx="5394960" cy="394208"/>
-          </a:xfrm>
-          <a:prstGeom prst="rect">
-            <a:avLst/>
-          </a:prstGeom>
-          <a:noFill/>
-        </p:spPr>
-        <p:txBody>
-          <a:bodyPr wrap="square">
-            <a:spAutoFit/>
-          </a:bodyPr>
-          <a:lstStyle/>
-          <a:p>
-            <a:pPr algn="ctr">
-              <a:spcAft>
-                <a:spcPts val="0"/>
-              </a:spcAft>
-            </a:pPr>
-            <a:r>
-              <a:rPr sz="1000" b="0">
-                <a:solidFill>
-                  <a:srgbClr val="6E6E6E"/>
-                </a:solidFill>
-                <a:latin typeface="Arial"/>
-              </a:rPr>
-              <a:t>State, wavefront and contrast against time.  The contrast panel is the payoff: open loop degrades 3.7×; the closed loop holds.</a:t>
-            </a:r>
-          </a:p>
-        </p:txBody>
-      </p:sp>
-    </p:spTree>
-  </p:cSld>
-  <p:clrMapOvr>
-    <a:masterClrMapping/>
-  </p:clrMapOvr>
-</p:sld>
-</file>
-
-<file path=ppt/slides/slide16.xml><?xml version="1.0" encoding="utf-8"?>
-<p:sld xmlns:a="http://schemas.openxmlformats.org/drawingml/2006/main" xmlns:p="http://schemas.openxmlformats.org/presentationml/2006/main" xmlns:r="http://schemas.openxmlformats.org/officeDocument/2006/relationships">
-  <p:cSld>
-    <p:spTree>
-      <p:nvGrpSpPr>
-        <p:cNvPr id="1" name=""/>
-        <p:cNvGrpSpPr/>
-        <p:nvPr/>
-      </p:nvGrpSpPr>
-      <p:grpSpPr/>
-      <p:sp>
-        <p:nvSpPr>
-          <p:cNvPr id="2" name="TextBox 1"/>
-          <p:cNvSpPr txBox="1"/>
-          <p:nvPr/>
-        </p:nvSpPr>
-        <p:spPr>
-          <a:xfrm>
-            <a:off x="411480" y="201168"/>
-            <a:ext cx="11368735" cy="914400"/>
-          </a:xfrm>
-          <a:prstGeom prst="rect">
-            <a:avLst/>
-          </a:prstGeom>
-          <a:noFill/>
-        </p:spPr>
-        <p:txBody>
-          <a:bodyPr wrap="square">
-            <a:spAutoFit/>
-          </a:bodyPr>
-          <a:lstStyle/>
-          <a:p>
-            <a:pPr>
-              <a:spcAft>
-                <a:spcPts val="400"/>
-              </a:spcAft>
-            </a:pPr>
-            <a:r>
-              <a:rPr sz="2400" b="1">
-                <a:solidFill>
-                  <a:srgbClr val="1F4E79"/>
-                </a:solidFill>
-                <a:latin typeface="Arial"/>
-              </a:rPr>
-              <a:t>What this demonstrates</a:t>
-            </a:r>
-          </a:p>
-          <a:p>
-            <a:pPr>
-              <a:spcAft>
-                <a:spcPts val="0"/>
-              </a:spcAft>
-            </a:pPr>
-            <a:r>
-              <a:rPr sz="1250" b="0">
-                <a:solidFill>
-                  <a:srgbClr val="6E6E6E"/>
-                </a:solidFill>
-                <a:latin typeface="Arial"/>
-              </a:rPr>
-              <a:t>One model, from surface figure to a held dark zone</a:t>
-            </a:r>
-          </a:p>
-        </p:txBody>
-      </p:sp>
-      <p:sp>
-        <p:nvSpPr>
-          <p:cNvPr id="3" name="Rectangle 2"/>
-          <p:cNvSpPr/>
-          <p:nvPr/>
-        </p:nvSpPr>
-        <p:spPr>
-          <a:xfrm>
-            <a:off x="411480" y="1133856"/>
-            <a:ext cx="11368735" cy="20320"/>
-          </a:xfrm>
-          <a:prstGeom prst="rect">
-            <a:avLst/>
-          </a:prstGeom>
-          <a:solidFill>
-            <a:srgbClr val="B8C6D4"/>
-          </a:solidFill>
-          <a:ln>
-            <a:noFill/>
-          </a:ln>
-          <a:effectLst/>
-        </p:spPr>
-        <p:style>
-          <a:lnRef idx="1">
-            <a:schemeClr val="accent1"/>
-          </a:lnRef>
-          <a:fillRef idx="3">
-            <a:schemeClr val="accent1"/>
-          </a:fillRef>
-          <a:effectRef idx="2">
-            <a:schemeClr val="accent1"/>
-          </a:effectRef>
-          <a:fontRef idx="minor">
-            <a:schemeClr val="lt1"/>
-          </a:fontRef>
-        </p:style>
-        <p:txBody>
-          <a:bodyPr rtlCol="0" anchor="ctr"/>
-          <a:lstStyle/>
-          <a:p>
-            <a:pPr algn="ctr"/>
-          </a:p>
-        </p:txBody>
-      </p:sp>
-      <p:sp>
-        <p:nvSpPr>
-          <p:cNvPr id="4" name="TextBox 3"/>
-          <p:cNvSpPr txBox="1"/>
-          <p:nvPr/>
-        </p:nvSpPr>
-        <p:spPr>
-          <a:xfrm>
-            <a:off x="411480" y="1298448"/>
-            <a:ext cx="11368735" cy="274320"/>
-          </a:xfrm>
-          <a:prstGeom prst="rect">
-            <a:avLst/>
-          </a:prstGeom>
-          <a:noFill/>
-        </p:spPr>
-        <p:txBody>
-          <a:bodyPr wrap="square">
-            <a:spAutoFit/>
-          </a:bodyPr>
-          <a:lstStyle/>
-          <a:p>
-            <a:pPr>
-              <a:spcAft>
-                <a:spcPts val="600"/>
-              </a:spcAft>
-            </a:pPr>
-            <a:r>
-              <a:rPr sz="1200" b="0">
-                <a:solidFill>
-                  <a:srgbClr val="282828"/>
-                </a:solidFill>
-                <a:latin typeface="Arial"/>
-              </a:rPr>
-              <a:t>•  </a:t>
-            </a:r>
-            <a:r>
-              <a:rPr sz="1200" b="1">
-                <a:solidFill>
-                  <a:srgbClr val="282828"/>
-                </a:solidFill>
-                <a:latin typeface="Arial"/>
-              </a:rPr>
-              <a:t>A design becomes an instrument becomes an error budget becomes a controlled observatory</a:t>
-            </a:r>
-            <a:r>
-              <a:rPr sz="1200" b="0">
-                <a:solidFill>
-                  <a:srgbClr val="282828"/>
-                </a:solidFill>
-                <a:latin typeface="Arial"/>
-              </a:rPr>
-              <a:t>, without leaving the model or re-entering the geometry anywhere.</a:t>
-            </a:r>
-          </a:p>
-          <a:p>
-            <a:pPr>
-              <a:spcAft>
-                <a:spcPts val="600"/>
-              </a:spcAft>
-            </a:pPr>
-            <a:r>
-              <a:rPr sz="1200" b="0">
-                <a:solidFill>
-                  <a:srgbClr val="282828"/>
-                </a:solidFill>
-                <a:latin typeface="Arial"/>
-              </a:rPr>
-              <a:t>•  </a:t>
-            </a:r>
-            <a:r>
-              <a:rPr sz="1200" b="1">
-                <a:solidFill>
-                  <a:srgbClr val="282828"/>
-                </a:solidFill>
-                <a:latin typeface="Arial"/>
-              </a:rPr>
-              <a:t>The gap penalty is measured, not assumed</a:t>
-            </a:r>
-            <a:r>
-              <a:rPr sz="1200" b="0">
-                <a:solidFill>
-                  <a:srgbClr val="282828"/>
-                </a:solidFill>
-                <a:latin typeface="Arial"/>
-              </a:rPr>
-              <a:t> — 1298× open loop — and the control loop that answers it is measured too: 1.7e-06 open against 2.5e-07 closed at the end of the soak.</a:t>
-            </a:r>
-          </a:p>
-          <a:p>
-            <a:pPr>
-              <a:spcAft>
-                <a:spcPts val="600"/>
-              </a:spcAft>
-            </a:pPr>
-            <a:r>
-              <a:rPr sz="1200" b="0">
-                <a:solidFill>
-                  <a:srgbClr val="282828"/>
-                </a:solidFill>
-                <a:latin typeface="Arial"/>
-              </a:rPr>
-              <a:t>•  </a:t>
-            </a:r>
-            <a:r>
-              <a:rPr sz="1200" b="1">
-                <a:solidFill>
-                  <a:srgbClr val="282828"/>
-                </a:solidFill>
-                <a:latin typeface="Arial"/>
-              </a:rPr>
-              <a:t>Every model-vs-engine comparison closes</a:t>
-            </a:r>
-            <a:r>
-              <a:rPr sz="1200" b="0">
-                <a:solidFill>
-                  <a:srgbClr val="282828"/>
-                </a:solidFill>
-                <a:latin typeface="Arial"/>
-              </a:rPr>
-              <a:t> — worst 0.0035 across segments, DMs and relay optics — because the comparison is made at the surface the model lives on.  Where a build disagreed, the deck says why and what fixed it.</a:t>
-            </a:r>
-          </a:p>
-          <a:p>
-            <a:pPr>
-              <a:spcAft>
-                <a:spcPts val="600"/>
-              </a:spcAft>
-            </a:pPr>
-            <a:r>
-              <a:rPr sz="1200" b="0">
-                <a:solidFill>
-                  <a:srgbClr val="282828"/>
-                </a:solidFill>
-                <a:latin typeface="Arial"/>
-              </a:rPr>
-              <a:t>•  </a:t>
-            </a:r>
-            <a:r>
-              <a:rPr sz="1200" b="1">
-                <a:solidFill>
-                  <a:srgbClr val="282828"/>
-                </a:solidFill>
-                <a:latin typeface="Arial"/>
-              </a:rPr>
-              <a:t>All of it is committed</a:t>
-            </a:r>
-            <a:r>
-              <a:rPr sz="1200" b="0">
-                <a:solidFill>
-                  <a:srgbClr val="282828"/>
-                </a:solidFill>
-                <a:latin typeface="Arial"/>
-              </a:rPr>
-              <a:t>: prescriptions, runners, reports, and this deck's numbers are one git clone away.</a:t>
             </a:r>
           </a:p>
         </p:txBody>
@@ -5938,7 +5935,23 @@
                 </a:solidFill>
                 <a:latin typeface="Arial"/>
               </a:rPr>
-              <a:t>Backup Slides</a:t>
+              <a:t>The loop closes</a:t>
+            </a:r>
+          </a:p>
+          <a:p>
+            <a:pPr>
+              <a:spcAft>
+                <a:spcPts val="0"/>
+              </a:spcAft>
+            </a:pPr>
+            <a:r>
+              <a:rPr sz="1250" b="0">
+                <a:solidFill>
+                  <a:srgbClr val="6E6E6E"/>
+                </a:solidFill>
+                <a:latin typeface="Arial"/>
+              </a:rPr>
+              <a:t>The dark zone held under drift: 2.5e-07 against 1.7e-06 open-loop</a:t>
             </a:r>
           </a:p>
         </p:txBody>
@@ -5951,7 +5964,7 @@
         </p:nvSpPr>
         <p:spPr>
           <a:xfrm>
-            <a:off x="411480" y="914400"/>
+            <a:off x="411480" y="1133856"/>
             <a:ext cx="11368735" cy="20320"/>
           </a:xfrm>
           <a:prstGeom prst="rect">
@@ -5984,6 +5997,262 @@
           <a:lstStyle/>
           <a:p>
             <a:pPr algn="ctr"/>
+          </a:p>
+        </p:txBody>
+      </p:sp>
+      <p:sp>
+        <p:nvSpPr>
+          <p:cNvPr id="4" name="TextBox 3"/>
+          <p:cNvSpPr txBox="1"/>
+          <p:nvPr/>
+        </p:nvSpPr>
+        <p:spPr>
+          <a:xfrm>
+            <a:off x="411480" y="1298448"/>
+            <a:ext cx="5806440" cy="274320"/>
+          </a:xfrm>
+          <a:prstGeom prst="rect">
+            <a:avLst/>
+          </a:prstGeom>
+          <a:noFill/>
+        </p:spPr>
+        <p:txBody>
+          <a:bodyPr wrap="square">
+            <a:spAutoFit/>
+          </a:bodyPr>
+          <a:lstStyle/>
+          <a:p>
+            <a:pPr>
+              <a:spcAft>
+                <a:spcPts val="600"/>
+              </a:spcAft>
+            </a:pPr>
+            <a:r>
+              <a:rPr sz="1200" b="0">
+                <a:solidFill>
+                  <a:srgbClr val="282828"/>
+                </a:solidFill>
+                <a:latin typeface="Arial"/>
+              </a:rPr>
+              <a:t>•  </a:t>
+            </a:r>
+            <a:r>
+              <a:rPr sz="1200" b="1">
+                <a:solidFill>
+                  <a:srgbClr val="282828"/>
+                </a:solidFill>
+                <a:latin typeface="Arial"/>
+              </a:rPr>
+              <a:t>The drift.</a:t>
+            </a:r>
+            <a:r>
+              <a:rPr sz="1200" b="0">
+                <a:solidFill>
+                  <a:srgbClr val="282828"/>
+                </a:solidFill>
+                <a:latin typeface="Arial"/>
+              </a:rPr>
+              <a:t> 41 frames over 7 minutes: random walk plus correlated drift on every freedom of all 19 segments, played through the engine on the full train.</a:t>
+            </a:r>
+          </a:p>
+          <a:p>
+            <a:pPr>
+              <a:spcAft>
+                <a:spcPts val="600"/>
+              </a:spcAft>
+            </a:pPr>
+            <a:r>
+              <a:rPr sz="1200" b="0">
+                <a:solidFill>
+                  <a:srgbClr val="282828"/>
+                </a:solidFill>
+                <a:latin typeface="Arial"/>
+              </a:rPr>
+              <a:t>•  </a:t>
+            </a:r>
+            <a:r>
+              <a:rPr sz="1200" b="1">
+                <a:solidFill>
+                  <a:srgbClr val="282828"/>
+                </a:solidFill>
+                <a:latin typeface="Arial"/>
+              </a:rPr>
+              <a:t>The rigid-body loop.</a:t>
+            </a:r>
+            <a:r>
+              <a:rPr sz="1200" b="0">
+                <a:solidFill>
+                  <a:srgbClr val="282828"/>
+                </a:solidFill>
+                <a:latin typeface="Arial"/>
+              </a:rPr>
+              <a:t> Edge and gauge readings, a weighted least-squares estimate, an integrating controller on all six freedoms of every segment: the state residual holds at 0.36 nm while the open-loop drift grows to 2.9 nm.</a:t>
+            </a:r>
+          </a:p>
+          <a:p>
+            <a:pPr>
+              <a:spcAft>
+                <a:spcPts val="600"/>
+              </a:spcAft>
+            </a:pPr>
+            <a:r>
+              <a:rPr sz="1200" b="0">
+                <a:solidFill>
+                  <a:srgbClr val="282828"/>
+                </a:solidFill>
+                <a:latin typeface="Arial"/>
+              </a:rPr>
+              <a:t>•  </a:t>
+            </a:r>
+            <a:r>
+              <a:rPr sz="1200" b="1">
+                <a:solidFill>
+                  <a:srgbClr val="282828"/>
+                </a:solidFill>
+                <a:latin typeface="Arial"/>
+              </a:rPr>
+              <a:t>The DM loop.</a:t>
+            </a:r>
+            <a:r>
+              <a:rPr sz="1200" b="0">
+                <a:solidFill>
+                  <a:srgbClr val="282828"/>
+                </a:solidFill>
+                <a:latin typeface="Arial"/>
+              </a:rPr>
+              <a:t> The measured actuator Jacobian digs the dark zone 4.6e-07 → 1.9e-07, then a damped re-solve at each scored frame holds it: 1.91e-07 → 2.46e-07 closed, against 4.65e-07 → 1.72e-06 open.</a:t>
+            </a:r>
+          </a:p>
+          <a:p>
+            <a:pPr>
+              <a:spcAft>
+                <a:spcPts val="600"/>
+              </a:spcAft>
+            </a:pPr>
+            <a:r>
+              <a:rPr sz="1200" b="0">
+                <a:solidFill>
+                  <a:srgbClr val="282828"/>
+                </a:solidFill>
+                <a:latin typeface="Arial"/>
+              </a:rPr>
+              <a:t>•  </a:t>
+            </a:r>
+            <a:r>
+              <a:rPr sz="1200" b="1">
+                <a:solidFill>
+                  <a:srgbClr val="282828"/>
+                </a:solidFill>
+                <a:latin typeface="Arial"/>
+              </a:rPr>
+              <a:t>The honest line.</a:t>
+            </a:r>
+            <a:r>
+              <a:rPr sz="1200" b="0">
+                <a:solidFill>
+                  <a:srgbClr val="282828"/>
+                </a:solidFill>
+                <a:latin typeface="Arial"/>
+              </a:rPr>
+              <a:t> Closed-loop pupil wavefront is larger than uncorrected — that is the DM stroke the contrast is bought with, and the figure labels it as such.</a:t>
+            </a:r>
+          </a:p>
+          <a:p>
+            <a:pPr>
+              <a:spcAft>
+                <a:spcPts val="600"/>
+              </a:spcAft>
+            </a:pPr>
+            <a:r>
+              <a:rPr sz="1200" b="0">
+                <a:solidFill>
+                  <a:srgbClr val="282828"/>
+                </a:solidFill>
+                <a:latin typeface="Arial"/>
+              </a:rPr>
+              <a:t>•  </a:t>
+            </a:r>
+            <a:r>
+              <a:rPr sz="1200" b="1">
+                <a:solidFill>
+                  <a:srgbClr val="282828"/>
+                </a:solidFill>
+                <a:latin typeface="Arial"/>
+              </a:rPr>
+              <a:t>Toned down 10x (0.3 nm-class drift): the hold is the mechanization's.</a:t>
+            </a:r>
+            <a:r>
+              <a:rPr sz="1200" b="0">
+                <a:solidFill>
+                  <a:srgbClr val="282828"/>
+                </a:solidFill>
+                <a:latin typeface="Arial"/>
+              </a:rPr>
+              <a:t>  The open loop no longer degrades (4.65e-07 -&gt; 4.63e-07) while the closed loop holds 2.46e-07 — identical to the 3 nm hold: the ~2.5e-07 level is the loop's own noise-injection floor, and control cadence/gain becomes the knob at low drift (flagged, not retuned; the estimator still tracks at 7.2e-11 against 3.0e-10 of drift).</a:t>
+            </a:r>
+          </a:p>
+        </p:txBody>
+      </p:sp>
+      <p:pic>
+        <p:nvPicPr>
+          <p:cNvPr id="5" name="Picture 4" descr="r4_series.png"/>
+          <p:cNvPicPr>
+            <a:picLocks noChangeAspect="1"/>
+          </p:cNvPicPr>
+          <p:nvPr/>
+        </p:nvPicPr>
+        <p:blipFill>
+          <a:blip r:embed="rId2"/>
+          <a:stretch>
+            <a:fillRect/>
+          </a:stretch>
+        </p:blipFill>
+        <p:spPr>
+          <a:xfrm>
+            <a:off x="7066277" y="1298448"/>
+            <a:ext cx="4064004" cy="3903472"/>
+          </a:xfrm>
+          <a:prstGeom prst="rect">
+            <a:avLst/>
+          </a:prstGeom>
+        </p:spPr>
+      </p:pic>
+      <p:sp>
+        <p:nvSpPr>
+          <p:cNvPr id="6" name="TextBox 5"/>
+          <p:cNvSpPr txBox="1"/>
+          <p:nvPr/>
+        </p:nvSpPr>
+        <p:spPr>
+          <a:xfrm>
+            <a:off x="6400800" y="5220208"/>
+            <a:ext cx="5394960" cy="394208"/>
+          </a:xfrm>
+          <a:prstGeom prst="rect">
+            <a:avLst/>
+          </a:prstGeom>
+          <a:noFill/>
+        </p:spPr>
+        <p:txBody>
+          <a:bodyPr wrap="square">
+            <a:spAutoFit/>
+          </a:bodyPr>
+          <a:lstStyle/>
+          <a:p>
+            <a:pPr algn="ctr">
+              <a:spcAft>
+                <a:spcPts val="0"/>
+              </a:spcAft>
+            </a:pPr>
+            <a:r>
+              <a:rPr sz="1000" b="0">
+                <a:solidFill>
+                  <a:srgbClr val="6E6E6E"/>
+                </a:solidFill>
+                <a:latin typeface="Arial"/>
+              </a:rPr>
+              <a:t>State, wavefront and contrast against time.  The contrast panel is the payoff: open loop degrades 3.7×; the closed loop holds.</a:t>
+            </a:r>
           </a:p>
         </p:txBody>
       </p:sp>
@@ -6039,7 +6308,7 @@
                 </a:solidFill>
                 <a:latin typeface="Arial"/>
               </a:rPr>
-              <a:t>The stop's edge, measured</a:t>
+              <a:t>What this demonstrates</a:t>
             </a:r>
           </a:p>
           <a:p>
@@ -6055,7 +6324,7 @@
                 </a:solidFill>
                 <a:latin typeface="Arial"/>
               </a:rPr>
-              <a:t>A Babinet split with 1e-15 closure: the edge interferes, it does not merely add</a:t>
+              <a:t>One model, from surface figure to a held dark zone</a:t>
             </a:r>
           </a:p>
         </p:txBody>
@@ -6113,7 +6382,7 @@
         <p:spPr>
           <a:xfrm>
             <a:off x="411480" y="1298448"/>
-            <a:ext cx="5806440" cy="274320"/>
+            <a:ext cx="11368735" cy="274320"/>
           </a:xfrm>
           <a:prstGeom prst="rect">
             <a:avLst/>
@@ -6147,16 +6416,16 @@
                 </a:solidFill>
                 <a:latin typeface="Arial"/>
               </a:rPr>
-              <a:t>Method.</a:t>
-            </a:r>
-            <a:r>
-              <a:rPr sz="1200" b="0">
-                <a:solidFill>
-                  <a:srgbClr val="282828"/>
-                </a:solidFill>
-                <a:latin typeface="Arial"/>
-              </a:rPr>
-              <a:t>  The circular stop applied as a SCREEN on the no-stop chain holds every mask and scale fixed, so E_rim = E_hex - E_screened is exactly the blocked rim's field.  Pins: screened bare peak == stopped bare peak to 0.0e0; both S1 records reproduced under 1%.</a:t>
+              <a:t>A design becomes an instrument becomes an error budget becomes a controlled observatory</a:t>
+            </a:r>
+            <a:r>
+              <a:rPr sz="1200" b="0">
+                <a:solidFill>
+                  <a:srgbClr val="282828"/>
+                </a:solidFill>
+                <a:latin typeface="Arial"/>
+              </a:rPr>
+              <a:t>, without leaving the model or re-entering the geometry anywhere.</a:t>
             </a:r>
           </a:p>
           <a:p>
@@ -6181,16 +6450,16 @@
                 </a:solidFill>
                 <a:latin typeface="Arial"/>
               </a:rPr>
-              <a:t>The split (dark-zone mean energy):</a:t>
-            </a:r>
-            <a:r>
-              <a:rPr sz="1200" b="0">
-                <a:solidFill>
-                  <a:srgbClr val="282828"/>
-                </a:solidFill>
-                <a:latin typeface="Arial"/>
-              </a:rPr>
-              <a:t> I_ns 1.09e-05 + rim 2.53e-06 + cross 6.54e-06 — the rim's own ring is ~28% of the increase; the cross term (coherent interference with the pre-existing gap speckle) is 2.6x larger.  Peak renormalization 1.178x; dark-zone energy up 1.83x at fixed masks; the lambda/D re-reference contributes 1.00x.</a:t>
+              <a:t>The gap penalty is measured, not assumed</a:t>
+            </a:r>
+            <a:r>
+              <a:rPr sz="1200" b="0">
+                <a:solidFill>
+                  <a:srgbClr val="282828"/>
+                </a:solidFill>
+                <a:latin typeface="Arial"/>
+              </a:rPr>
+              <a:t> — 1298× open loop — and the control loop that answers it is measured too: 1.7e-06 open against 2.5e-07 closed at the end of the soak.</a:t>
             </a:r>
           </a:p>
           <a:p>
@@ -6215,79 +6484,50 @@
                 </a:solidFill>
                 <a:latin typeface="Arial"/>
               </a:rPr>
-              <a:t>The APLC flag, restated:</a:t>
-            </a:r>
-            <a:r>
-              <a:rPr sz="1200" b="0">
-                <a:solidFill>
-                  <a:srgbClr val="282828"/>
-                </a:solidFill>
-                <a:latin typeface="Arial"/>
-              </a:rPr>
-              <a:t> the stopped aperture-matched prolate hit its iteration cap unconverged (the answer moves with the cap — not an eigenfunction, not a design); its row stands flagged, and the block/Lanczos eigensolver or the N'Diaye LP co-design are the named, deferred machines.</a:t>
-            </a:r>
-          </a:p>
-        </p:txBody>
-      </p:sp>
-      <p:pic>
-        <p:nvPicPr>
-          <p:cNvPr id="5" name="Picture 4" descr="cf1c_stop_attrib.png"/>
-          <p:cNvPicPr>
-            <a:picLocks noChangeAspect="1"/>
-          </p:cNvPicPr>
-          <p:nvPr/>
-        </p:nvPicPr>
-        <p:blipFill>
-          <a:blip r:embed="rId2"/>
-          <a:stretch>
-            <a:fillRect/>
-          </a:stretch>
-        </p:blipFill>
-        <p:spPr>
-          <a:xfrm>
-            <a:off x="6758517" y="1298448"/>
-            <a:ext cx="4679524" cy="3611371"/>
-          </a:xfrm>
-          <a:prstGeom prst="rect">
-            <a:avLst/>
-          </a:prstGeom>
-        </p:spPr>
-      </p:pic>
-      <p:sp>
-        <p:nvSpPr>
-          <p:cNvPr id="6" name="TextBox 5"/>
-          <p:cNvSpPr txBox="1"/>
-          <p:nvPr/>
-        </p:nvSpPr>
-        <p:spPr>
-          <a:xfrm>
-            <a:off x="6400800" y="4928107"/>
-            <a:ext cx="5394960" cy="229107"/>
-          </a:xfrm>
-          <a:prstGeom prst="rect">
-            <a:avLst/>
-          </a:prstGeom>
-          <a:noFill/>
-        </p:spPr>
-        <p:txBody>
-          <a:bodyPr wrap="square">
-            <a:spAutoFit/>
-          </a:bodyPr>
-          <a:lstStyle/>
-          <a:p>
-            <a:pPr algn="ctr">
-              <a:spcAft>
-                <a:spcPts val="0"/>
-              </a:spcAft>
-            </a:pPr>
-            <a:r>
-              <a:rPr sz="1000" b="0">
-                <a:solidFill>
-                  <a:srgbClr val="6E6E6E"/>
-                </a:solidFill>
-                <a:latin typeface="Arial"/>
-              </a:rPr>
-              <a:t>Where the stop's edge lands: no-stop, stop-as-screen, and the rim field alone.</a:t>
+              <a:t>Every model-vs-engine comparison closes</a:t>
+            </a:r>
+            <a:r>
+              <a:rPr sz="1200" b="0">
+                <a:solidFill>
+                  <a:srgbClr val="282828"/>
+                </a:solidFill>
+                <a:latin typeface="Arial"/>
+              </a:rPr>
+              <a:t> — worst 0.0035 across segments, DMs and relay optics — because the comparison is made at the surface the model lives on.  Where a build disagreed, the deck says why and what fixed it.</a:t>
+            </a:r>
+          </a:p>
+          <a:p>
+            <a:pPr>
+              <a:spcAft>
+                <a:spcPts val="600"/>
+              </a:spcAft>
+            </a:pPr>
+            <a:r>
+              <a:rPr sz="1200" b="0">
+                <a:solidFill>
+                  <a:srgbClr val="282828"/>
+                </a:solidFill>
+                <a:latin typeface="Arial"/>
+              </a:rPr>
+              <a:t>•  </a:t>
+            </a:r>
+            <a:r>
+              <a:rPr sz="1200" b="1">
+                <a:solidFill>
+                  <a:srgbClr val="282828"/>
+                </a:solidFill>
+                <a:latin typeface="Arial"/>
+              </a:rPr>
+              <a:t>All of it is committed</a:t>
+            </a:r>
+            <a:r>
+              <a:rPr sz="1200" b="0">
+                <a:solidFill>
+                  <a:srgbClr val="282828"/>
+                </a:solidFill>
+                <a:latin typeface="Arial"/>
+              </a:rPr>
+              <a:t>: prescriptions, runners, reports, and this deck's numbers are one git clone away.</a:t>
             </a:r>
           </a:p>
         </p:txBody>
@@ -6301,6 +6541,814 @@
 </file>
 
 <file path=ppt/slides/slide19.xml><?xml version="1.0" encoding="utf-8"?>
+<p:sld xmlns:a="http://schemas.openxmlformats.org/drawingml/2006/main" xmlns:p="http://schemas.openxmlformats.org/presentationml/2006/main" xmlns:r="http://schemas.openxmlformats.org/officeDocument/2006/relationships">
+  <p:cSld>
+    <p:spTree>
+      <p:nvGrpSpPr>
+        <p:cNvPr id="1" name=""/>
+        <p:cNvGrpSpPr/>
+        <p:nvPr/>
+      </p:nvGrpSpPr>
+      <p:grpSpPr/>
+      <p:sp>
+        <p:nvSpPr>
+          <p:cNvPr id="2" name="TextBox 1"/>
+          <p:cNvSpPr txBox="1"/>
+          <p:nvPr/>
+        </p:nvSpPr>
+        <p:spPr>
+          <a:xfrm>
+            <a:off x="411480" y="201168"/>
+            <a:ext cx="11368735" cy="914400"/>
+          </a:xfrm>
+          <a:prstGeom prst="rect">
+            <a:avLst/>
+          </a:prstGeom>
+          <a:noFill/>
+        </p:spPr>
+        <p:txBody>
+          <a:bodyPr wrap="square">
+            <a:spAutoFit/>
+          </a:bodyPr>
+          <a:lstStyle/>
+          <a:p>
+            <a:pPr>
+              <a:spcAft>
+                <a:spcPts val="400"/>
+              </a:spcAft>
+            </a:pPr>
+            <a:r>
+              <a:rPr sz="2400" b="1">
+                <a:solidFill>
+                  <a:srgbClr val="1F4E79"/>
+                </a:solidFill>
+                <a:latin typeface="Arial"/>
+              </a:rPr>
+              <a:t>Backup Slides</a:t>
+            </a:r>
+          </a:p>
+        </p:txBody>
+      </p:sp>
+      <p:sp>
+        <p:nvSpPr>
+          <p:cNvPr id="3" name="Rectangle 2"/>
+          <p:cNvSpPr/>
+          <p:nvPr/>
+        </p:nvSpPr>
+        <p:spPr>
+          <a:xfrm>
+            <a:off x="411480" y="914400"/>
+            <a:ext cx="11368735" cy="20320"/>
+          </a:xfrm>
+          <a:prstGeom prst="rect">
+            <a:avLst/>
+          </a:prstGeom>
+          <a:solidFill>
+            <a:srgbClr val="B8C6D4"/>
+          </a:solidFill>
+          <a:ln>
+            <a:noFill/>
+          </a:ln>
+          <a:effectLst/>
+        </p:spPr>
+        <p:style>
+          <a:lnRef idx="1">
+            <a:schemeClr val="accent1"/>
+          </a:lnRef>
+          <a:fillRef idx="3">
+            <a:schemeClr val="accent1"/>
+          </a:fillRef>
+          <a:effectRef idx="2">
+            <a:schemeClr val="accent1"/>
+          </a:effectRef>
+          <a:fontRef idx="minor">
+            <a:schemeClr val="lt1"/>
+          </a:fontRef>
+        </p:style>
+        <p:txBody>
+          <a:bodyPr rtlCol="0" anchor="ctr"/>
+          <a:lstStyle/>
+          <a:p>
+            <a:pPr algn="ctr"/>
+          </a:p>
+        </p:txBody>
+      </p:sp>
+    </p:spTree>
+  </p:cSld>
+  <p:clrMapOvr>
+    <a:masterClrMapping/>
+  </p:clrMapOvr>
+</p:sld>
+</file>
+
+<file path=ppt/slides/slide2.xml><?xml version="1.0" encoding="utf-8"?>
+<p:sld xmlns:a="http://schemas.openxmlformats.org/drawingml/2006/main" xmlns:p="http://schemas.openxmlformats.org/presentationml/2006/main" xmlns:r="http://schemas.openxmlformats.org/officeDocument/2006/relationships">
+  <p:cSld>
+    <p:spTree>
+      <p:nvGrpSpPr>
+        <p:cNvPr id="1" name=""/>
+        <p:cNvGrpSpPr/>
+        <p:nvPr/>
+      </p:nvGrpSpPr>
+      <p:grpSpPr/>
+      <p:sp>
+        <p:nvSpPr>
+          <p:cNvPr id="2" name="TextBox 1"/>
+          <p:cNvSpPr txBox="1"/>
+          <p:nvPr/>
+        </p:nvSpPr>
+        <p:spPr>
+          <a:xfrm>
+            <a:off x="411480" y="201168"/>
+            <a:ext cx="11368735" cy="914400"/>
+          </a:xfrm>
+          <a:prstGeom prst="rect">
+            <a:avLst/>
+          </a:prstGeom>
+          <a:noFill/>
+        </p:spPr>
+        <p:txBody>
+          <a:bodyPr wrap="square">
+            <a:spAutoFit/>
+          </a:bodyPr>
+          <a:lstStyle/>
+          <a:p>
+            <a:pPr>
+              <a:spcAft>
+                <a:spcPts val="400"/>
+              </a:spcAft>
+            </a:pPr>
+            <a:r>
+              <a:rPr sz="2400" b="1">
+                <a:solidFill>
+                  <a:srgbClr val="1F4E79"/>
+                </a:solidFill>
+                <a:latin typeface="Arial"/>
+              </a:rPr>
+              <a:t>The telescope</a:t>
+            </a:r>
+          </a:p>
+          <a:p>
+            <a:pPr>
+              <a:spcAft>
+                <a:spcPts val="0"/>
+              </a:spcAft>
+            </a:pPr>
+            <a:r>
+              <a:rPr sz="1250" b="0">
+                <a:solidFill>
+                  <a:srgbClr val="6E6E6E"/>
+                </a:solidFill>
+                <a:latin typeface="Arial"/>
+              </a:rPr>
+              <a:t>0.0473 waves RMS across the field — diffraction-limited at 500 nm</a:t>
+            </a:r>
+          </a:p>
+        </p:txBody>
+      </p:sp>
+      <p:sp>
+        <p:nvSpPr>
+          <p:cNvPr id="3" name="Rectangle 2"/>
+          <p:cNvSpPr/>
+          <p:nvPr/>
+        </p:nvSpPr>
+        <p:spPr>
+          <a:xfrm>
+            <a:off x="411480" y="1133856"/>
+            <a:ext cx="11368735" cy="20320"/>
+          </a:xfrm>
+          <a:prstGeom prst="rect">
+            <a:avLst/>
+          </a:prstGeom>
+          <a:solidFill>
+            <a:srgbClr val="B8C6D4"/>
+          </a:solidFill>
+          <a:ln>
+            <a:noFill/>
+          </a:ln>
+          <a:effectLst/>
+        </p:spPr>
+        <p:style>
+          <a:lnRef idx="1">
+            <a:schemeClr val="accent1"/>
+          </a:lnRef>
+          <a:fillRef idx="3">
+            <a:schemeClr val="accent1"/>
+          </a:fillRef>
+          <a:effectRef idx="2">
+            <a:schemeClr val="accent1"/>
+          </a:effectRef>
+          <a:fontRef idx="minor">
+            <a:schemeClr val="lt1"/>
+          </a:fontRef>
+        </p:style>
+        <p:txBody>
+          <a:bodyPr rtlCol="0" anchor="ctr"/>
+          <a:lstStyle/>
+          <a:p>
+            <a:pPr algn="ctr"/>
+          </a:p>
+        </p:txBody>
+      </p:sp>
+      <p:sp>
+        <p:nvSpPr>
+          <p:cNvPr id="4" name="TextBox 3"/>
+          <p:cNvSpPr txBox="1"/>
+          <p:nvPr/>
+        </p:nvSpPr>
+        <p:spPr>
+          <a:xfrm>
+            <a:off x="411480" y="1298448"/>
+            <a:ext cx="5806440" cy="274320"/>
+          </a:xfrm>
+          <a:prstGeom prst="rect">
+            <a:avLst/>
+          </a:prstGeom>
+          <a:noFill/>
+        </p:spPr>
+        <p:txBody>
+          <a:bodyPr wrap="square">
+            <a:spAutoFit/>
+          </a:bodyPr>
+          <a:lstStyle/>
+          <a:p>
+            <a:pPr>
+              <a:spcAft>
+                <a:spcPts val="600"/>
+              </a:spcAft>
+            </a:pPr>
+            <a:r>
+              <a:rPr sz="1200" b="0">
+                <a:solidFill>
+                  <a:srgbClr val="282828"/>
+                </a:solidFill>
+                <a:latin typeface="Arial"/>
+              </a:rPr>
+              <a:t>•  </a:t>
+            </a:r>
+            <a:r>
+              <a:rPr sz="1200" b="1">
+                <a:solidFill>
+                  <a:srgbClr val="282828"/>
+                </a:solidFill>
+                <a:latin typeface="Arial"/>
+              </a:rPr>
+              <a:t>The design.</a:t>
+            </a:r>
+            <a:r>
+              <a:rPr sz="1200" b="0">
+                <a:solidFill>
+                  <a:srgbClr val="282828"/>
+                </a:solidFill>
+                <a:latin typeface="Arial"/>
+              </a:rPr>
+              <a:t> A 6 m unobscured three-mirror telescope: three base spheres placed for packaging, fold tilts doing the unobscuration, all correction carried by Zernike surface departures.  Field ±0.35 arcmin.</a:t>
+            </a:r>
+          </a:p>
+          <a:p>
+            <a:pPr>
+              <a:spcAft>
+                <a:spcPts val="600"/>
+              </a:spcAft>
+            </a:pPr>
+            <a:r>
+              <a:rPr sz="1200" b="0">
+                <a:solidFill>
+                  <a:srgbClr val="282828"/>
+                </a:solidFill>
+                <a:latin typeface="Arial"/>
+              </a:rPr>
+              <a:t>•  </a:t>
+            </a:r>
+            <a:r>
+              <a:rPr sz="1200" b="1">
+                <a:solidFill>
+                  <a:srgbClr val="282828"/>
+                </a:solidFill>
+                <a:latin typeface="Arial"/>
+              </a:rPr>
+              <a:t>The wavefront.</a:t>
+            </a:r>
+            <a:r>
+              <a:rPr sz="1200" b="0">
+                <a:solidFill>
+                  <a:srgbClr val="282828"/>
+                </a:solidFill>
+                <a:latin typeface="Arial"/>
+              </a:rPr>
+              <a:t> 0.0473 waves RMS worst case over the field, against a 0.071-wave diffraction limit.</a:t>
+            </a:r>
+          </a:p>
+          <a:p>
+            <a:pPr>
+              <a:spcAft>
+                <a:spcPts val="600"/>
+              </a:spcAft>
+            </a:pPr>
+            <a:r>
+              <a:rPr sz="1200" b="0">
+                <a:solidFill>
+                  <a:srgbClr val="282828"/>
+                </a:solidFill>
+                <a:latin typeface="Arial"/>
+              </a:rPr>
+              <a:t>•  </a:t>
+            </a:r>
+            <a:r>
+              <a:rPr sz="1200" b="1">
+                <a:solidFill>
+                  <a:srgbClr val="282828"/>
+                </a:solidFill>
+                <a:latin typeface="Arial"/>
+              </a:rPr>
+              <a:t>The packaging.</a:t>
+            </a:r>
+            <a:r>
+              <a:rPr sz="1200" b="0">
+                <a:solidFill>
+                  <a:srgbClr val="282828"/>
+                </a:solidFill>
+                <a:latin typeface="Arial"/>
+              </a:rPr>
+              <a:t> 7.450 m diameter against the 8 m shroud; 1185/1185 rays survive a standalone reload of the saved prescription.</a:t>
+            </a:r>
+          </a:p>
+          <a:p>
+            <a:pPr>
+              <a:spcAft>
+                <a:spcPts val="600"/>
+              </a:spcAft>
+            </a:pPr>
+            <a:r>
+              <a:rPr sz="1200" b="0">
+                <a:solidFill>
+                  <a:srgbClr val="282828"/>
+                </a:solidFill>
+                <a:latin typeface="Arial"/>
+              </a:rPr>
+              <a:t>•  </a:t>
+            </a:r>
+            <a:r>
+              <a:rPr sz="1200" b="1">
+                <a:solidFill>
+                  <a:srgbClr val="282828"/>
+                </a:solidFill>
+                <a:latin typeface="Arial"/>
+              </a:rPr>
+              <a:t>The one miss.</a:t>
+            </a:r>
+            <a:r>
+              <a:rPr sz="1200" b="0">
+                <a:solidFill>
+                  <a:srgbClr val="282828"/>
+                </a:solidFill>
+                <a:latin typeface="Arial"/>
+              </a:rPr>
+              <a:t> Focal ratio f/25.39 against a requested f/12–20; not a tuning failure — see the backup.</a:t>
+            </a:r>
+          </a:p>
+        </p:txBody>
+      </p:sp>
+      <p:pic>
+        <p:nvPicPr>
+          <p:cNvPr id="5" name="Picture 4" descr="s1_layout.png"/>
+          <p:cNvPicPr>
+            <a:picLocks noChangeAspect="1"/>
+          </p:cNvPicPr>
+          <p:nvPr/>
+        </p:nvPicPr>
+        <p:blipFill>
+          <a:blip r:embed="rId2"/>
+          <a:stretch>
+            <a:fillRect/>
+          </a:stretch>
+        </p:blipFill>
+        <p:spPr>
+          <a:xfrm>
+            <a:off x="6980220" y="1298448"/>
+            <a:ext cx="4236119" cy="2348992"/>
+          </a:xfrm>
+          <a:prstGeom prst="rect">
+            <a:avLst/>
+          </a:prstGeom>
+        </p:spPr>
+      </p:pic>
+      <p:sp>
+        <p:nvSpPr>
+          <p:cNvPr id="6" name="TextBox 5"/>
+          <p:cNvSpPr txBox="1"/>
+          <p:nvPr/>
+        </p:nvSpPr>
+        <p:spPr>
+          <a:xfrm>
+            <a:off x="6400800" y="3665727"/>
+            <a:ext cx="5394960" cy="394208"/>
+          </a:xfrm>
+          <a:prstGeom prst="rect">
+            <a:avLst/>
+          </a:prstGeom>
+          <a:noFill/>
+        </p:spPr>
+        <p:txBody>
+          <a:bodyPr wrap="square">
+            <a:spAutoFit/>
+          </a:bodyPr>
+          <a:lstStyle/>
+          <a:p>
+            <a:pPr algn="ctr">
+              <a:spcAft>
+                <a:spcPts val="0"/>
+              </a:spcAft>
+            </a:pPr>
+            <a:r>
+              <a:rPr sz="1000" b="0">
+                <a:solidFill>
+                  <a:srgbClr val="6E6E6E"/>
+                </a:solidFill>
+                <a:latin typeface="Arial"/>
+              </a:rPr>
+              <a:t>The three-mirror train: light enters from the left, folds back to the secondary, returns past the primary to the tertiary and the focus.</a:t>
+            </a:r>
+          </a:p>
+        </p:txBody>
+      </p:sp>
+      <p:pic>
+        <p:nvPicPr>
+          <p:cNvPr id="7" name="Picture 6" descr="s1_wfe_field.png"/>
+          <p:cNvPicPr>
+            <a:picLocks noChangeAspect="1"/>
+          </p:cNvPicPr>
+          <p:nvPr/>
+        </p:nvPicPr>
+        <p:blipFill>
+          <a:blip r:embed="rId3"/>
+          <a:stretch>
+            <a:fillRect/>
+          </a:stretch>
+        </p:blipFill>
+        <p:spPr>
+          <a:xfrm>
+            <a:off x="7705463" y="4096512"/>
+            <a:ext cx="2785632" cy="2367788"/>
+          </a:xfrm>
+          <a:prstGeom prst="rect">
+            <a:avLst/>
+          </a:prstGeom>
+        </p:spPr>
+      </p:pic>
+      <p:sp>
+        <p:nvSpPr>
+          <p:cNvPr id="8" name="TextBox 7"/>
+          <p:cNvSpPr txBox="1"/>
+          <p:nvPr/>
+        </p:nvSpPr>
+        <p:spPr>
+          <a:xfrm>
+            <a:off x="6400800" y="6482588"/>
+            <a:ext cx="5394960" cy="229107"/>
+          </a:xfrm>
+          <a:prstGeom prst="rect">
+            <a:avLst/>
+          </a:prstGeom>
+          <a:noFill/>
+        </p:spPr>
+        <p:txBody>
+          <a:bodyPr wrap="square">
+            <a:spAutoFit/>
+          </a:bodyPr>
+          <a:lstStyle/>
+          <a:p>
+            <a:pPr algn="ctr">
+              <a:spcAft>
+                <a:spcPts val="0"/>
+              </a:spcAft>
+            </a:pPr>
+            <a:r>
+              <a:rPr sz="1000" b="0">
+                <a:solidFill>
+                  <a:srgbClr val="6E6E6E"/>
+                </a:solidFill>
+                <a:latin typeface="Arial"/>
+              </a:rPr>
+              <a:t>Wavefront error over the design field.  Worst corner 0.0473 waves.</a:t>
+            </a:r>
+          </a:p>
+        </p:txBody>
+      </p:sp>
+    </p:spTree>
+  </p:cSld>
+  <p:clrMapOvr>
+    <a:masterClrMapping/>
+  </p:clrMapOvr>
+</p:sld>
+</file>
+
+<file path=ppt/slides/slide20.xml><?xml version="1.0" encoding="utf-8"?>
+<p:sld xmlns:a="http://schemas.openxmlformats.org/drawingml/2006/main" xmlns:p="http://schemas.openxmlformats.org/presentationml/2006/main" xmlns:r="http://schemas.openxmlformats.org/officeDocument/2006/relationships">
+  <p:cSld>
+    <p:spTree>
+      <p:nvGrpSpPr>
+        <p:cNvPr id="1" name=""/>
+        <p:cNvGrpSpPr/>
+        <p:nvPr/>
+      </p:nvGrpSpPr>
+      <p:grpSpPr/>
+      <p:sp>
+        <p:nvSpPr>
+          <p:cNvPr id="2" name="TextBox 1"/>
+          <p:cNvSpPr txBox="1"/>
+          <p:nvPr/>
+        </p:nvSpPr>
+        <p:spPr>
+          <a:xfrm>
+            <a:off x="411480" y="201168"/>
+            <a:ext cx="11368735" cy="914400"/>
+          </a:xfrm>
+          <a:prstGeom prst="rect">
+            <a:avLst/>
+          </a:prstGeom>
+          <a:noFill/>
+        </p:spPr>
+        <p:txBody>
+          <a:bodyPr wrap="square">
+            <a:spAutoFit/>
+          </a:bodyPr>
+          <a:lstStyle/>
+          <a:p>
+            <a:pPr>
+              <a:spcAft>
+                <a:spcPts val="400"/>
+              </a:spcAft>
+            </a:pPr>
+            <a:r>
+              <a:rPr sz="2400" b="1">
+                <a:solidFill>
+                  <a:srgbClr val="1F4E79"/>
+                </a:solidFill>
+                <a:latin typeface="Arial"/>
+              </a:rPr>
+              <a:t>The stop's edge, measured</a:t>
+            </a:r>
+          </a:p>
+          <a:p>
+            <a:pPr>
+              <a:spcAft>
+                <a:spcPts val="0"/>
+              </a:spcAft>
+            </a:pPr>
+            <a:r>
+              <a:rPr sz="1250" b="0">
+                <a:solidFill>
+                  <a:srgbClr val="6E6E6E"/>
+                </a:solidFill>
+                <a:latin typeface="Arial"/>
+              </a:rPr>
+              <a:t>A Babinet split with 1e-15 closure: the edge interferes, it does not merely add</a:t>
+            </a:r>
+          </a:p>
+        </p:txBody>
+      </p:sp>
+      <p:sp>
+        <p:nvSpPr>
+          <p:cNvPr id="3" name="Rectangle 2"/>
+          <p:cNvSpPr/>
+          <p:nvPr/>
+        </p:nvSpPr>
+        <p:spPr>
+          <a:xfrm>
+            <a:off x="411480" y="1133856"/>
+            <a:ext cx="11368735" cy="20320"/>
+          </a:xfrm>
+          <a:prstGeom prst="rect">
+            <a:avLst/>
+          </a:prstGeom>
+          <a:solidFill>
+            <a:srgbClr val="B8C6D4"/>
+          </a:solidFill>
+          <a:ln>
+            <a:noFill/>
+          </a:ln>
+          <a:effectLst/>
+        </p:spPr>
+        <p:style>
+          <a:lnRef idx="1">
+            <a:schemeClr val="accent1"/>
+          </a:lnRef>
+          <a:fillRef idx="3">
+            <a:schemeClr val="accent1"/>
+          </a:fillRef>
+          <a:effectRef idx="2">
+            <a:schemeClr val="accent1"/>
+          </a:effectRef>
+          <a:fontRef idx="minor">
+            <a:schemeClr val="lt1"/>
+          </a:fontRef>
+        </p:style>
+        <p:txBody>
+          <a:bodyPr rtlCol="0" anchor="ctr"/>
+          <a:lstStyle/>
+          <a:p>
+            <a:pPr algn="ctr"/>
+          </a:p>
+        </p:txBody>
+      </p:sp>
+      <p:sp>
+        <p:nvSpPr>
+          <p:cNvPr id="4" name="TextBox 3"/>
+          <p:cNvSpPr txBox="1"/>
+          <p:nvPr/>
+        </p:nvSpPr>
+        <p:spPr>
+          <a:xfrm>
+            <a:off x="411480" y="1298448"/>
+            <a:ext cx="5806440" cy="274320"/>
+          </a:xfrm>
+          <a:prstGeom prst="rect">
+            <a:avLst/>
+          </a:prstGeom>
+          <a:noFill/>
+        </p:spPr>
+        <p:txBody>
+          <a:bodyPr wrap="square">
+            <a:spAutoFit/>
+          </a:bodyPr>
+          <a:lstStyle/>
+          <a:p>
+            <a:pPr>
+              <a:spcAft>
+                <a:spcPts val="600"/>
+              </a:spcAft>
+            </a:pPr>
+            <a:r>
+              <a:rPr sz="1200" b="0">
+                <a:solidFill>
+                  <a:srgbClr val="282828"/>
+                </a:solidFill>
+                <a:latin typeface="Arial"/>
+              </a:rPr>
+              <a:t>•  </a:t>
+            </a:r>
+            <a:r>
+              <a:rPr sz="1200" b="1">
+                <a:solidFill>
+                  <a:srgbClr val="282828"/>
+                </a:solidFill>
+                <a:latin typeface="Arial"/>
+              </a:rPr>
+              <a:t>Method.</a:t>
+            </a:r>
+            <a:r>
+              <a:rPr sz="1200" b="0">
+                <a:solidFill>
+                  <a:srgbClr val="282828"/>
+                </a:solidFill>
+                <a:latin typeface="Arial"/>
+              </a:rPr>
+              <a:t>  The circular stop applied as a SCREEN on the no-stop chain holds every mask and scale fixed, so E_rim = E_hex - E_screened is exactly the blocked rim's field.  Pins: screened bare peak == stopped bare peak to 0.0e0; both S1 records reproduced under 1%.</a:t>
+            </a:r>
+          </a:p>
+          <a:p>
+            <a:pPr>
+              <a:spcAft>
+                <a:spcPts val="600"/>
+              </a:spcAft>
+            </a:pPr>
+            <a:r>
+              <a:rPr sz="1200" b="0">
+                <a:solidFill>
+                  <a:srgbClr val="282828"/>
+                </a:solidFill>
+                <a:latin typeface="Arial"/>
+              </a:rPr>
+              <a:t>•  </a:t>
+            </a:r>
+            <a:r>
+              <a:rPr sz="1200" b="1">
+                <a:solidFill>
+                  <a:srgbClr val="282828"/>
+                </a:solidFill>
+                <a:latin typeface="Arial"/>
+              </a:rPr>
+              <a:t>The split (dark-zone mean energy):</a:t>
+            </a:r>
+            <a:r>
+              <a:rPr sz="1200" b="0">
+                <a:solidFill>
+                  <a:srgbClr val="282828"/>
+                </a:solidFill>
+                <a:latin typeface="Arial"/>
+              </a:rPr>
+              <a:t> I_ns 1.09e-05 + rim 2.53e-06 + cross 6.54e-06 — the rim's own ring is ~28% of the increase; the cross term (coherent interference with the pre-existing gap speckle) is 2.6x larger.  Peak renormalization 1.178x; dark-zone energy up 1.83x at fixed masks; the lambda/D re-reference contributes 1.00x.</a:t>
+            </a:r>
+          </a:p>
+          <a:p>
+            <a:pPr>
+              <a:spcAft>
+                <a:spcPts val="600"/>
+              </a:spcAft>
+            </a:pPr>
+            <a:r>
+              <a:rPr sz="1200" b="0">
+                <a:solidFill>
+                  <a:srgbClr val="282828"/>
+                </a:solidFill>
+                <a:latin typeface="Arial"/>
+              </a:rPr>
+              <a:t>•  </a:t>
+            </a:r>
+            <a:r>
+              <a:rPr sz="1200" b="1">
+                <a:solidFill>
+                  <a:srgbClr val="282828"/>
+                </a:solidFill>
+                <a:latin typeface="Arial"/>
+              </a:rPr>
+              <a:t>The APLC flag, restated:</a:t>
+            </a:r>
+            <a:r>
+              <a:rPr sz="1200" b="0">
+                <a:solidFill>
+                  <a:srgbClr val="282828"/>
+                </a:solidFill>
+                <a:latin typeface="Arial"/>
+              </a:rPr>
+              <a:t> the stopped aperture-matched prolate hit its iteration cap unconverged (the answer moves with the cap — not an eigenfunction, not a design); its apodizer also moves 2x with grid size (1.07e-6 at N=512 vs 2.18e-6 at 1024) — an implementation verdict, not a family verdict; the family is DEFERRED and the block/Lanczos eigensolver or the N'Diaye LP co-design are the named machines.  Bound reading (all rows): lin-ach is the relin G's rank-curve at the achieved stroke — a scale, not a strict inequality; Tikhonov solutions can undercut it by O(20%) (vortex c6 does).</a:t>
+            </a:r>
+          </a:p>
+        </p:txBody>
+      </p:sp>
+      <p:pic>
+        <p:nvPicPr>
+          <p:cNvPr id="5" name="Picture 4" descr="cf1c_stop_attrib.png"/>
+          <p:cNvPicPr>
+            <a:picLocks noChangeAspect="1"/>
+          </p:cNvPicPr>
+          <p:nvPr/>
+        </p:nvPicPr>
+        <p:blipFill>
+          <a:blip r:embed="rId2"/>
+          <a:stretch>
+            <a:fillRect/>
+          </a:stretch>
+        </p:blipFill>
+        <p:spPr>
+          <a:xfrm>
+            <a:off x="6758517" y="1298448"/>
+            <a:ext cx="4679524" cy="3611371"/>
+          </a:xfrm>
+          <a:prstGeom prst="rect">
+            <a:avLst/>
+          </a:prstGeom>
+        </p:spPr>
+      </p:pic>
+      <p:sp>
+        <p:nvSpPr>
+          <p:cNvPr id="6" name="TextBox 5"/>
+          <p:cNvSpPr txBox="1"/>
+          <p:nvPr/>
+        </p:nvSpPr>
+        <p:spPr>
+          <a:xfrm>
+            <a:off x="6400800" y="4928107"/>
+            <a:ext cx="5394960" cy="229107"/>
+          </a:xfrm>
+          <a:prstGeom prst="rect">
+            <a:avLst/>
+          </a:prstGeom>
+          <a:noFill/>
+        </p:spPr>
+        <p:txBody>
+          <a:bodyPr wrap="square">
+            <a:spAutoFit/>
+          </a:bodyPr>
+          <a:lstStyle/>
+          <a:p>
+            <a:pPr algn="ctr">
+              <a:spcAft>
+                <a:spcPts val="0"/>
+              </a:spcAft>
+            </a:pPr>
+            <a:r>
+              <a:rPr sz="1000" b="0">
+                <a:solidFill>
+                  <a:srgbClr val="6E6E6E"/>
+                </a:solidFill>
+                <a:latin typeface="Arial"/>
+              </a:rPr>
+              <a:t>Where the stop's edge lands: no-stop, stop-as-screen, and the rim field alone.</a:t>
+            </a:r>
+          </a:p>
+        </p:txBody>
+      </p:sp>
+    </p:spTree>
+  </p:cSld>
+  <p:clrMapOvr>
+    <a:masterClrMapping/>
+  </p:clrMapOvr>
+</p:sld>
+</file>
+
+<file path=ppt/slides/slide21.xml><?xml version="1.0" encoding="utf-8"?>
 <p:sld xmlns:a="http://schemas.openxmlformats.org/drawingml/2006/main" xmlns:p="http://schemas.openxmlformats.org/presentationml/2006/main" xmlns:r="http://schemas.openxmlformats.org/officeDocument/2006/relationships">
   <p:cSld>
     <p:spTree>
@@ -7118,7 +8166,7 @@
 </p:sld>
 </file>
 
-<file path=ppt/slides/slide2.xml><?xml version="1.0" encoding="utf-8"?>
+<file path=ppt/slides/slide22.xml><?xml version="1.0" encoding="utf-8"?>
 <p:sld xmlns:a="http://schemas.openxmlformats.org/drawingml/2006/main" xmlns:p="http://schemas.openxmlformats.org/presentationml/2006/main" xmlns:r="http://schemas.openxmlformats.org/officeDocument/2006/relationships">
   <p:cSld>
     <p:spTree>
@@ -7162,7 +8210,7 @@
                 </a:solidFill>
                 <a:latin typeface="Arial"/>
               </a:rPr>
-              <a:t>The telescope</a:t>
+              <a:t>Choosing a stable control law</a:t>
             </a:r>
           </a:p>
           <a:p>
@@ -7178,7 +8226,7 @@
                 </a:solidFill>
                 <a:latin typeface="Arial"/>
               </a:rPr>
-              <a:t>0.0473 waves RMS across the field — diffraction-limited at 500 nm</a:t>
+              <a:t>Two mechanizations rejected by measurement</a:t>
             </a:r>
           </a:p>
         </p:txBody>
@@ -7236,7 +8284,7 @@
         <p:spPr>
           <a:xfrm>
             <a:off x="411480" y="1298448"/>
-            <a:ext cx="5806440" cy="274320"/>
+            <a:ext cx="11368735" cy="274320"/>
           </a:xfrm>
           <a:prstGeom prst="rect">
             <a:avLst/>
@@ -7270,16 +8318,16 @@
                 </a:solidFill>
                 <a:latin typeface="Arial"/>
               </a:rPr>
-              <a:t>The design.</a:t>
-            </a:r>
-            <a:r>
-              <a:rPr sz="1200" b="0">
-                <a:solidFill>
-                  <a:srgbClr val="282828"/>
-                </a:solidFill>
-                <a:latin typeface="Arial"/>
-              </a:rPr>
-              <a:t> A 6 m unobscured three-mirror telescope: three base spheres placed for packaging, fold tilts doing the unobscuration, all correction carried by Zernike surface departures.  Field ±0.35 arcmin.</a:t>
+              <a:t>A held one-shot correction</a:t>
+            </a:r>
+            <a:r>
+              <a:rPr sz="1200" b="0">
+                <a:solidFill>
+                  <a:srgbClr val="282828"/>
+                </a:solidFill>
+                <a:latin typeface="Arial"/>
+              </a:rPr>
+              <a:t> (the round-1 idiom, with real sensor noise): at the solve frame the drift sits below the 1 nm edge noise, the estimate residual exceeds the state, and the corrected leg ends worse than the uncorrected one.</a:t>
             </a:r>
           </a:p>
           <a:p>
@@ -7304,16 +8352,16 @@
                 </a:solidFill>
                 <a:latin typeface="Arial"/>
               </a:rPr>
-              <a:t>The wavefront.</a:t>
-            </a:r>
-            <a:r>
-              <a:rPr sz="1200" b="0">
-                <a:solidFill>
-                  <a:srgbClr val="282828"/>
-                </a:solidFill>
-                <a:latin typeface="Arial"/>
-              </a:rPr>
-              <a:t> 0.0473 waves RMS worst case over the field, against a 0.071-wave diffraction limit.</a:t>
+              <a:t>A per-frame loop on the estimator's segment slice</a:t>
+            </a:r>
+            <a:r>
+              <a:rPr sz="1200" b="0">
+                <a:solidFill>
+                  <a:srgbClr val="282828"/>
+                </a:solidFill>
+                <a:latin typeface="Arial"/>
+              </a:rPr>
+              <a:t>: the full-body minimum-variance gain is contractive, its segment slice is not (spectral radius 1.154) — the engine loop diverged to 19 nm on a 3 nm drift, and a pure-linear simulation predicts the divergence to three digits.</a:t>
             </a:r>
           </a:p>
           <a:p>
@@ -7338,16 +8386,16 @@
                 </a:solidFill>
                 <a:latin typeface="Arial"/>
               </a:rPr>
-              <a:t>The packaging.</a:t>
-            </a:r>
-            <a:r>
-              <a:rPr sz="1200" b="0">
-                <a:solidFill>
-                  <a:srgbClr val="282828"/>
-                </a:solidFill>
-                <a:latin typeface="Arial"/>
-              </a:rPr>
-              <a:t> 7.450 m diameter against the 8 m shroud; 1185/1185 rays survive a standalone reload of the saved prescription.</a:t>
+              <a:t>Shipped: weighted least squares with ridge on the segment state</a:t>
+            </a:r>
+            <a:r>
+              <a:rPr sz="1200" b="0">
+                <a:solidFill>
+                  <a:srgbClr val="282828"/>
+                </a:solidFill>
+                <a:latin typeface="Arial"/>
+              </a:rPr>
+              <a:t> (radius 0.9998, gain 0.5): converges to the 0.36 nm sensor-noise floor.</a:t>
             </a:r>
           </a:p>
           <a:p>
@@ -7372,408 +8420,6 @@
                 </a:solidFill>
                 <a:latin typeface="Arial"/>
               </a:rPr>
-              <a:t>The one miss.</a:t>
-            </a:r>
-            <a:r>
-              <a:rPr sz="1200" b="0">
-                <a:solidFill>
-                  <a:srgbClr val="282828"/>
-                </a:solidFill>
-                <a:latin typeface="Arial"/>
-              </a:rPr>
-              <a:t> Focal ratio f/25.39 against a requested f/12–20; not a tuning failure — see the backup.</a:t>
-            </a:r>
-          </a:p>
-        </p:txBody>
-      </p:sp>
-      <p:pic>
-        <p:nvPicPr>
-          <p:cNvPr id="5" name="Picture 4" descr="s1_layout.png"/>
-          <p:cNvPicPr>
-            <a:picLocks noChangeAspect="1"/>
-          </p:cNvPicPr>
-          <p:nvPr/>
-        </p:nvPicPr>
-        <p:blipFill>
-          <a:blip r:embed="rId2"/>
-          <a:stretch>
-            <a:fillRect/>
-          </a:stretch>
-        </p:blipFill>
-        <p:spPr>
-          <a:xfrm>
-            <a:off x="6980220" y="1298448"/>
-            <a:ext cx="4236119" cy="2348992"/>
-          </a:xfrm>
-          <a:prstGeom prst="rect">
-            <a:avLst/>
-          </a:prstGeom>
-        </p:spPr>
-      </p:pic>
-      <p:sp>
-        <p:nvSpPr>
-          <p:cNvPr id="6" name="TextBox 5"/>
-          <p:cNvSpPr txBox="1"/>
-          <p:nvPr/>
-        </p:nvSpPr>
-        <p:spPr>
-          <a:xfrm>
-            <a:off x="6400800" y="3665727"/>
-            <a:ext cx="5394960" cy="394208"/>
-          </a:xfrm>
-          <a:prstGeom prst="rect">
-            <a:avLst/>
-          </a:prstGeom>
-          <a:noFill/>
-        </p:spPr>
-        <p:txBody>
-          <a:bodyPr wrap="square">
-            <a:spAutoFit/>
-          </a:bodyPr>
-          <a:lstStyle/>
-          <a:p>
-            <a:pPr algn="ctr">
-              <a:spcAft>
-                <a:spcPts val="0"/>
-              </a:spcAft>
-            </a:pPr>
-            <a:r>
-              <a:rPr sz="1000" b="0">
-                <a:solidFill>
-                  <a:srgbClr val="6E6E6E"/>
-                </a:solidFill>
-                <a:latin typeface="Arial"/>
-              </a:rPr>
-              <a:t>The three-mirror train: light enters from the left, folds back to the secondary, returns past the primary to the tertiary and the focus.</a:t>
-            </a:r>
-          </a:p>
-        </p:txBody>
-      </p:sp>
-      <p:pic>
-        <p:nvPicPr>
-          <p:cNvPr id="7" name="Picture 6" descr="s1_wfe_field.png"/>
-          <p:cNvPicPr>
-            <a:picLocks noChangeAspect="1"/>
-          </p:cNvPicPr>
-          <p:nvPr/>
-        </p:nvPicPr>
-        <p:blipFill>
-          <a:blip r:embed="rId3"/>
-          <a:stretch>
-            <a:fillRect/>
-          </a:stretch>
-        </p:blipFill>
-        <p:spPr>
-          <a:xfrm>
-            <a:off x="7705463" y="4096512"/>
-            <a:ext cx="2785632" cy="2367788"/>
-          </a:xfrm>
-          <a:prstGeom prst="rect">
-            <a:avLst/>
-          </a:prstGeom>
-        </p:spPr>
-      </p:pic>
-      <p:sp>
-        <p:nvSpPr>
-          <p:cNvPr id="8" name="TextBox 7"/>
-          <p:cNvSpPr txBox="1"/>
-          <p:nvPr/>
-        </p:nvSpPr>
-        <p:spPr>
-          <a:xfrm>
-            <a:off x="6400800" y="6482588"/>
-            <a:ext cx="5394960" cy="229107"/>
-          </a:xfrm>
-          <a:prstGeom prst="rect">
-            <a:avLst/>
-          </a:prstGeom>
-          <a:noFill/>
-        </p:spPr>
-        <p:txBody>
-          <a:bodyPr wrap="square">
-            <a:spAutoFit/>
-          </a:bodyPr>
-          <a:lstStyle/>
-          <a:p>
-            <a:pPr algn="ctr">
-              <a:spcAft>
-                <a:spcPts val="0"/>
-              </a:spcAft>
-            </a:pPr>
-            <a:r>
-              <a:rPr sz="1000" b="0">
-                <a:solidFill>
-                  <a:srgbClr val="6E6E6E"/>
-                </a:solidFill>
-                <a:latin typeface="Arial"/>
-              </a:rPr>
-              <a:t>Wavefront error over the design field.  Worst corner 0.0473 waves.</a:t>
-            </a:r>
-          </a:p>
-        </p:txBody>
-      </p:sp>
-    </p:spTree>
-  </p:cSld>
-  <p:clrMapOvr>
-    <a:masterClrMapping/>
-  </p:clrMapOvr>
-</p:sld>
-</file>
-
-<file path=ppt/slides/slide20.xml><?xml version="1.0" encoding="utf-8"?>
-<p:sld xmlns:a="http://schemas.openxmlformats.org/drawingml/2006/main" xmlns:p="http://schemas.openxmlformats.org/presentationml/2006/main" xmlns:r="http://schemas.openxmlformats.org/officeDocument/2006/relationships">
-  <p:cSld>
-    <p:spTree>
-      <p:nvGrpSpPr>
-        <p:cNvPr id="1" name=""/>
-        <p:cNvGrpSpPr/>
-        <p:nvPr/>
-      </p:nvGrpSpPr>
-      <p:grpSpPr/>
-      <p:sp>
-        <p:nvSpPr>
-          <p:cNvPr id="2" name="TextBox 1"/>
-          <p:cNvSpPr txBox="1"/>
-          <p:nvPr/>
-        </p:nvSpPr>
-        <p:spPr>
-          <a:xfrm>
-            <a:off x="411480" y="201168"/>
-            <a:ext cx="11368735" cy="914400"/>
-          </a:xfrm>
-          <a:prstGeom prst="rect">
-            <a:avLst/>
-          </a:prstGeom>
-          <a:noFill/>
-        </p:spPr>
-        <p:txBody>
-          <a:bodyPr wrap="square">
-            <a:spAutoFit/>
-          </a:bodyPr>
-          <a:lstStyle/>
-          <a:p>
-            <a:pPr>
-              <a:spcAft>
-                <a:spcPts val="400"/>
-              </a:spcAft>
-            </a:pPr>
-            <a:r>
-              <a:rPr sz="2400" b="1">
-                <a:solidFill>
-                  <a:srgbClr val="1F4E79"/>
-                </a:solidFill>
-                <a:latin typeface="Arial"/>
-              </a:rPr>
-              <a:t>Choosing a stable control law</a:t>
-            </a:r>
-          </a:p>
-          <a:p>
-            <a:pPr>
-              <a:spcAft>
-                <a:spcPts val="0"/>
-              </a:spcAft>
-            </a:pPr>
-            <a:r>
-              <a:rPr sz="1250" b="0">
-                <a:solidFill>
-                  <a:srgbClr val="6E6E6E"/>
-                </a:solidFill>
-                <a:latin typeface="Arial"/>
-              </a:rPr>
-              <a:t>Two mechanizations rejected by measurement</a:t>
-            </a:r>
-          </a:p>
-        </p:txBody>
-      </p:sp>
-      <p:sp>
-        <p:nvSpPr>
-          <p:cNvPr id="3" name="Rectangle 2"/>
-          <p:cNvSpPr/>
-          <p:nvPr/>
-        </p:nvSpPr>
-        <p:spPr>
-          <a:xfrm>
-            <a:off x="411480" y="1133856"/>
-            <a:ext cx="11368735" cy="20320"/>
-          </a:xfrm>
-          <a:prstGeom prst="rect">
-            <a:avLst/>
-          </a:prstGeom>
-          <a:solidFill>
-            <a:srgbClr val="B8C6D4"/>
-          </a:solidFill>
-          <a:ln>
-            <a:noFill/>
-          </a:ln>
-          <a:effectLst/>
-        </p:spPr>
-        <p:style>
-          <a:lnRef idx="1">
-            <a:schemeClr val="accent1"/>
-          </a:lnRef>
-          <a:fillRef idx="3">
-            <a:schemeClr val="accent1"/>
-          </a:fillRef>
-          <a:effectRef idx="2">
-            <a:schemeClr val="accent1"/>
-          </a:effectRef>
-          <a:fontRef idx="minor">
-            <a:schemeClr val="lt1"/>
-          </a:fontRef>
-        </p:style>
-        <p:txBody>
-          <a:bodyPr rtlCol="0" anchor="ctr"/>
-          <a:lstStyle/>
-          <a:p>
-            <a:pPr algn="ctr"/>
-          </a:p>
-        </p:txBody>
-      </p:sp>
-      <p:sp>
-        <p:nvSpPr>
-          <p:cNvPr id="4" name="TextBox 3"/>
-          <p:cNvSpPr txBox="1"/>
-          <p:nvPr/>
-        </p:nvSpPr>
-        <p:spPr>
-          <a:xfrm>
-            <a:off x="411480" y="1298448"/>
-            <a:ext cx="11368735" cy="274320"/>
-          </a:xfrm>
-          <a:prstGeom prst="rect">
-            <a:avLst/>
-          </a:prstGeom>
-          <a:noFill/>
-        </p:spPr>
-        <p:txBody>
-          <a:bodyPr wrap="square">
-            <a:spAutoFit/>
-          </a:bodyPr>
-          <a:lstStyle/>
-          <a:p>
-            <a:pPr>
-              <a:spcAft>
-                <a:spcPts val="600"/>
-              </a:spcAft>
-            </a:pPr>
-            <a:r>
-              <a:rPr sz="1200" b="0">
-                <a:solidFill>
-                  <a:srgbClr val="282828"/>
-                </a:solidFill>
-                <a:latin typeface="Arial"/>
-              </a:rPr>
-              <a:t>•  </a:t>
-            </a:r>
-            <a:r>
-              <a:rPr sz="1200" b="1">
-                <a:solidFill>
-                  <a:srgbClr val="282828"/>
-                </a:solidFill>
-                <a:latin typeface="Arial"/>
-              </a:rPr>
-              <a:t>A held one-shot correction</a:t>
-            </a:r>
-            <a:r>
-              <a:rPr sz="1200" b="0">
-                <a:solidFill>
-                  <a:srgbClr val="282828"/>
-                </a:solidFill>
-                <a:latin typeface="Arial"/>
-              </a:rPr>
-              <a:t> (the round-1 idiom, with real sensor noise): at the solve frame the drift sits below the 1 nm edge noise, the estimate residual exceeds the state, and the corrected leg ends worse than the uncorrected one.</a:t>
-            </a:r>
-          </a:p>
-          <a:p>
-            <a:pPr>
-              <a:spcAft>
-                <a:spcPts val="600"/>
-              </a:spcAft>
-            </a:pPr>
-            <a:r>
-              <a:rPr sz="1200" b="0">
-                <a:solidFill>
-                  <a:srgbClr val="282828"/>
-                </a:solidFill>
-                <a:latin typeface="Arial"/>
-              </a:rPr>
-              <a:t>•  </a:t>
-            </a:r>
-            <a:r>
-              <a:rPr sz="1200" b="1">
-                <a:solidFill>
-                  <a:srgbClr val="282828"/>
-                </a:solidFill>
-                <a:latin typeface="Arial"/>
-              </a:rPr>
-              <a:t>A per-frame loop on the estimator's segment slice</a:t>
-            </a:r>
-            <a:r>
-              <a:rPr sz="1200" b="0">
-                <a:solidFill>
-                  <a:srgbClr val="282828"/>
-                </a:solidFill>
-                <a:latin typeface="Arial"/>
-              </a:rPr>
-              <a:t>: the full-body minimum-variance gain is contractive, its segment slice is not (spectral radius 1.154) — the engine loop diverged to 19 nm on a 3 nm drift, and a pure-linear simulation predicts the divergence to three digits.</a:t>
-            </a:r>
-          </a:p>
-          <a:p>
-            <a:pPr>
-              <a:spcAft>
-                <a:spcPts val="600"/>
-              </a:spcAft>
-            </a:pPr>
-            <a:r>
-              <a:rPr sz="1200" b="0">
-                <a:solidFill>
-                  <a:srgbClr val="282828"/>
-                </a:solidFill>
-                <a:latin typeface="Arial"/>
-              </a:rPr>
-              <a:t>•  </a:t>
-            </a:r>
-            <a:r>
-              <a:rPr sz="1200" b="1">
-                <a:solidFill>
-                  <a:srgbClr val="282828"/>
-                </a:solidFill>
-                <a:latin typeface="Arial"/>
-              </a:rPr>
-              <a:t>Shipped: weighted least squares with ridge on the segment state</a:t>
-            </a:r>
-            <a:r>
-              <a:rPr sz="1200" b="0">
-                <a:solidFill>
-                  <a:srgbClr val="282828"/>
-                </a:solidFill>
-                <a:latin typeface="Arial"/>
-              </a:rPr>
-              <a:t> (radius 0.9998, gain 0.5): converges to the 0.36 nm sensor-noise floor.</a:t>
-            </a:r>
-          </a:p>
-          <a:p>
-            <a:pPr>
-              <a:spcAft>
-                <a:spcPts val="600"/>
-              </a:spcAft>
-            </a:pPr>
-            <a:r>
-              <a:rPr sz="1200" b="0">
-                <a:solidFill>
-                  <a:srgbClr val="282828"/>
-                </a:solidFill>
-                <a:latin typeface="Arial"/>
-              </a:rPr>
-              <a:t>•  </a:t>
-            </a:r>
-            <a:r>
-              <a:rPr sz="1200" b="1">
-                <a:solidFill>
-                  <a:srgbClr val="282828"/>
-                </a:solidFill>
-                <a:latin typeface="Arial"/>
-              </a:rPr>
               <a:t>The DM re-solve needed the same care.</a:t>
             </a:r>
             <a:r>
@@ -7784,420 +8430,6 @@
                 <a:latin typeface="Arial"/>
               </a:rPr>
               <a:t> Undamped solves against gap speckle — amplitude-dominated, weakly controllable at this DM spacing — push stroke along near-null directions and diverge; damping (0.7) plus a small leak (0.02) makes the dig monotone and held.  DM spacing as an amplitude-authority knob is a stated design trade, not exercised here.</a:t>
-            </a:r>
-          </a:p>
-        </p:txBody>
-      </p:sp>
-    </p:spTree>
-  </p:cSld>
-  <p:clrMapOvr>
-    <a:masterClrMapping/>
-  </p:clrMapOvr>
-</p:sld>
-</file>
-
-<file path=ppt/slides/slide21.xml><?xml version="1.0" encoding="utf-8"?>
-<p:sld xmlns:a="http://schemas.openxmlformats.org/drawingml/2006/main" xmlns:p="http://schemas.openxmlformats.org/presentationml/2006/main" xmlns:r="http://schemas.openxmlformats.org/officeDocument/2006/relationships">
-  <p:cSld>
-    <p:spTree>
-      <p:nvGrpSpPr>
-        <p:cNvPr id="1" name=""/>
-        <p:cNvGrpSpPr/>
-        <p:nvPr/>
-      </p:nvGrpSpPr>
-      <p:grpSpPr/>
-      <p:sp>
-        <p:nvSpPr>
-          <p:cNvPr id="2" name="TextBox 1"/>
-          <p:cNvSpPr txBox="1"/>
-          <p:nvPr/>
-        </p:nvSpPr>
-        <p:spPr>
-          <a:xfrm>
-            <a:off x="411480" y="201168"/>
-            <a:ext cx="11368735" cy="914400"/>
-          </a:xfrm>
-          <a:prstGeom prst="rect">
-            <a:avLst/>
-          </a:prstGeom>
-          <a:noFill/>
-        </p:spPr>
-        <p:txBody>
-          <a:bodyPr wrap="square">
-            <a:spAutoFit/>
-          </a:bodyPr>
-          <a:lstStyle/>
-          <a:p>
-            <a:pPr>
-              <a:spcAft>
-                <a:spcPts val="400"/>
-              </a:spcAft>
-            </a:pPr>
-            <a:r>
-              <a:rPr sz="2400" b="1">
-                <a:solidFill>
-                  <a:srgbClr val="1F4E79"/>
-                </a:solidFill>
-                <a:latin typeface="Arial"/>
-              </a:rPr>
-              <a:t>Packaging the longer relay</a:t>
-            </a:r>
-          </a:p>
-          <a:p>
-            <a:pPr>
-              <a:spcAft>
-                <a:spcPts val="0"/>
-              </a:spcAft>
-            </a:pPr>
-            <a:r>
-              <a:rPr sz="1250" b="0">
-                <a:solidFill>
-                  <a:srgbClr val="6E6E6E"/>
-                </a:solidFill>
-                <a:latin typeface="Arial"/>
-              </a:rPr>
-              <a:t>Fold side is a stability choice, not a taste choice</a:t>
-            </a:r>
-          </a:p>
-        </p:txBody>
-      </p:sp>
-      <p:sp>
-        <p:nvSpPr>
-          <p:cNvPr id="3" name="Rectangle 2"/>
-          <p:cNvSpPr/>
-          <p:nvPr/>
-        </p:nvSpPr>
-        <p:spPr>
-          <a:xfrm>
-            <a:off x="411480" y="1133856"/>
-            <a:ext cx="11368735" cy="20320"/>
-          </a:xfrm>
-          <a:prstGeom prst="rect">
-            <a:avLst/>
-          </a:prstGeom>
-          <a:solidFill>
-            <a:srgbClr val="B8C6D4"/>
-          </a:solidFill>
-          <a:ln>
-            <a:noFill/>
-          </a:ln>
-          <a:effectLst/>
-        </p:spPr>
-        <p:style>
-          <a:lnRef idx="1">
-            <a:schemeClr val="accent1"/>
-          </a:lnRef>
-          <a:fillRef idx="3">
-            <a:schemeClr val="accent1"/>
-          </a:fillRef>
-          <a:effectRef idx="2">
-            <a:schemeClr val="accent1"/>
-          </a:effectRef>
-          <a:fontRef idx="minor">
-            <a:schemeClr val="lt1"/>
-          </a:fontRef>
-        </p:style>
-        <p:txBody>
-          <a:bodyPr rtlCol="0" anchor="ctr"/>
-          <a:lstStyle/>
-          <a:p>
-            <a:pPr algn="ctr"/>
-          </a:p>
-        </p:txBody>
-      </p:sp>
-      <p:sp>
-        <p:nvSpPr>
-          <p:cNvPr id="4" name="TextBox 3"/>
-          <p:cNvSpPr txBox="1"/>
-          <p:nvPr/>
-        </p:nvSpPr>
-        <p:spPr>
-          <a:xfrm>
-            <a:off x="411480" y="1298448"/>
-            <a:ext cx="11368735" cy="274320"/>
-          </a:xfrm>
-          <a:prstGeom prst="rect">
-            <a:avLst/>
-          </a:prstGeom>
-          <a:noFill/>
-        </p:spPr>
-        <p:txBody>
-          <a:bodyPr wrap="square">
-            <a:spAutoFit/>
-          </a:bodyPr>
-          <a:lstStyle/>
-          <a:p>
-            <a:pPr>
-              <a:spcAft>
-                <a:spcPts val="600"/>
-              </a:spcAft>
-            </a:pPr>
-            <a:r>
-              <a:rPr sz="1200" b="0">
-                <a:solidFill>
-                  <a:srgbClr val="282828"/>
-                </a:solidFill>
-                <a:latin typeface="Arial"/>
-              </a:rPr>
-              <a:t>•  A near-normal fold turns the chief by 180° − 2·AOI, and the beam direction reverses at each mirror.</a:t>
-            </a:r>
-          </a:p>
-          <a:p>
-            <a:pPr>
-              <a:spcAft>
-                <a:spcPts val="600"/>
-              </a:spcAft>
-            </a:pPr>
-            <a:r>
-              <a:rPr sz="1200" b="0">
-                <a:solidFill>
-                  <a:srgbClr val="282828"/>
-                </a:solidFill>
-                <a:latin typeface="Arial"/>
-              </a:rPr>
-              <a:t>•  </a:t>
-            </a:r>
-            <a:r>
-              <a:rPr sz="1200" b="1">
-                <a:solidFill>
-                  <a:srgbClr val="282828"/>
-                </a:solidFill>
-                <a:latin typeface="Arial"/>
-              </a:rPr>
-              <a:t>Alternating the fold side</a:t>
-            </a:r>
-            <a:r>
-              <a:rPr sz="1200" b="0">
-                <a:solidFill>
-                  <a:srgbClr val="282828"/>
-                </a:solidFill>
-                <a:latin typeface="Arial"/>
-              </a:rPr>
-              <a:t> — fine for the five folds of the shorter round-1 relay — adds −2·AOI of net rotation per fold: over this chain's ten folds the accordion fans ~120° and walks to a 10.33 m shroud diameter.  Measured, with the element positions in the record.</a:t>
-            </a:r>
-          </a:p>
-          <a:p>
-            <a:pPr>
-              <a:spcAft>
-                <a:spcPts val="600"/>
-              </a:spcAft>
-            </a:pPr>
-            <a:r>
-              <a:rPr sz="1200" b="0">
-                <a:solidFill>
-                  <a:srgbClr val="282828"/>
-                </a:solidFill>
-                <a:latin typeface="Arial"/>
-              </a:rPr>
-              <a:t>•  </a:t>
-            </a:r>
-            <a:r>
-              <a:rPr sz="1200" b="1">
-                <a:solidFill>
-                  <a:srgbClr val="282828"/>
-                </a:solidFill>
-                <a:latin typeface="Arial"/>
-              </a:rPr>
-              <a:t>Keeping the same side every fold</a:t>
-            </a:r>
-            <a:r>
-              <a:rPr sz="1200" b="0">
-                <a:solidFill>
-                  <a:srgbClr val="282828"/>
-                </a:solidFill>
-                <a:latin typeface="Arial"/>
-              </a:rPr>
-              <a:t> ping-pongs the beam between two fixed directions and packs the chain into a leg-sized pocket: 7.451 m, identical to the primary-set envelope.  The DM-bearing back end costs nothing in shroud diameter.</a:t>
-            </a:r>
-          </a:p>
-        </p:txBody>
-      </p:sp>
-    </p:spTree>
-  </p:cSld>
-  <p:clrMapOvr>
-    <a:masterClrMapping/>
-  </p:clrMapOvr>
-</p:sld>
-</file>
-
-<file path=ppt/slides/slide22.xml><?xml version="1.0" encoding="utf-8"?>
-<p:sld xmlns:a="http://schemas.openxmlformats.org/drawingml/2006/main" xmlns:p="http://schemas.openxmlformats.org/presentationml/2006/main" xmlns:r="http://schemas.openxmlformats.org/officeDocument/2006/relationships">
-  <p:cSld>
-    <p:spTree>
-      <p:nvGrpSpPr>
-        <p:cNvPr id="1" name=""/>
-        <p:cNvGrpSpPr/>
-        <p:nvPr/>
-      </p:nvGrpSpPr>
-      <p:grpSpPr/>
-      <p:sp>
-        <p:nvSpPr>
-          <p:cNvPr id="2" name="TextBox 1"/>
-          <p:cNvSpPr txBox="1"/>
-          <p:nvPr/>
-        </p:nvSpPr>
-        <p:spPr>
-          <a:xfrm>
-            <a:off x="411480" y="201168"/>
-            <a:ext cx="11368735" cy="914400"/>
-          </a:xfrm>
-          <a:prstGeom prst="rect">
-            <a:avLst/>
-          </a:prstGeom>
-          <a:noFill/>
-        </p:spPr>
-        <p:txBody>
-          <a:bodyPr wrap="square">
-            <a:spAutoFit/>
-          </a:bodyPr>
-          <a:lstStyle/>
-          <a:p>
-            <a:pPr>
-              <a:spcAft>
-                <a:spcPts val="400"/>
-              </a:spcAft>
-            </a:pPr>
-            <a:r>
-              <a:rPr sz="2400" b="1">
-                <a:solidFill>
-                  <a:srgbClr val="1F4E79"/>
-                </a:solidFill>
-                <a:latin typeface="Arial"/>
-              </a:rPr>
-              <a:t>Focal ratio: why f/25.4 and not f/12–20</a:t>
-            </a:r>
-          </a:p>
-          <a:p>
-            <a:pPr>
-              <a:spcAft>
-                <a:spcPts val="0"/>
-              </a:spcAft>
-            </a:pPr>
-            <a:r>
-              <a:rPr sz="1250" b="0">
-                <a:solidFill>
-                  <a:srgbClr val="6E6E6E"/>
-                </a:solidFill>
-                <a:latin typeface="Arial"/>
-              </a:rPr>
-              <a:t>The corrected focal ratio is not a continuous function of the layout</a:t>
-            </a:r>
-          </a:p>
-        </p:txBody>
-      </p:sp>
-      <p:sp>
-        <p:nvSpPr>
-          <p:cNvPr id="3" name="Rectangle 2"/>
-          <p:cNvSpPr/>
-          <p:nvPr/>
-        </p:nvSpPr>
-        <p:spPr>
-          <a:xfrm>
-            <a:off x="411480" y="1133856"/>
-            <a:ext cx="11368735" cy="20320"/>
-          </a:xfrm>
-          <a:prstGeom prst="rect">
-            <a:avLst/>
-          </a:prstGeom>
-          <a:solidFill>
-            <a:srgbClr val="B8C6D4"/>
-          </a:solidFill>
-          <a:ln>
-            <a:noFill/>
-          </a:ln>
-          <a:effectLst/>
-        </p:spPr>
-        <p:style>
-          <a:lnRef idx="1">
-            <a:schemeClr val="accent1"/>
-          </a:lnRef>
-          <a:fillRef idx="3">
-            <a:schemeClr val="accent1"/>
-          </a:fillRef>
-          <a:effectRef idx="2">
-            <a:schemeClr val="accent1"/>
-          </a:effectRef>
-          <a:fontRef idx="minor">
-            <a:schemeClr val="lt1"/>
-          </a:fontRef>
-        </p:style>
-        <p:txBody>
-          <a:bodyPr rtlCol="0" anchor="ctr"/>
-          <a:lstStyle/>
-          <a:p>
-            <a:pPr algn="ctr"/>
-          </a:p>
-        </p:txBody>
-      </p:sp>
-      <p:sp>
-        <p:nvSpPr>
-          <p:cNvPr id="4" name="TextBox 3"/>
-          <p:cNvSpPr txBox="1"/>
-          <p:nvPr/>
-        </p:nvSpPr>
-        <p:spPr>
-          <a:xfrm>
-            <a:off x="411480" y="1298448"/>
-            <a:ext cx="11368735" cy="274320"/>
-          </a:xfrm>
-          <a:prstGeom prst="rect">
-            <a:avLst/>
-          </a:prstGeom>
-          <a:noFill/>
-        </p:spPr>
-        <p:txBody>
-          <a:bodyPr wrap="square">
-            <a:spAutoFit/>
-          </a:bodyPr>
-          <a:lstStyle/>
-          <a:p>
-            <a:pPr>
-              <a:spcAft>
-                <a:spcPts val="600"/>
-              </a:spcAft>
-            </a:pPr>
-            <a:r>
-              <a:rPr sz="1200" b="0">
-                <a:solidFill>
-                  <a:srgbClr val="282828"/>
-                </a:solidFill>
-                <a:latin typeface="Arial"/>
-              </a:rPr>
-              <a:t>•  The surface-figure solve spends optical power, so the focal ratio must be read on the corrected system; a search on the tertiary radius lands in different solve basins and refuses to steer continuously (f/15.5 and f/25.7 at layouts 0.36% apart).</a:t>
-            </a:r>
-          </a:p>
-          <a:p>
-            <a:pPr>
-              <a:spcAft>
-                <a:spcPts val="600"/>
-              </a:spcAft>
-            </a:pPr>
-            <a:r>
-              <a:rPr sz="1200" b="0">
-                <a:solidFill>
-                  <a:srgbClr val="282828"/>
-                </a:solidFill>
-                <a:latin typeface="Arial"/>
-              </a:rPr>
-              <a:t>•  </a:t>
-            </a:r>
-            <a:r>
-              <a:rPr sz="1200" b="1">
-                <a:solidFill>
-                  <a:srgbClr val="282828"/>
-                </a:solidFill>
-                <a:latin typeface="Arial"/>
-              </a:rPr>
-              <a:t>The design point was chosen on wavefront</a:t>
-            </a:r>
-            <a:r>
-              <a:rPr sz="1200" b="0">
-                <a:solidFill>
-                  <a:srgbClr val="282828"/>
-                </a:solidFill>
-                <a:latin typeface="Arial"/>
-              </a:rPr>
-              <a:t>, which it meets; the slower focal ratio also puts more λ/D on the focal-plane mask, easing its fabrication.</a:t>
             </a:r>
           </a:p>
         </p:txBody>
@@ -8254,7 +8486,7 @@
                 </a:solidFill>
                 <a:latin typeface="Arial"/>
               </a:rPr>
-              <a:t>What an apodizer alone does not buy back</a:t>
+              <a:t>Packaging the longer relay</a:t>
             </a:r>
           </a:p>
           <a:p>
@@ -8270,7 +8502,7 @@
                 </a:solidFill>
                 <a:latin typeface="Arial"/>
               </a:rPr>
-              <a:t>The round-1 negative result stands</a:t>
+              <a:t>Fold side is a stability choice, not a taste choice</a:t>
             </a:r>
           </a:p>
         </p:txBody>
@@ -8353,7 +8585,7 @@
                 </a:solidFill>
                 <a:latin typeface="Arial"/>
               </a:rPr>
-              <a:t>•  Redesigning the apodizer for the segmented pupil — a linear-program optimum and an aperture-specific eigenfunction — recovered essentially nothing: the gaps scatter light no transmission profile removes.</a:t>
+              <a:t>•  A near-normal fold turns the chief by 180° − 2·AOI, and the beam direction reverses at each mirror.</a:t>
             </a:r>
           </a:p>
           <a:p>
@@ -8369,7 +8601,7 @@
                 </a:solidFill>
                 <a:latin typeface="Arial"/>
               </a:rPr>
-              <a:t>•  The optimizer's design model (a single Fourier transform) floors five times above what the engine already reaches, and the disagreement </a:t>
+              <a:t>•  </a:t>
             </a:r>
             <a:r>
               <a:rPr sz="1200" b="1">
@@ -8378,16 +8610,16 @@
                 </a:solidFill>
                 <a:latin typeface="Arial"/>
               </a:rPr>
-              <a:t>grows</a:t>
-            </a:r>
-            <a:r>
-              <a:rPr sz="1200" b="0">
-                <a:solidFill>
-                  <a:srgbClr val="282828"/>
-                </a:solidFill>
-                <a:latin typeface="Arial"/>
-              </a:rPr>
-              <a:t> the harder the optimizer is pushed — the signature of an optimizer mining its model, worth reusing as a diagnostic anywhere a design model is cheaper than the simulator it feeds.</a:t>
+              <a:t>Alternating the fold side</a:t>
+            </a:r>
+            <a:r>
+              <a:rPr sz="1200" b="0">
+                <a:solidFill>
+                  <a:srgbClr val="282828"/>
+                </a:solidFill>
+                <a:latin typeface="Arial"/>
+              </a:rPr>
+              <a:t> — fine for the five folds of the shorter round-1 relay — adds −2·AOI of net rotation per fold: over this chain's ten folds the accordion fans ~120° and walks to a 10.33 m shroud diameter.  Measured, with the element positions in the record.</a:t>
             </a:r>
           </a:p>
           <a:p>
@@ -8403,7 +8635,25 @@
                 </a:solidFill>
                 <a:latin typeface="Arial"/>
               </a:rPr>
-              <a:t>•  The round-2 answer is the deformable mirrors: measured against the engine, they dig the segmented floor 4.6e-07 → 1.9e-07 and hold it under drift.</a:t>
+              <a:t>•  </a:t>
+            </a:r>
+            <a:r>
+              <a:rPr sz="1200" b="1">
+                <a:solidFill>
+                  <a:srgbClr val="282828"/>
+                </a:solidFill>
+                <a:latin typeface="Arial"/>
+              </a:rPr>
+              <a:t>Keeping the same side every fold</a:t>
+            </a:r>
+            <a:r>
+              <a:rPr sz="1200" b="0">
+                <a:solidFill>
+                  <a:srgbClr val="282828"/>
+                </a:solidFill>
+                <a:latin typeface="Arial"/>
+              </a:rPr>
+              <a:t> ping-pongs the beam between two fixed directions and packs the chain into a leg-sized pocket: 7.451 m, identical to the primary-set envelope.  The DM-bearing back end costs nothing in shroud diameter.</a:t>
             </a:r>
           </a:p>
         </p:txBody>
@@ -8460,7 +8710,7 @@
                 </a:solidFill>
                 <a:latin typeface="Arial"/>
               </a:rPr>
-              <a:t>What is not in this model</a:t>
+              <a:t>Focal ratio: why f/25.4 and not f/12–20</a:t>
             </a:r>
           </a:p>
           <a:p>
@@ -8476,7 +8726,7 @@
                 </a:solidFill>
                 <a:latin typeface="Arial"/>
               </a:rPr>
-              <a:t>Stated, not omitted</a:t>
+              <a:t>The corrected focal ratio is not a continuous function of the layout</a:t>
             </a:r>
           </a:p>
         </p:txBody>
@@ -8559,6 +8809,22 @@
                 </a:solidFill>
                 <a:latin typeface="Arial"/>
               </a:rPr>
+              <a:t>•  The surface-figure solve spends optical power, so the focal ratio must be read on the corrected system; a search on the tertiary radius lands in different solve basins and refuses to steer continuously (f/15.5 and f/25.7 at layouts 0.36% apart).</a:t>
+            </a:r>
+          </a:p>
+          <a:p>
+            <a:pPr>
+              <a:spcAft>
+                <a:spcPts val="600"/>
+              </a:spcAft>
+            </a:pPr>
+            <a:r>
+              <a:rPr sz="1200" b="0">
+                <a:solidFill>
+                  <a:srgbClr val="282828"/>
+                </a:solidFill>
+                <a:latin typeface="Arial"/>
+              </a:rPr>
               <a:t>•  </a:t>
             </a:r>
             <a:r>
@@ -8568,118 +8834,16 @@
                 </a:solidFill>
                 <a:latin typeface="Arial"/>
               </a:rPr>
-              <a:t>The coronagraph masks are clear-pupil designs.</a:t>
-            </a:r>
-            <a:r>
-              <a:rPr sz="1200" b="0">
-                <a:solidFill>
-                  <a:srgbClr val="282828"/>
-                </a:solidFill>
-                <a:latin typeface="Arial"/>
-              </a:rPr>
-              <a:t>  Co-optimising apodizer, occulter and Lyot for the segmented aperture is known, separate work; the open-loop 1298× is the size of that prize.</a:t>
-            </a:r>
-          </a:p>
-          <a:p>
-            <a:pPr>
-              <a:spcAft>
-                <a:spcPts val="600"/>
-              </a:spcAft>
-            </a:pPr>
-            <a:r>
-              <a:rPr sz="1200" b="0">
-                <a:solidFill>
-                  <a:srgbClr val="282828"/>
-                </a:solidFill>
-                <a:latin typeface="Arial"/>
-              </a:rPr>
-              <a:t>•  </a:t>
-            </a:r>
-            <a:r>
-              <a:rPr sz="1200" b="1">
-                <a:solidFill>
-                  <a:srgbClr val="282828"/>
-                </a:solidFill>
-                <a:latin typeface="Arial"/>
-              </a:rPr>
-              <a:t>Monochromatic, at 500 nm.</a:t>
-            </a:r>
-            <a:r>
-              <a:rPr sz="1200" b="0">
-                <a:solidFill>
-                  <a:srgbClr val="282828"/>
-                </a:solidFill>
-                <a:latin typeface="Arial"/>
-              </a:rPr>
-              <a:t>  The bandwidth and polarization layers exist on the testbed substrate and are configuration away, not new machinery.</a:t>
-            </a:r>
-          </a:p>
-          <a:p>
-            <a:pPr>
-              <a:spcAft>
-                <a:spcPts val="600"/>
-              </a:spcAft>
-            </a:pPr>
-            <a:r>
-              <a:rPr sz="1200" b="0">
-                <a:solidFill>
-                  <a:srgbClr val="282828"/>
-                </a:solidFill>
-                <a:latin typeface="Arial"/>
-              </a:rPr>
-              <a:t>•  </a:t>
-            </a:r>
-            <a:r>
-              <a:rPr sz="1200" b="1">
-                <a:solidFill>
-                  <a:srgbClr val="282828"/>
-                </a:solidFill>
-                <a:latin typeface="Arial"/>
-              </a:rPr>
-              <a:t>The metrology measurement is simulated from its validated linear model</a:t>
-            </a:r>
-            <a:r>
-              <a:rPr sz="1200" b="0">
-                <a:solidFill>
-                  <a:srgbClr val="282828"/>
-                </a:solidFill>
-                <a:latin typeface="Arial"/>
-              </a:rPr>
-              <a:t> plus noise, not a second engine trace of the truss; the engine holds the truss points rigid, so the model is the only figure source either way.</a:t>
-            </a:r>
-          </a:p>
-          <a:p>
-            <a:pPr>
-              <a:spcAft>
-                <a:spcPts val="600"/>
-              </a:spcAft>
-            </a:pPr>
-            <a:r>
-              <a:rPr sz="1200" b="0">
-                <a:solidFill>
-                  <a:srgbClr val="282828"/>
-                </a:solidFill>
-                <a:latin typeface="Arial"/>
-              </a:rPr>
-              <a:t>•  </a:t>
-            </a:r>
-            <a:r>
-              <a:rPr sz="1200" b="1">
-                <a:solidFill>
-                  <a:srgbClr val="282828"/>
-                </a:solidFill>
-                <a:latin typeface="Arial"/>
-              </a:rPr>
-              <a:t>DM spacing</a:t>
-            </a:r>
-            <a:r>
-              <a:rPr sz="1200" b="0">
-                <a:solidFill>
-                  <a:srgbClr val="282828"/>
-                </a:solidFill>
-                <a:latin typeface="Arial"/>
-              </a:rPr>
-              <a:t> (47 mm pupil, 0.15 m apart) limits amplitude-speckle authority; the testbed's wider spacing is the knob, and re-running the chain at another spacing is parameter work.</a:t>
+              <a:t>The design point was chosen on wavefront</a:t>
+            </a:r>
+            <a:r>
+              <a:rPr sz="1200" b="0">
+                <a:solidFill>
+                  <a:srgbClr val="282828"/>
+                </a:solidFill>
+                <a:latin typeface="Arial"/>
+              </a:rPr>
+              <a:t>, which it meets; the slower focal ratio also puts more λ/D on the focal-plane mask, easing its fabrication.</a:t>
             </a:r>
           </a:p>
         </p:txBody>
@@ -8693,6 +8857,488 @@
 </file>
 
 <file path=ppt/slides/slide25.xml><?xml version="1.0" encoding="utf-8"?>
+<p:sld xmlns:a="http://schemas.openxmlformats.org/drawingml/2006/main" xmlns:p="http://schemas.openxmlformats.org/presentationml/2006/main" xmlns:r="http://schemas.openxmlformats.org/officeDocument/2006/relationships">
+  <p:cSld>
+    <p:spTree>
+      <p:nvGrpSpPr>
+        <p:cNvPr id="1" name=""/>
+        <p:cNvGrpSpPr/>
+        <p:nvPr/>
+      </p:nvGrpSpPr>
+      <p:grpSpPr/>
+      <p:sp>
+        <p:nvSpPr>
+          <p:cNvPr id="2" name="TextBox 1"/>
+          <p:cNvSpPr txBox="1"/>
+          <p:nvPr/>
+        </p:nvSpPr>
+        <p:spPr>
+          <a:xfrm>
+            <a:off x="411480" y="201168"/>
+            <a:ext cx="11368735" cy="914400"/>
+          </a:xfrm>
+          <a:prstGeom prst="rect">
+            <a:avLst/>
+          </a:prstGeom>
+          <a:noFill/>
+        </p:spPr>
+        <p:txBody>
+          <a:bodyPr wrap="square">
+            <a:spAutoFit/>
+          </a:bodyPr>
+          <a:lstStyle/>
+          <a:p>
+            <a:pPr>
+              <a:spcAft>
+                <a:spcPts val="400"/>
+              </a:spcAft>
+            </a:pPr>
+            <a:r>
+              <a:rPr sz="2400" b="1">
+                <a:solidFill>
+                  <a:srgbClr val="1F4E79"/>
+                </a:solidFill>
+                <a:latin typeface="Arial"/>
+              </a:rPr>
+              <a:t>What an apodizer alone does not buy back</a:t>
+            </a:r>
+          </a:p>
+          <a:p>
+            <a:pPr>
+              <a:spcAft>
+                <a:spcPts val="0"/>
+              </a:spcAft>
+            </a:pPr>
+            <a:r>
+              <a:rPr sz="1250" b="0">
+                <a:solidFill>
+                  <a:srgbClr val="6E6E6E"/>
+                </a:solidFill>
+                <a:latin typeface="Arial"/>
+              </a:rPr>
+              <a:t>The round-1 negative result stands</a:t>
+            </a:r>
+          </a:p>
+        </p:txBody>
+      </p:sp>
+      <p:sp>
+        <p:nvSpPr>
+          <p:cNvPr id="3" name="Rectangle 2"/>
+          <p:cNvSpPr/>
+          <p:nvPr/>
+        </p:nvSpPr>
+        <p:spPr>
+          <a:xfrm>
+            <a:off x="411480" y="1133856"/>
+            <a:ext cx="11368735" cy="20320"/>
+          </a:xfrm>
+          <a:prstGeom prst="rect">
+            <a:avLst/>
+          </a:prstGeom>
+          <a:solidFill>
+            <a:srgbClr val="B8C6D4"/>
+          </a:solidFill>
+          <a:ln>
+            <a:noFill/>
+          </a:ln>
+          <a:effectLst/>
+        </p:spPr>
+        <p:style>
+          <a:lnRef idx="1">
+            <a:schemeClr val="accent1"/>
+          </a:lnRef>
+          <a:fillRef idx="3">
+            <a:schemeClr val="accent1"/>
+          </a:fillRef>
+          <a:effectRef idx="2">
+            <a:schemeClr val="accent1"/>
+          </a:effectRef>
+          <a:fontRef idx="minor">
+            <a:schemeClr val="lt1"/>
+          </a:fontRef>
+        </p:style>
+        <p:txBody>
+          <a:bodyPr rtlCol="0" anchor="ctr"/>
+          <a:lstStyle/>
+          <a:p>
+            <a:pPr algn="ctr"/>
+          </a:p>
+        </p:txBody>
+      </p:sp>
+      <p:sp>
+        <p:nvSpPr>
+          <p:cNvPr id="4" name="TextBox 3"/>
+          <p:cNvSpPr txBox="1"/>
+          <p:nvPr/>
+        </p:nvSpPr>
+        <p:spPr>
+          <a:xfrm>
+            <a:off x="411480" y="1298448"/>
+            <a:ext cx="11368735" cy="274320"/>
+          </a:xfrm>
+          <a:prstGeom prst="rect">
+            <a:avLst/>
+          </a:prstGeom>
+          <a:noFill/>
+        </p:spPr>
+        <p:txBody>
+          <a:bodyPr wrap="square">
+            <a:spAutoFit/>
+          </a:bodyPr>
+          <a:lstStyle/>
+          <a:p>
+            <a:pPr>
+              <a:spcAft>
+                <a:spcPts val="600"/>
+              </a:spcAft>
+            </a:pPr>
+            <a:r>
+              <a:rPr sz="1200" b="0">
+                <a:solidFill>
+                  <a:srgbClr val="282828"/>
+                </a:solidFill>
+                <a:latin typeface="Arial"/>
+              </a:rPr>
+              <a:t>•  Redesigning the apodizer for the segmented pupil — a linear-program optimum and an aperture-specific eigenfunction — recovered essentially nothing: the gaps scatter light no transmission profile removes.</a:t>
+            </a:r>
+          </a:p>
+          <a:p>
+            <a:pPr>
+              <a:spcAft>
+                <a:spcPts val="600"/>
+              </a:spcAft>
+            </a:pPr>
+            <a:r>
+              <a:rPr sz="1200" b="0">
+                <a:solidFill>
+                  <a:srgbClr val="282828"/>
+                </a:solidFill>
+                <a:latin typeface="Arial"/>
+              </a:rPr>
+              <a:t>•  The optimizer's design model (a single Fourier transform) floors five times above what the engine already reaches, and the disagreement </a:t>
+            </a:r>
+            <a:r>
+              <a:rPr sz="1200" b="1">
+                <a:solidFill>
+                  <a:srgbClr val="282828"/>
+                </a:solidFill>
+                <a:latin typeface="Arial"/>
+              </a:rPr>
+              <a:t>grows</a:t>
+            </a:r>
+            <a:r>
+              <a:rPr sz="1200" b="0">
+                <a:solidFill>
+                  <a:srgbClr val="282828"/>
+                </a:solidFill>
+                <a:latin typeface="Arial"/>
+              </a:rPr>
+              <a:t> the harder the optimizer is pushed — the signature of an optimizer mining its model, worth reusing as a diagnostic anywhere a design model is cheaper than the simulator it feeds.</a:t>
+            </a:r>
+          </a:p>
+          <a:p>
+            <a:pPr>
+              <a:spcAft>
+                <a:spcPts val="600"/>
+              </a:spcAft>
+            </a:pPr>
+            <a:r>
+              <a:rPr sz="1200" b="0">
+                <a:solidFill>
+                  <a:srgbClr val="282828"/>
+                </a:solidFill>
+                <a:latin typeface="Arial"/>
+              </a:rPr>
+              <a:t>•  The round-2 answer is the deformable mirrors: measured against the engine, they dig the segmented floor 4.6e-07 → 1.9e-07 and hold it under drift.</a:t>
+            </a:r>
+          </a:p>
+        </p:txBody>
+      </p:sp>
+    </p:spTree>
+  </p:cSld>
+  <p:clrMapOvr>
+    <a:masterClrMapping/>
+  </p:clrMapOvr>
+</p:sld>
+</file>
+
+<file path=ppt/slides/slide26.xml><?xml version="1.0" encoding="utf-8"?>
+<p:sld xmlns:a="http://schemas.openxmlformats.org/drawingml/2006/main" xmlns:p="http://schemas.openxmlformats.org/presentationml/2006/main" xmlns:r="http://schemas.openxmlformats.org/officeDocument/2006/relationships">
+  <p:cSld>
+    <p:spTree>
+      <p:nvGrpSpPr>
+        <p:cNvPr id="1" name=""/>
+        <p:cNvGrpSpPr/>
+        <p:nvPr/>
+      </p:nvGrpSpPr>
+      <p:grpSpPr/>
+      <p:sp>
+        <p:nvSpPr>
+          <p:cNvPr id="2" name="TextBox 1"/>
+          <p:cNvSpPr txBox="1"/>
+          <p:nvPr/>
+        </p:nvSpPr>
+        <p:spPr>
+          <a:xfrm>
+            <a:off x="411480" y="201168"/>
+            <a:ext cx="11368735" cy="914400"/>
+          </a:xfrm>
+          <a:prstGeom prst="rect">
+            <a:avLst/>
+          </a:prstGeom>
+          <a:noFill/>
+        </p:spPr>
+        <p:txBody>
+          <a:bodyPr wrap="square">
+            <a:spAutoFit/>
+          </a:bodyPr>
+          <a:lstStyle/>
+          <a:p>
+            <a:pPr>
+              <a:spcAft>
+                <a:spcPts val="400"/>
+              </a:spcAft>
+            </a:pPr>
+            <a:r>
+              <a:rPr sz="2400" b="1">
+                <a:solidFill>
+                  <a:srgbClr val="1F4E79"/>
+                </a:solidFill>
+                <a:latin typeface="Arial"/>
+              </a:rPr>
+              <a:t>What is not in this model</a:t>
+            </a:r>
+          </a:p>
+          <a:p>
+            <a:pPr>
+              <a:spcAft>
+                <a:spcPts val="0"/>
+              </a:spcAft>
+            </a:pPr>
+            <a:r>
+              <a:rPr sz="1250" b="0">
+                <a:solidFill>
+                  <a:srgbClr val="6E6E6E"/>
+                </a:solidFill>
+                <a:latin typeface="Arial"/>
+              </a:rPr>
+              <a:t>Stated, not omitted</a:t>
+            </a:r>
+          </a:p>
+        </p:txBody>
+      </p:sp>
+      <p:sp>
+        <p:nvSpPr>
+          <p:cNvPr id="3" name="Rectangle 2"/>
+          <p:cNvSpPr/>
+          <p:nvPr/>
+        </p:nvSpPr>
+        <p:spPr>
+          <a:xfrm>
+            <a:off x="411480" y="1133856"/>
+            <a:ext cx="11368735" cy="20320"/>
+          </a:xfrm>
+          <a:prstGeom prst="rect">
+            <a:avLst/>
+          </a:prstGeom>
+          <a:solidFill>
+            <a:srgbClr val="B8C6D4"/>
+          </a:solidFill>
+          <a:ln>
+            <a:noFill/>
+          </a:ln>
+          <a:effectLst/>
+        </p:spPr>
+        <p:style>
+          <a:lnRef idx="1">
+            <a:schemeClr val="accent1"/>
+          </a:lnRef>
+          <a:fillRef idx="3">
+            <a:schemeClr val="accent1"/>
+          </a:fillRef>
+          <a:effectRef idx="2">
+            <a:schemeClr val="accent1"/>
+          </a:effectRef>
+          <a:fontRef idx="minor">
+            <a:schemeClr val="lt1"/>
+          </a:fontRef>
+        </p:style>
+        <p:txBody>
+          <a:bodyPr rtlCol="0" anchor="ctr"/>
+          <a:lstStyle/>
+          <a:p>
+            <a:pPr algn="ctr"/>
+          </a:p>
+        </p:txBody>
+      </p:sp>
+      <p:sp>
+        <p:nvSpPr>
+          <p:cNvPr id="4" name="TextBox 3"/>
+          <p:cNvSpPr txBox="1"/>
+          <p:nvPr/>
+        </p:nvSpPr>
+        <p:spPr>
+          <a:xfrm>
+            <a:off x="411480" y="1298448"/>
+            <a:ext cx="11368735" cy="274320"/>
+          </a:xfrm>
+          <a:prstGeom prst="rect">
+            <a:avLst/>
+          </a:prstGeom>
+          <a:noFill/>
+        </p:spPr>
+        <p:txBody>
+          <a:bodyPr wrap="square">
+            <a:spAutoFit/>
+          </a:bodyPr>
+          <a:lstStyle/>
+          <a:p>
+            <a:pPr>
+              <a:spcAft>
+                <a:spcPts val="600"/>
+              </a:spcAft>
+            </a:pPr>
+            <a:r>
+              <a:rPr sz="1200" b="0">
+                <a:solidFill>
+                  <a:srgbClr val="282828"/>
+                </a:solidFill>
+                <a:latin typeface="Arial"/>
+              </a:rPr>
+              <a:t>•  </a:t>
+            </a:r>
+            <a:r>
+              <a:rPr sz="1200" b="1">
+                <a:solidFill>
+                  <a:srgbClr val="282828"/>
+                </a:solidFill>
+                <a:latin typeface="Arial"/>
+              </a:rPr>
+              <a:t>The coronagraph masks are clear-pupil designs.</a:t>
+            </a:r>
+            <a:r>
+              <a:rPr sz="1200" b="0">
+                <a:solidFill>
+                  <a:srgbClr val="282828"/>
+                </a:solidFill>
+                <a:latin typeface="Arial"/>
+              </a:rPr>
+              <a:t>  Co-optimising apodizer, occulter and Lyot for the segmented aperture is known, separate work; the open-loop 1298× is the size of that prize.</a:t>
+            </a:r>
+          </a:p>
+          <a:p>
+            <a:pPr>
+              <a:spcAft>
+                <a:spcPts val="600"/>
+              </a:spcAft>
+            </a:pPr>
+            <a:r>
+              <a:rPr sz="1200" b="0">
+                <a:solidFill>
+                  <a:srgbClr val="282828"/>
+                </a:solidFill>
+                <a:latin typeface="Arial"/>
+              </a:rPr>
+              <a:t>•  </a:t>
+            </a:r>
+            <a:r>
+              <a:rPr sz="1200" b="1">
+                <a:solidFill>
+                  <a:srgbClr val="282828"/>
+                </a:solidFill>
+                <a:latin typeface="Arial"/>
+              </a:rPr>
+              <a:t>Monochromatic, at 500 nm.</a:t>
+            </a:r>
+            <a:r>
+              <a:rPr sz="1200" b="0">
+                <a:solidFill>
+                  <a:srgbClr val="282828"/>
+                </a:solidFill>
+                <a:latin typeface="Arial"/>
+              </a:rPr>
+              <a:t>  The bandwidth and polarization layers exist on the testbed substrate and are configuration away, not new machinery.</a:t>
+            </a:r>
+          </a:p>
+          <a:p>
+            <a:pPr>
+              <a:spcAft>
+                <a:spcPts val="600"/>
+              </a:spcAft>
+            </a:pPr>
+            <a:r>
+              <a:rPr sz="1200" b="0">
+                <a:solidFill>
+                  <a:srgbClr val="282828"/>
+                </a:solidFill>
+                <a:latin typeface="Arial"/>
+              </a:rPr>
+              <a:t>•  </a:t>
+            </a:r>
+            <a:r>
+              <a:rPr sz="1200" b="1">
+                <a:solidFill>
+                  <a:srgbClr val="282828"/>
+                </a:solidFill>
+                <a:latin typeface="Arial"/>
+              </a:rPr>
+              <a:t>The metrology measurement is simulated from its validated linear model</a:t>
+            </a:r>
+            <a:r>
+              <a:rPr sz="1200" b="0">
+                <a:solidFill>
+                  <a:srgbClr val="282828"/>
+                </a:solidFill>
+                <a:latin typeface="Arial"/>
+              </a:rPr>
+              <a:t> plus noise, not a second engine trace of the truss; the engine holds the truss points rigid, so the model is the only figure source either way.</a:t>
+            </a:r>
+          </a:p>
+          <a:p>
+            <a:pPr>
+              <a:spcAft>
+                <a:spcPts val="600"/>
+              </a:spcAft>
+            </a:pPr>
+            <a:r>
+              <a:rPr sz="1200" b="0">
+                <a:solidFill>
+                  <a:srgbClr val="282828"/>
+                </a:solidFill>
+                <a:latin typeface="Arial"/>
+              </a:rPr>
+              <a:t>•  </a:t>
+            </a:r>
+            <a:r>
+              <a:rPr sz="1200" b="1">
+                <a:solidFill>
+                  <a:srgbClr val="282828"/>
+                </a:solidFill>
+                <a:latin typeface="Arial"/>
+              </a:rPr>
+              <a:t>DM spacing</a:t>
+            </a:r>
+            <a:r>
+              <a:rPr sz="1200" b="0">
+                <a:solidFill>
+                  <a:srgbClr val="282828"/>
+                </a:solidFill>
+                <a:latin typeface="Arial"/>
+              </a:rPr>
+              <a:t> (47 mm pupil, 0.15 m apart) limits amplitude-speckle authority; the testbed's wider spacing is the knob, and re-running the chain at another spacing is parameter work.</a:t>
+            </a:r>
+          </a:p>
+        </p:txBody>
+      </p:sp>
+    </p:spTree>
+  </p:cSld>
+  <p:clrMapOvr>
+    <a:masterClrMapping/>
+  </p:clrMapOvr>
+</p:sld>
+</file>
+
+<file path=ppt/slides/slide27.xml><?xml version="1.0" encoding="utf-8"?>
 <p:sld xmlns:a="http://schemas.openxmlformats.org/drawingml/2006/main" xmlns:p="http://schemas.openxmlformats.org/presentationml/2006/main" xmlns:r="http://schemas.openxmlformats.org/officeDocument/2006/relationships">
   <p:cSld>
     <p:spTree>

</xml_diff>

<commit_message>
e2e6m CF3d: horizontal stations strip + campaign-deck slides (ladder + inside-the-dig)
cf3d_stations now caches fields to .mat; cf3d_stations_fig renders
tall + the 2x7 wide slide strip.  cf3d() records fn (loud-on-miss,
last-DONE-line semantics); deck gains 'The restart ladder' and
'Inside the dig, station by station' at 29 slides.

Co-Authored-By: Claude Fable 5 <noreply@anthropic.com>
</commit_message>
<xml_diff>
--- a/mmacos/templates/80_end_to_end/e2e6m_r2/deck_e2e6m_r2.pptx
+++ b/mmacos/templates/80_end_to_end/e2e6m_r2/deck_e2e6m_r2.pptx
@@ -32,6 +32,8 @@
     <p:sldId id="280" r:id="rId31"/>
     <p:sldId id="281" r:id="rId32"/>
     <p:sldId id="282" r:id="rId33"/>
+    <p:sldId id="283" r:id="rId34"/>
+    <p:sldId id="284" r:id="rId35"/>
   </p:sldIdLst>
   <p:sldSz cx="12191695" cy="6858000" type="screen4x3"/>
   <p:notesSz cx="6858000" cy="9144000"/>
@@ -6308,7 +6310,7 @@
                 </a:solidFill>
                 <a:latin typeface="Arial"/>
               </a:rPr>
-              <a:t>What this demonstrates</a:t>
+              <a:t>The restart ladder</a:t>
             </a:r>
           </a:p>
           <a:p>
@@ -6324,7 +6326,7 @@
                 </a:solidFill>
                 <a:latin typeface="Arial"/>
               </a:rPr>
-              <a:t>One model, from surface figure to a held dark zone</a:t>
+              <a:t>The controller was the bottleneck: 1.2e-06 → 1.13e-09 at d = 1.10 m, with the substrate still pricing 3.5e-11</a:t>
             </a:r>
           </a:p>
         </p:txBody>
@@ -6382,7 +6384,7 @@
         <p:spPr>
           <a:xfrm>
             <a:off x="411480" y="1298448"/>
-            <a:ext cx="11368735" cy="274320"/>
+            <a:ext cx="5806440" cy="274320"/>
           </a:xfrm>
           <a:prstGeom prst="rect">
             <a:avLst/>
@@ -6416,16 +6418,16 @@
                 </a:solidFill>
                 <a:latin typeface="Arial"/>
               </a:rPr>
-              <a:t>A design becomes an instrument becomes an error budget becomes a controlled observatory</a:t>
-            </a:r>
-            <a:r>
-              <a:rPr sz="1200" b="0">
-                <a:solidFill>
-                  <a:srgbClr val="282828"/>
-                </a:solidFill>
-                <a:latin typeface="Arial"/>
-              </a:rPr>
-              <a:t>, without leaving the model or re-entering the geometry anywhere.</a:t>
+              <a:t>The recipe (rinse and repeat):</a:t>
+            </a:r>
+            <a:r>
+              <a:rPr sz="1200" b="0">
+                <a:solidFill>
+                  <a:srgbClr val="282828"/>
+                </a:solidFill>
+                <a:latin typeface="Arial"/>
+              </a:rPr>
+              <a:t> EFC to a floor, relinearize about the dug state, restart at that floor.  10 digging rounds over 4.6 h unattended; 3 stall rounds then prove the plateau — no accepted step at any Tikhonov α down to 1e-10, and two independent G measurements at the unchanged state agree to four digits.</a:t>
             </a:r>
           </a:p>
           <a:p>
@@ -6450,16 +6452,16 @@
                 </a:solidFill>
                 <a:latin typeface="Arial"/>
               </a:rPr>
-              <a:t>The gap penalty is measured, not assumed</a:t>
-            </a:r>
-            <a:r>
-              <a:rPr sz="1200" b="0">
-                <a:solidFill>
-                  <a:srgbClr val="282828"/>
-                </a:solidFill>
-                <a:latin typeface="Arial"/>
-              </a:rPr>
-              <a:t> — 1298× open loop — and the control loop that answers it is measured too: 1.7e-06 open against 2.5e-07 closed at the end of the soak.</a:t>
+              <a:t>What it removed:</a:t>
+            </a:r>
+            <a:r>
+              <a:rPr sz="1200" b="0">
+                <a:solidFill>
+                  <a:srgbClr val="282828"/>
+                </a:solidFill>
+                <a:latin typeface="Arial"/>
+              </a:rPr>
+              <a:t> the single-linearization stall at 9.0e-07 (the spacing sweep's d = 1.10 m entry) — four decades above the linear bound at this spacing.</a:t>
             </a:r>
           </a:p>
           <a:p>
@@ -6484,50 +6486,79 @@
                 </a:solidFill>
                 <a:latin typeface="Arial"/>
               </a:rPr>
-              <a:t>Every model-vs-engine comparison closes</a:t>
-            </a:r>
-            <a:r>
-              <a:rPr sz="1200" b="0">
-                <a:solidFill>
-                  <a:srgbClr val="282828"/>
-                </a:solidFill>
-                <a:latin typeface="Arial"/>
-              </a:rPr>
-              <a:t> — worst 0.0035 across segments, DMs and relay optics — because the comparison is made at the surface the model lives on.  Where a build disagreed, the deck says why and what fixed it.</a:t>
-            </a:r>
-          </a:p>
-          <a:p>
-            <a:pPr>
-              <a:spcAft>
-                <a:spcPts val="600"/>
-              </a:spcAft>
-            </a:pPr>
-            <a:r>
-              <a:rPr sz="1200" b="0">
-                <a:solidFill>
-                  <a:srgbClr val="282828"/>
-                </a:solidFill>
-                <a:latin typeface="Arial"/>
-              </a:rPr>
-              <a:t>•  </a:t>
-            </a:r>
-            <a:r>
-              <a:rPr sz="1200" b="1">
-                <a:solidFill>
-                  <a:srgbClr val="282828"/>
-                </a:solidFill>
-                <a:latin typeface="Arial"/>
-              </a:rPr>
-              <a:t>All of it is committed</a:t>
-            </a:r>
-            <a:r>
-              <a:rPr sz="1200" b="0">
-                <a:solidFill>
-                  <a:srgbClr val="282828"/>
-                </a:solidFill>
-                <a:latin typeface="Arial"/>
-              </a:rPr>
-              <a:t>: prescriptions, runners, reports, and this deck's numbers are one git clone away.</a:t>
+              <a:t>What remains, priced:</a:t>
+            </a:r>
+            <a:r>
+              <a:rPr sz="1200" b="0">
+                <a:solidFill>
+                  <a:srgbClr val="282828"/>
+                </a:solidFill>
+                <a:latin typeface="Arial"/>
+              </a:rPr>
+              <a:t> la(G) holds 2.0e-11–3.8e-11 at every dug state; the plateau at 1.13e-09 is the monotone full-Tikhonov step rule — the measured case for FALCO-grade step machinery.  Strokes end at 33 nm rms of the 50 nm bound.</a:t>
+            </a:r>
+          </a:p>
+        </p:txBody>
+      </p:sp>
+      <p:pic>
+        <p:nvPicPr>
+          <p:cNvPr id="5" name="Picture 4" descr="cf3d_dig.png"/>
+          <p:cNvPicPr>
+            <a:picLocks noChangeAspect="1"/>
+          </p:cNvPicPr>
+          <p:nvPr/>
+        </p:nvPicPr>
+        <p:blipFill>
+          <a:blip r:embed="rId2"/>
+          <a:stretch>
+            <a:fillRect/>
+          </a:stretch>
+        </p:blipFill>
+        <p:spPr>
+          <a:xfrm>
+            <a:off x="6461474" y="1298448"/>
+            <a:ext cx="5273611" cy="3555492"/>
+          </a:xfrm>
+          <a:prstGeom prst="rect">
+            <a:avLst/>
+          </a:prstGeom>
+        </p:spPr>
+      </p:pic>
+      <p:sp>
+        <p:nvSpPr>
+          <p:cNvPr id="6" name="TextBox 5"/>
+          <p:cNvSpPr txBox="1"/>
+          <p:nvPr/>
+        </p:nvSpPr>
+        <p:spPr>
+          <a:xfrm>
+            <a:off x="6400800" y="4872228"/>
+            <a:ext cx="5394960" cy="559307"/>
+          </a:xfrm>
+          <a:prstGeom prst="rect">
+            <a:avLst/>
+          </a:prstGeom>
+          <a:noFill/>
+        </p:spPr>
+        <p:txBody>
+          <a:bodyPr wrap="square">
+            <a:spAutoFit/>
+          </a:bodyPr>
+          <a:lstStyle/>
+          <a:p>
+            <a:pPr algn="ctr">
+              <a:spcAft>
+                <a:spcPts val="0"/>
+              </a:spcAft>
+            </a:pPr>
+            <a:r>
+              <a:rPr sz="1000" b="0">
+                <a:solidFill>
+                  <a:srgbClr val="6E6E6E"/>
+                </a:solidFill>
+                <a:latin typeface="Arial"/>
+              </a:rPr>
+              <a:t>The ladder: achieved floor by restart round against the linear-achievable substrate re-measured at every dug state.  The early linear claims (rounds 1–2) are flat-state optimism; they settle once the linearization is honest.</a:t>
             </a:r>
           </a:p>
         </p:txBody>
@@ -6584,7 +6615,23 @@
                 </a:solidFill>
                 <a:latin typeface="Arial"/>
               </a:rPr>
-              <a:t>Backup Slides</a:t>
+              <a:t>Inside the dig, station by station</a:t>
+            </a:r>
+          </a:p>
+          <a:p>
+            <a:pPr>
+              <a:spcAft>
+                <a:spcPts val="0"/>
+              </a:spcAft>
+            </a:pPr>
+            <a:r>
+              <a:rPr sz="1250" b="0">
+                <a:solidFill>
+                  <a:srgbClr val="6E6E6E"/>
+                </a:solidFill>
+                <a:latin typeface="Arial"/>
+              </a:rPr>
+              <a:t>The controller does the gap work: the DM commands imprint the hex-gap lattice</a:t>
             </a:r>
           </a:p>
         </p:txBody>
@@ -6597,7 +6644,7 @@
         </p:nvSpPr>
         <p:spPr>
           <a:xfrm>
-            <a:off x="411480" y="914400"/>
+            <a:off x="411480" y="1133856"/>
             <a:ext cx="11368735" cy="20320"/>
           </a:xfrm>
           <a:prstGeom prst="rect">
@@ -6630,6 +6677,223 @@
           <a:lstStyle/>
           <a:p>
             <a:pPr algn="ctr"/>
+          </a:p>
+        </p:txBody>
+      </p:sp>
+      <p:pic>
+        <p:nvPicPr>
+          <p:cNvPr id="4" name="Picture 3" descr="cf3d_stations_wide.png"/>
+          <p:cNvPicPr>
+            <a:picLocks noChangeAspect="1"/>
+          </p:cNvPicPr>
+          <p:nvPr/>
+        </p:nvPicPr>
+        <p:blipFill>
+          <a:blip r:embed="rId2"/>
+          <a:stretch>
+            <a:fillRect/>
+          </a:stretch>
+        </p:blipFill>
+        <p:spPr>
+          <a:xfrm>
+            <a:off x="1728779" y="1298448"/>
+            <a:ext cx="8734135" cy="2166112"/>
+          </a:xfrm>
+          <a:prstGeom prst="rect">
+            <a:avLst/>
+          </a:prstGeom>
+        </p:spPr>
+      </p:pic>
+      <p:sp>
+        <p:nvSpPr>
+          <p:cNvPr id="5" name="TextBox 4"/>
+          <p:cNvSpPr txBox="1"/>
+          <p:nvPr/>
+        </p:nvSpPr>
+        <p:spPr>
+          <a:xfrm>
+            <a:off x="411480" y="3482848"/>
+            <a:ext cx="11368735" cy="394208"/>
+          </a:xfrm>
+          <a:prstGeom prst="rect">
+            <a:avLst/>
+          </a:prstGeom>
+          <a:noFill/>
+        </p:spPr>
+        <p:txBody>
+          <a:bodyPr wrap="square">
+            <a:spAutoFit/>
+          </a:bodyPr>
+          <a:lstStyle/>
+          <a:p>
+            <a:pPr algn="ctr">
+              <a:spcAft>
+                <a:spcPts val="0"/>
+              </a:spcAft>
+            </a:pPr>
+            <a:r>
+              <a:rPr sz="1000" b="0">
+                <a:solidFill>
+                  <a:srgbClr val="6E6E6E"/>
+                </a:solidFill>
+                <a:latin typeface="Arial"/>
+              </a:rPr>
+              <a:t>Seven planes, DMs flat against the dug state: pupil, apodizer, FPM before/after the occulter, Lyot before/after the stop, science-plane contrast.  The in-walk dark-zone means reproduce the scored record exactly (1.22e-06 / 1.13e-09).</a:t>
+            </a:r>
+          </a:p>
+        </p:txBody>
+      </p:sp>
+      <p:sp>
+        <p:nvSpPr>
+          <p:cNvPr id="6" name="TextBox 5"/>
+          <p:cNvSpPr txBox="1"/>
+          <p:nvPr/>
+        </p:nvSpPr>
+        <p:spPr>
+          <a:xfrm>
+            <a:off x="411480" y="3913632"/>
+            <a:ext cx="11368735" cy="274320"/>
+          </a:xfrm>
+          <a:prstGeom prst="rect">
+            <a:avLst/>
+          </a:prstGeom>
+          <a:noFill/>
+        </p:spPr>
+        <p:txBody>
+          <a:bodyPr wrap="square">
+            <a:spAutoFit/>
+          </a:bodyPr>
+          <a:lstStyle/>
+          <a:p>
+            <a:pPr>
+              <a:spcAft>
+                <a:spcPts val="600"/>
+              </a:spcAft>
+            </a:pPr>
+            <a:r>
+              <a:rPr sz="1200" b="0">
+                <a:solidFill>
+                  <a:srgbClr val="282828"/>
+                </a:solidFill>
+                <a:latin typeface="Arial"/>
+              </a:rPr>
+              <a:t>•  </a:t>
+            </a:r>
+            <a:r>
+              <a:rPr sz="1200" b="1">
+                <a:solidFill>
+                  <a:srgbClr val="282828"/>
+                </a:solidFill>
+                <a:latin typeface="Arial"/>
+              </a:rPr>
+              <a:t>Reading the strip:</a:t>
+            </a:r>
+            <a:r>
+              <a:rPr sz="1200" b="0">
+                <a:solidFill>
+                  <a:srgbClr val="282828"/>
+                </a:solidFill>
+                <a:latin typeface="Arial"/>
+              </a:rPr>
+              <a:t> the flat row's segment-lattice speckle becomes the dug row's sculpted field; the science panel shows the full 3–15 λ/D annular dark hole carved to the 1e-9 floor.</a:t>
+            </a:r>
+          </a:p>
+          <a:p>
+            <a:pPr>
+              <a:spcAft>
+                <a:spcPts val="600"/>
+              </a:spcAft>
+            </a:pPr>
+            <a:r>
+              <a:rPr sz="1200" b="0">
+                <a:solidFill>
+                  <a:srgbClr val="282828"/>
+                </a:solidFill>
+                <a:latin typeface="Arial"/>
+              </a:rPr>
+              <a:t>•  </a:t>
+            </a:r>
+            <a:r>
+              <a:rPr sz="1200" b="1">
+                <a:solidFill>
+                  <a:srgbClr val="282828"/>
+                </a:solidFill>
+                <a:latin typeface="Arial"/>
+              </a:rPr>
+              <a:t>Two measured readables:</a:t>
+            </a:r>
+            <a:r>
+              <a:rPr sz="1200" b="0">
+                <a:solidFill>
+                  <a:srgbClr val="282828"/>
+                </a:solidFill>
+                <a:latin typeface="Arial"/>
+              </a:rPr>
+              <a:t> DM1's command map carries the hex-gap lattice — the DMs are doing the gap work themselves (the no-apodizer A/B is the scoped follow-on); and the 0.90 Lyot stop removes only ~0.1% of the post-FPM energy — this train's rejected light is interior gap structure, not edge rings.</a:t>
+            </a:r>
+          </a:p>
+        </p:txBody>
+      </p:sp>
+      <p:pic>
+        <p:nvPicPr>
+          <p:cNvPr id="7" name="Picture 6" descr="cf3d_dm_state.png"/>
+          <p:cNvPicPr>
+            <a:picLocks noChangeAspect="1"/>
+          </p:cNvPicPr>
+          <p:nvPr/>
+        </p:nvPicPr>
+        <p:blipFill>
+          <a:blip r:embed="rId3"/>
+          <a:stretch>
+            <a:fillRect/>
+          </a:stretch>
+        </p:blipFill>
+        <p:spPr>
+          <a:xfrm>
+            <a:off x="4702699" y="5221224"/>
+            <a:ext cx="2786296" cy="1243075"/>
+          </a:xfrm>
+          <a:prstGeom prst="rect">
+            <a:avLst/>
+          </a:prstGeom>
+        </p:spPr>
+      </p:pic>
+      <p:sp>
+        <p:nvSpPr>
+          <p:cNvPr id="8" name="TextBox 7"/>
+          <p:cNvSpPr txBox="1"/>
+          <p:nvPr/>
+        </p:nvSpPr>
+        <p:spPr>
+          <a:xfrm>
+            <a:off x="411480" y="6482588"/>
+            <a:ext cx="11368735" cy="229107"/>
+          </a:xfrm>
+          <a:prstGeom prst="rect">
+            <a:avLst/>
+          </a:prstGeom>
+          <a:noFill/>
+        </p:spPr>
+        <p:txBody>
+          <a:bodyPr wrap="square">
+            <a:spAutoFit/>
+          </a:bodyPr>
+          <a:lstStyle/>
+          <a:p>
+            <a:pPr algn="ctr">
+              <a:spcAft>
+                <a:spcPts val="0"/>
+              </a:spcAft>
+            </a:pPr>
+            <a:r>
+              <a:rPr sz="1000" b="0">
+                <a:solidFill>
+                  <a:srgbClr val="6E6E6E"/>
+                </a:solidFill>
+                <a:latin typeface="Arial"/>
+              </a:rPr>
+              <a:t>The dug command state: DM1 imprints the gap lattice; strokes ~33 nm rms, peaks ~160 nm.</a:t>
+            </a:r>
           </a:p>
         </p:txBody>
       </p:sp>
@@ -7087,7 +7351,7 @@
                 </a:solidFill>
                 <a:latin typeface="Arial"/>
               </a:rPr>
-              <a:t>The stop's edge, measured</a:t>
+              <a:t>What this demonstrates</a:t>
             </a:r>
           </a:p>
           <a:p>
@@ -7103,7 +7367,7 @@
                 </a:solidFill>
                 <a:latin typeface="Arial"/>
               </a:rPr>
-              <a:t>A Babinet split with 1e-15 closure: the edge interferes, it does not merely add</a:t>
+              <a:t>One model, from surface figure to a held dark zone</a:t>
             </a:r>
           </a:p>
         </p:txBody>
@@ -7161,7 +7425,7 @@
         <p:spPr>
           <a:xfrm>
             <a:off x="411480" y="1298448"/>
-            <a:ext cx="5806440" cy="274320"/>
+            <a:ext cx="11368735" cy="274320"/>
           </a:xfrm>
           <a:prstGeom prst="rect">
             <a:avLst/>
@@ -7195,16 +7459,16 @@
                 </a:solidFill>
                 <a:latin typeface="Arial"/>
               </a:rPr>
-              <a:t>Method.</a:t>
-            </a:r>
-            <a:r>
-              <a:rPr sz="1200" b="0">
-                <a:solidFill>
-                  <a:srgbClr val="282828"/>
-                </a:solidFill>
-                <a:latin typeface="Arial"/>
-              </a:rPr>
-              <a:t>  The circular stop applied as a SCREEN on the no-stop chain holds every mask and scale fixed, so E_rim = E_hex - E_screened is exactly the blocked rim's field.  Pins: screened bare peak == stopped bare peak to 0.0e0; both S1 records reproduced under 1%.</a:t>
+              <a:t>A design becomes an instrument becomes an error budget becomes a controlled observatory</a:t>
+            </a:r>
+            <a:r>
+              <a:rPr sz="1200" b="0">
+                <a:solidFill>
+                  <a:srgbClr val="282828"/>
+                </a:solidFill>
+                <a:latin typeface="Arial"/>
+              </a:rPr>
+              <a:t>, without leaving the model or re-entering the geometry anywhere.</a:t>
             </a:r>
           </a:p>
           <a:p>
@@ -7229,16 +7493,16 @@
                 </a:solidFill>
                 <a:latin typeface="Arial"/>
               </a:rPr>
-              <a:t>The split (dark-zone mean energy):</a:t>
-            </a:r>
-            <a:r>
-              <a:rPr sz="1200" b="0">
-                <a:solidFill>
-                  <a:srgbClr val="282828"/>
-                </a:solidFill>
-                <a:latin typeface="Arial"/>
-              </a:rPr>
-              <a:t> I_ns 1.09e-05 + rim 2.53e-06 + cross 6.54e-06 — the rim's own ring is ~28% of the increase; the cross term (coherent interference with the pre-existing gap speckle) is 2.6x larger.  Peak renormalization 1.178x; dark-zone energy up 1.83x at fixed masks; the lambda/D re-reference contributes 1.00x.</a:t>
+              <a:t>The gap penalty is measured, not assumed</a:t>
+            </a:r>
+            <a:r>
+              <a:rPr sz="1200" b="0">
+                <a:solidFill>
+                  <a:srgbClr val="282828"/>
+                </a:solidFill>
+                <a:latin typeface="Arial"/>
+              </a:rPr>
+              <a:t> — 1298× open loop — and the control loop that answers it is measured too: 1.7e-06 open against 2.5e-07 closed at the end of the soak.</a:t>
             </a:r>
           </a:p>
           <a:p>
@@ -7263,79 +7527,50 @@
                 </a:solidFill>
                 <a:latin typeface="Arial"/>
               </a:rPr>
-              <a:t>The APLC flag, restated:</a:t>
-            </a:r>
-            <a:r>
-              <a:rPr sz="1200" b="0">
-                <a:solidFill>
-                  <a:srgbClr val="282828"/>
-                </a:solidFill>
-                <a:latin typeface="Arial"/>
-              </a:rPr>
-              <a:t> the stopped aperture-matched prolate hit its iteration cap unconverged (the answer moves with the cap — not an eigenfunction, not a design); its apodizer also moves 2x with grid size (1.07e-6 at N=512 vs 2.18e-6 at 1024) — an implementation verdict, not a family verdict; the family is DEFERRED and the block/Lanczos eigensolver or the N'Diaye LP co-design are the named machines.  Bound reading (all rows): lin-ach is the relin G's rank-curve at the achieved stroke — a scale, not a strict inequality; Tikhonov solutions can undercut it by O(20%) (vortex c6 does).</a:t>
-            </a:r>
-          </a:p>
-        </p:txBody>
-      </p:sp>
-      <p:pic>
-        <p:nvPicPr>
-          <p:cNvPr id="5" name="Picture 4" descr="cf1c_stop_attrib.png"/>
-          <p:cNvPicPr>
-            <a:picLocks noChangeAspect="1"/>
-          </p:cNvPicPr>
-          <p:nvPr/>
-        </p:nvPicPr>
-        <p:blipFill>
-          <a:blip r:embed="rId2"/>
-          <a:stretch>
-            <a:fillRect/>
-          </a:stretch>
-        </p:blipFill>
-        <p:spPr>
-          <a:xfrm>
-            <a:off x="6758517" y="1298448"/>
-            <a:ext cx="4679524" cy="3611371"/>
-          </a:xfrm>
-          <a:prstGeom prst="rect">
-            <a:avLst/>
-          </a:prstGeom>
-        </p:spPr>
-      </p:pic>
-      <p:sp>
-        <p:nvSpPr>
-          <p:cNvPr id="6" name="TextBox 5"/>
-          <p:cNvSpPr txBox="1"/>
-          <p:nvPr/>
-        </p:nvSpPr>
-        <p:spPr>
-          <a:xfrm>
-            <a:off x="6400800" y="4928107"/>
-            <a:ext cx="5394960" cy="229107"/>
-          </a:xfrm>
-          <a:prstGeom prst="rect">
-            <a:avLst/>
-          </a:prstGeom>
-          <a:noFill/>
-        </p:spPr>
-        <p:txBody>
-          <a:bodyPr wrap="square">
-            <a:spAutoFit/>
-          </a:bodyPr>
-          <a:lstStyle/>
-          <a:p>
-            <a:pPr algn="ctr">
-              <a:spcAft>
-                <a:spcPts val="0"/>
-              </a:spcAft>
-            </a:pPr>
-            <a:r>
-              <a:rPr sz="1000" b="0">
-                <a:solidFill>
-                  <a:srgbClr val="6E6E6E"/>
-                </a:solidFill>
-                <a:latin typeface="Arial"/>
-              </a:rPr>
-              <a:t>Where the stop's edge lands: no-stop, stop-as-screen, and the rim field alone.</a:t>
+              <a:t>Every model-vs-engine comparison closes</a:t>
+            </a:r>
+            <a:r>
+              <a:rPr sz="1200" b="0">
+                <a:solidFill>
+                  <a:srgbClr val="282828"/>
+                </a:solidFill>
+                <a:latin typeface="Arial"/>
+              </a:rPr>
+              <a:t> — worst 0.0035 across segments, DMs and relay optics — because the comparison is made at the surface the model lives on.  Where a build disagreed, the deck says why and what fixed it.</a:t>
+            </a:r>
+          </a:p>
+          <a:p>
+            <a:pPr>
+              <a:spcAft>
+                <a:spcPts val="600"/>
+              </a:spcAft>
+            </a:pPr>
+            <a:r>
+              <a:rPr sz="1200" b="0">
+                <a:solidFill>
+                  <a:srgbClr val="282828"/>
+                </a:solidFill>
+                <a:latin typeface="Arial"/>
+              </a:rPr>
+              <a:t>•  </a:t>
+            </a:r>
+            <a:r>
+              <a:rPr sz="1200" b="1">
+                <a:solidFill>
+                  <a:srgbClr val="282828"/>
+                </a:solidFill>
+                <a:latin typeface="Arial"/>
+              </a:rPr>
+              <a:t>All of it is committed</a:t>
+            </a:r>
+            <a:r>
+              <a:rPr sz="1200" b="0">
+                <a:solidFill>
+                  <a:srgbClr val="282828"/>
+                </a:solidFill>
+                <a:latin typeface="Arial"/>
+              </a:rPr>
+              <a:t>: prescriptions, runners, reports, and this deck's numbers are one git clone away.</a:t>
             </a:r>
           </a:p>
         </p:txBody>
@@ -7349,6 +7584,412 @@
 </file>
 
 <file path=ppt/slides/slide21.xml><?xml version="1.0" encoding="utf-8"?>
+<p:sld xmlns:a="http://schemas.openxmlformats.org/drawingml/2006/main" xmlns:p="http://schemas.openxmlformats.org/presentationml/2006/main" xmlns:r="http://schemas.openxmlformats.org/officeDocument/2006/relationships">
+  <p:cSld>
+    <p:spTree>
+      <p:nvGrpSpPr>
+        <p:cNvPr id="1" name=""/>
+        <p:cNvGrpSpPr/>
+        <p:nvPr/>
+      </p:nvGrpSpPr>
+      <p:grpSpPr/>
+      <p:sp>
+        <p:nvSpPr>
+          <p:cNvPr id="2" name="TextBox 1"/>
+          <p:cNvSpPr txBox="1"/>
+          <p:nvPr/>
+        </p:nvSpPr>
+        <p:spPr>
+          <a:xfrm>
+            <a:off x="411480" y="201168"/>
+            <a:ext cx="11368735" cy="914400"/>
+          </a:xfrm>
+          <a:prstGeom prst="rect">
+            <a:avLst/>
+          </a:prstGeom>
+          <a:noFill/>
+        </p:spPr>
+        <p:txBody>
+          <a:bodyPr wrap="square">
+            <a:spAutoFit/>
+          </a:bodyPr>
+          <a:lstStyle/>
+          <a:p>
+            <a:pPr>
+              <a:spcAft>
+                <a:spcPts val="400"/>
+              </a:spcAft>
+            </a:pPr>
+            <a:r>
+              <a:rPr sz="2400" b="1">
+                <a:solidFill>
+                  <a:srgbClr val="1F4E79"/>
+                </a:solidFill>
+                <a:latin typeface="Arial"/>
+              </a:rPr>
+              <a:t>Backup Slides</a:t>
+            </a:r>
+          </a:p>
+        </p:txBody>
+      </p:sp>
+      <p:sp>
+        <p:nvSpPr>
+          <p:cNvPr id="3" name="Rectangle 2"/>
+          <p:cNvSpPr/>
+          <p:nvPr/>
+        </p:nvSpPr>
+        <p:spPr>
+          <a:xfrm>
+            <a:off x="411480" y="914400"/>
+            <a:ext cx="11368735" cy="20320"/>
+          </a:xfrm>
+          <a:prstGeom prst="rect">
+            <a:avLst/>
+          </a:prstGeom>
+          <a:solidFill>
+            <a:srgbClr val="B8C6D4"/>
+          </a:solidFill>
+          <a:ln>
+            <a:noFill/>
+          </a:ln>
+          <a:effectLst/>
+        </p:spPr>
+        <p:style>
+          <a:lnRef idx="1">
+            <a:schemeClr val="accent1"/>
+          </a:lnRef>
+          <a:fillRef idx="3">
+            <a:schemeClr val="accent1"/>
+          </a:fillRef>
+          <a:effectRef idx="2">
+            <a:schemeClr val="accent1"/>
+          </a:effectRef>
+          <a:fontRef idx="minor">
+            <a:schemeClr val="lt1"/>
+          </a:fontRef>
+        </p:style>
+        <p:txBody>
+          <a:bodyPr rtlCol="0" anchor="ctr"/>
+          <a:lstStyle/>
+          <a:p>
+            <a:pPr algn="ctr"/>
+          </a:p>
+        </p:txBody>
+      </p:sp>
+    </p:spTree>
+  </p:cSld>
+  <p:clrMapOvr>
+    <a:masterClrMapping/>
+  </p:clrMapOvr>
+</p:sld>
+</file>
+
+<file path=ppt/slides/slide22.xml><?xml version="1.0" encoding="utf-8"?>
+<p:sld xmlns:a="http://schemas.openxmlformats.org/drawingml/2006/main" xmlns:p="http://schemas.openxmlformats.org/presentationml/2006/main" xmlns:r="http://schemas.openxmlformats.org/officeDocument/2006/relationships">
+  <p:cSld>
+    <p:spTree>
+      <p:nvGrpSpPr>
+        <p:cNvPr id="1" name=""/>
+        <p:cNvGrpSpPr/>
+        <p:nvPr/>
+      </p:nvGrpSpPr>
+      <p:grpSpPr/>
+      <p:sp>
+        <p:nvSpPr>
+          <p:cNvPr id="2" name="TextBox 1"/>
+          <p:cNvSpPr txBox="1"/>
+          <p:nvPr/>
+        </p:nvSpPr>
+        <p:spPr>
+          <a:xfrm>
+            <a:off x="411480" y="201168"/>
+            <a:ext cx="11368735" cy="914400"/>
+          </a:xfrm>
+          <a:prstGeom prst="rect">
+            <a:avLst/>
+          </a:prstGeom>
+          <a:noFill/>
+        </p:spPr>
+        <p:txBody>
+          <a:bodyPr wrap="square">
+            <a:spAutoFit/>
+          </a:bodyPr>
+          <a:lstStyle/>
+          <a:p>
+            <a:pPr>
+              <a:spcAft>
+                <a:spcPts val="400"/>
+              </a:spcAft>
+            </a:pPr>
+            <a:r>
+              <a:rPr sz="2400" b="1">
+                <a:solidFill>
+                  <a:srgbClr val="1F4E79"/>
+                </a:solidFill>
+                <a:latin typeface="Arial"/>
+              </a:rPr>
+              <a:t>The stop's edge, measured</a:t>
+            </a:r>
+          </a:p>
+          <a:p>
+            <a:pPr>
+              <a:spcAft>
+                <a:spcPts val="0"/>
+              </a:spcAft>
+            </a:pPr>
+            <a:r>
+              <a:rPr sz="1250" b="0">
+                <a:solidFill>
+                  <a:srgbClr val="6E6E6E"/>
+                </a:solidFill>
+                <a:latin typeface="Arial"/>
+              </a:rPr>
+              <a:t>A Babinet split with 1e-15 closure: the edge interferes, it does not merely add</a:t>
+            </a:r>
+          </a:p>
+        </p:txBody>
+      </p:sp>
+      <p:sp>
+        <p:nvSpPr>
+          <p:cNvPr id="3" name="Rectangle 2"/>
+          <p:cNvSpPr/>
+          <p:nvPr/>
+        </p:nvSpPr>
+        <p:spPr>
+          <a:xfrm>
+            <a:off x="411480" y="1133856"/>
+            <a:ext cx="11368735" cy="20320"/>
+          </a:xfrm>
+          <a:prstGeom prst="rect">
+            <a:avLst/>
+          </a:prstGeom>
+          <a:solidFill>
+            <a:srgbClr val="B8C6D4"/>
+          </a:solidFill>
+          <a:ln>
+            <a:noFill/>
+          </a:ln>
+          <a:effectLst/>
+        </p:spPr>
+        <p:style>
+          <a:lnRef idx="1">
+            <a:schemeClr val="accent1"/>
+          </a:lnRef>
+          <a:fillRef idx="3">
+            <a:schemeClr val="accent1"/>
+          </a:fillRef>
+          <a:effectRef idx="2">
+            <a:schemeClr val="accent1"/>
+          </a:effectRef>
+          <a:fontRef idx="minor">
+            <a:schemeClr val="lt1"/>
+          </a:fontRef>
+        </p:style>
+        <p:txBody>
+          <a:bodyPr rtlCol="0" anchor="ctr"/>
+          <a:lstStyle/>
+          <a:p>
+            <a:pPr algn="ctr"/>
+          </a:p>
+        </p:txBody>
+      </p:sp>
+      <p:sp>
+        <p:nvSpPr>
+          <p:cNvPr id="4" name="TextBox 3"/>
+          <p:cNvSpPr txBox="1"/>
+          <p:nvPr/>
+        </p:nvSpPr>
+        <p:spPr>
+          <a:xfrm>
+            <a:off x="411480" y="1298448"/>
+            <a:ext cx="5806440" cy="274320"/>
+          </a:xfrm>
+          <a:prstGeom prst="rect">
+            <a:avLst/>
+          </a:prstGeom>
+          <a:noFill/>
+        </p:spPr>
+        <p:txBody>
+          <a:bodyPr wrap="square">
+            <a:spAutoFit/>
+          </a:bodyPr>
+          <a:lstStyle/>
+          <a:p>
+            <a:pPr>
+              <a:spcAft>
+                <a:spcPts val="600"/>
+              </a:spcAft>
+            </a:pPr>
+            <a:r>
+              <a:rPr sz="1200" b="0">
+                <a:solidFill>
+                  <a:srgbClr val="282828"/>
+                </a:solidFill>
+                <a:latin typeface="Arial"/>
+              </a:rPr>
+              <a:t>•  </a:t>
+            </a:r>
+            <a:r>
+              <a:rPr sz="1200" b="1">
+                <a:solidFill>
+                  <a:srgbClr val="282828"/>
+                </a:solidFill>
+                <a:latin typeface="Arial"/>
+              </a:rPr>
+              <a:t>Method.</a:t>
+            </a:r>
+            <a:r>
+              <a:rPr sz="1200" b="0">
+                <a:solidFill>
+                  <a:srgbClr val="282828"/>
+                </a:solidFill>
+                <a:latin typeface="Arial"/>
+              </a:rPr>
+              <a:t>  The circular stop applied as a SCREEN on the no-stop chain holds every mask and scale fixed, so E_rim = E_hex - E_screened is exactly the blocked rim's field.  Pins: screened bare peak == stopped bare peak to 0.0e0; both S1 records reproduced under 1%.</a:t>
+            </a:r>
+          </a:p>
+          <a:p>
+            <a:pPr>
+              <a:spcAft>
+                <a:spcPts val="600"/>
+              </a:spcAft>
+            </a:pPr>
+            <a:r>
+              <a:rPr sz="1200" b="0">
+                <a:solidFill>
+                  <a:srgbClr val="282828"/>
+                </a:solidFill>
+                <a:latin typeface="Arial"/>
+              </a:rPr>
+              <a:t>•  </a:t>
+            </a:r>
+            <a:r>
+              <a:rPr sz="1200" b="1">
+                <a:solidFill>
+                  <a:srgbClr val="282828"/>
+                </a:solidFill>
+                <a:latin typeface="Arial"/>
+              </a:rPr>
+              <a:t>The split (dark-zone mean energy):</a:t>
+            </a:r>
+            <a:r>
+              <a:rPr sz="1200" b="0">
+                <a:solidFill>
+                  <a:srgbClr val="282828"/>
+                </a:solidFill>
+                <a:latin typeface="Arial"/>
+              </a:rPr>
+              <a:t> I_ns 1.09e-05 + rim 2.53e-06 + cross 6.54e-06 — the rim's own ring is ~28% of the increase; the cross term (coherent interference with the pre-existing gap speckle) is 2.6x larger.  Peak renormalization 1.178x; dark-zone energy up 1.83x at fixed masks; the lambda/D re-reference contributes 1.00x.</a:t>
+            </a:r>
+          </a:p>
+          <a:p>
+            <a:pPr>
+              <a:spcAft>
+                <a:spcPts val="600"/>
+              </a:spcAft>
+            </a:pPr>
+            <a:r>
+              <a:rPr sz="1200" b="0">
+                <a:solidFill>
+                  <a:srgbClr val="282828"/>
+                </a:solidFill>
+                <a:latin typeface="Arial"/>
+              </a:rPr>
+              <a:t>•  </a:t>
+            </a:r>
+            <a:r>
+              <a:rPr sz="1200" b="1">
+                <a:solidFill>
+                  <a:srgbClr val="282828"/>
+                </a:solidFill>
+                <a:latin typeface="Arial"/>
+              </a:rPr>
+              <a:t>The APLC flag, restated:</a:t>
+            </a:r>
+            <a:r>
+              <a:rPr sz="1200" b="0">
+                <a:solidFill>
+                  <a:srgbClr val="282828"/>
+                </a:solidFill>
+                <a:latin typeface="Arial"/>
+              </a:rPr>
+              <a:t> the stopped aperture-matched prolate hit its iteration cap unconverged (the answer moves with the cap — not an eigenfunction, not a design); its apodizer also moves 2x with grid size (1.07e-6 at N=512 vs 2.18e-6 at 1024) — an implementation verdict, not a family verdict; the family is DEFERRED and the block/Lanczos eigensolver or the N'Diaye LP co-design are the named machines.  Bound reading (all rows): lin-ach is the relin G's rank-curve at the achieved stroke — a scale, not a strict inequality; Tikhonov solutions can undercut it by O(20%) (vortex c6 does).</a:t>
+            </a:r>
+          </a:p>
+        </p:txBody>
+      </p:sp>
+      <p:pic>
+        <p:nvPicPr>
+          <p:cNvPr id="5" name="Picture 4" descr="cf1c_stop_attrib.png"/>
+          <p:cNvPicPr>
+            <a:picLocks noChangeAspect="1"/>
+          </p:cNvPicPr>
+          <p:nvPr/>
+        </p:nvPicPr>
+        <p:blipFill>
+          <a:blip r:embed="rId2"/>
+          <a:stretch>
+            <a:fillRect/>
+          </a:stretch>
+        </p:blipFill>
+        <p:spPr>
+          <a:xfrm>
+            <a:off x="6758517" y="1298448"/>
+            <a:ext cx="4679524" cy="3611371"/>
+          </a:xfrm>
+          <a:prstGeom prst="rect">
+            <a:avLst/>
+          </a:prstGeom>
+        </p:spPr>
+      </p:pic>
+      <p:sp>
+        <p:nvSpPr>
+          <p:cNvPr id="6" name="TextBox 5"/>
+          <p:cNvSpPr txBox="1"/>
+          <p:nvPr/>
+        </p:nvSpPr>
+        <p:spPr>
+          <a:xfrm>
+            <a:off x="6400800" y="4928107"/>
+            <a:ext cx="5394960" cy="229107"/>
+          </a:xfrm>
+          <a:prstGeom prst="rect">
+            <a:avLst/>
+          </a:prstGeom>
+          <a:noFill/>
+        </p:spPr>
+        <p:txBody>
+          <a:bodyPr wrap="square">
+            <a:spAutoFit/>
+          </a:bodyPr>
+          <a:lstStyle/>
+          <a:p>
+            <a:pPr algn="ctr">
+              <a:spcAft>
+                <a:spcPts val="0"/>
+              </a:spcAft>
+            </a:pPr>
+            <a:r>
+              <a:rPr sz="1000" b="0">
+                <a:solidFill>
+                  <a:srgbClr val="6E6E6E"/>
+                </a:solidFill>
+                <a:latin typeface="Arial"/>
+              </a:rPr>
+              <a:t>Where the stop's edge lands: no-stop, stop-as-screen, and the rim field alone.</a:t>
+            </a:r>
+          </a:p>
+        </p:txBody>
+      </p:sp>
+    </p:spTree>
+  </p:cSld>
+  <p:clrMapOvr>
+    <a:masterClrMapping/>
+  </p:clrMapOvr>
+</p:sld>
+</file>
+
+<file path=ppt/slides/slide23.xml><?xml version="1.0" encoding="utf-8"?>
 <p:sld xmlns:a="http://schemas.openxmlformats.org/drawingml/2006/main" xmlns:p="http://schemas.openxmlformats.org/presentationml/2006/main" xmlns:r="http://schemas.openxmlformats.org/officeDocument/2006/relationships">
   <p:cSld>
     <p:spTree>
@@ -8166,7 +8807,7 @@
 </p:sld>
 </file>
 
-<file path=ppt/slides/slide22.xml><?xml version="1.0" encoding="utf-8"?>
+<file path=ppt/slides/slide24.xml><?xml version="1.0" encoding="utf-8"?>
 <p:sld xmlns:a="http://schemas.openxmlformats.org/drawingml/2006/main" xmlns:p="http://schemas.openxmlformats.org/presentationml/2006/main" xmlns:r="http://schemas.openxmlformats.org/officeDocument/2006/relationships">
   <p:cSld>
     <p:spTree>
@@ -8430,420 +9071,6 @@
                 <a:latin typeface="Arial"/>
               </a:rPr>
               <a:t> Undamped solves against gap speckle — amplitude-dominated, weakly controllable at this DM spacing — push stroke along near-null directions and diverge; damping (0.7) plus a small leak (0.02) makes the dig monotone and held.  DM spacing as an amplitude-authority knob is a stated design trade, not exercised here.</a:t>
-            </a:r>
-          </a:p>
-        </p:txBody>
-      </p:sp>
-    </p:spTree>
-  </p:cSld>
-  <p:clrMapOvr>
-    <a:masterClrMapping/>
-  </p:clrMapOvr>
-</p:sld>
-</file>
-
-<file path=ppt/slides/slide23.xml><?xml version="1.0" encoding="utf-8"?>
-<p:sld xmlns:a="http://schemas.openxmlformats.org/drawingml/2006/main" xmlns:p="http://schemas.openxmlformats.org/presentationml/2006/main" xmlns:r="http://schemas.openxmlformats.org/officeDocument/2006/relationships">
-  <p:cSld>
-    <p:spTree>
-      <p:nvGrpSpPr>
-        <p:cNvPr id="1" name=""/>
-        <p:cNvGrpSpPr/>
-        <p:nvPr/>
-      </p:nvGrpSpPr>
-      <p:grpSpPr/>
-      <p:sp>
-        <p:nvSpPr>
-          <p:cNvPr id="2" name="TextBox 1"/>
-          <p:cNvSpPr txBox="1"/>
-          <p:nvPr/>
-        </p:nvSpPr>
-        <p:spPr>
-          <a:xfrm>
-            <a:off x="411480" y="201168"/>
-            <a:ext cx="11368735" cy="914400"/>
-          </a:xfrm>
-          <a:prstGeom prst="rect">
-            <a:avLst/>
-          </a:prstGeom>
-          <a:noFill/>
-        </p:spPr>
-        <p:txBody>
-          <a:bodyPr wrap="square">
-            <a:spAutoFit/>
-          </a:bodyPr>
-          <a:lstStyle/>
-          <a:p>
-            <a:pPr>
-              <a:spcAft>
-                <a:spcPts val="400"/>
-              </a:spcAft>
-            </a:pPr>
-            <a:r>
-              <a:rPr sz="2400" b="1">
-                <a:solidFill>
-                  <a:srgbClr val="1F4E79"/>
-                </a:solidFill>
-                <a:latin typeface="Arial"/>
-              </a:rPr>
-              <a:t>Packaging the longer relay</a:t>
-            </a:r>
-          </a:p>
-          <a:p>
-            <a:pPr>
-              <a:spcAft>
-                <a:spcPts val="0"/>
-              </a:spcAft>
-            </a:pPr>
-            <a:r>
-              <a:rPr sz="1250" b="0">
-                <a:solidFill>
-                  <a:srgbClr val="6E6E6E"/>
-                </a:solidFill>
-                <a:latin typeface="Arial"/>
-              </a:rPr>
-              <a:t>Fold side is a stability choice, not a taste choice</a:t>
-            </a:r>
-          </a:p>
-        </p:txBody>
-      </p:sp>
-      <p:sp>
-        <p:nvSpPr>
-          <p:cNvPr id="3" name="Rectangle 2"/>
-          <p:cNvSpPr/>
-          <p:nvPr/>
-        </p:nvSpPr>
-        <p:spPr>
-          <a:xfrm>
-            <a:off x="411480" y="1133856"/>
-            <a:ext cx="11368735" cy="20320"/>
-          </a:xfrm>
-          <a:prstGeom prst="rect">
-            <a:avLst/>
-          </a:prstGeom>
-          <a:solidFill>
-            <a:srgbClr val="B8C6D4"/>
-          </a:solidFill>
-          <a:ln>
-            <a:noFill/>
-          </a:ln>
-          <a:effectLst/>
-        </p:spPr>
-        <p:style>
-          <a:lnRef idx="1">
-            <a:schemeClr val="accent1"/>
-          </a:lnRef>
-          <a:fillRef idx="3">
-            <a:schemeClr val="accent1"/>
-          </a:fillRef>
-          <a:effectRef idx="2">
-            <a:schemeClr val="accent1"/>
-          </a:effectRef>
-          <a:fontRef idx="minor">
-            <a:schemeClr val="lt1"/>
-          </a:fontRef>
-        </p:style>
-        <p:txBody>
-          <a:bodyPr rtlCol="0" anchor="ctr"/>
-          <a:lstStyle/>
-          <a:p>
-            <a:pPr algn="ctr"/>
-          </a:p>
-        </p:txBody>
-      </p:sp>
-      <p:sp>
-        <p:nvSpPr>
-          <p:cNvPr id="4" name="TextBox 3"/>
-          <p:cNvSpPr txBox="1"/>
-          <p:nvPr/>
-        </p:nvSpPr>
-        <p:spPr>
-          <a:xfrm>
-            <a:off x="411480" y="1298448"/>
-            <a:ext cx="11368735" cy="274320"/>
-          </a:xfrm>
-          <a:prstGeom prst="rect">
-            <a:avLst/>
-          </a:prstGeom>
-          <a:noFill/>
-        </p:spPr>
-        <p:txBody>
-          <a:bodyPr wrap="square">
-            <a:spAutoFit/>
-          </a:bodyPr>
-          <a:lstStyle/>
-          <a:p>
-            <a:pPr>
-              <a:spcAft>
-                <a:spcPts val="600"/>
-              </a:spcAft>
-            </a:pPr>
-            <a:r>
-              <a:rPr sz="1200" b="0">
-                <a:solidFill>
-                  <a:srgbClr val="282828"/>
-                </a:solidFill>
-                <a:latin typeface="Arial"/>
-              </a:rPr>
-              <a:t>•  A near-normal fold turns the chief by 180° − 2·AOI, and the beam direction reverses at each mirror.</a:t>
-            </a:r>
-          </a:p>
-          <a:p>
-            <a:pPr>
-              <a:spcAft>
-                <a:spcPts val="600"/>
-              </a:spcAft>
-            </a:pPr>
-            <a:r>
-              <a:rPr sz="1200" b="0">
-                <a:solidFill>
-                  <a:srgbClr val="282828"/>
-                </a:solidFill>
-                <a:latin typeface="Arial"/>
-              </a:rPr>
-              <a:t>•  </a:t>
-            </a:r>
-            <a:r>
-              <a:rPr sz="1200" b="1">
-                <a:solidFill>
-                  <a:srgbClr val="282828"/>
-                </a:solidFill>
-                <a:latin typeface="Arial"/>
-              </a:rPr>
-              <a:t>Alternating the fold side</a:t>
-            </a:r>
-            <a:r>
-              <a:rPr sz="1200" b="0">
-                <a:solidFill>
-                  <a:srgbClr val="282828"/>
-                </a:solidFill>
-                <a:latin typeface="Arial"/>
-              </a:rPr>
-              <a:t> — fine for the five folds of the shorter round-1 relay — adds −2·AOI of net rotation per fold: over this chain's ten folds the accordion fans ~120° and walks to a 10.33 m shroud diameter.  Measured, with the element positions in the record.</a:t>
-            </a:r>
-          </a:p>
-          <a:p>
-            <a:pPr>
-              <a:spcAft>
-                <a:spcPts val="600"/>
-              </a:spcAft>
-            </a:pPr>
-            <a:r>
-              <a:rPr sz="1200" b="0">
-                <a:solidFill>
-                  <a:srgbClr val="282828"/>
-                </a:solidFill>
-                <a:latin typeface="Arial"/>
-              </a:rPr>
-              <a:t>•  </a:t>
-            </a:r>
-            <a:r>
-              <a:rPr sz="1200" b="1">
-                <a:solidFill>
-                  <a:srgbClr val="282828"/>
-                </a:solidFill>
-                <a:latin typeface="Arial"/>
-              </a:rPr>
-              <a:t>Keeping the same side every fold</a:t>
-            </a:r>
-            <a:r>
-              <a:rPr sz="1200" b="0">
-                <a:solidFill>
-                  <a:srgbClr val="282828"/>
-                </a:solidFill>
-                <a:latin typeface="Arial"/>
-              </a:rPr>
-              <a:t> ping-pongs the beam between two fixed directions and packs the chain into a leg-sized pocket: 7.451 m, identical to the primary-set envelope.  The DM-bearing back end costs nothing in shroud diameter.</a:t>
-            </a:r>
-          </a:p>
-        </p:txBody>
-      </p:sp>
-    </p:spTree>
-  </p:cSld>
-  <p:clrMapOvr>
-    <a:masterClrMapping/>
-  </p:clrMapOvr>
-</p:sld>
-</file>
-
-<file path=ppt/slides/slide24.xml><?xml version="1.0" encoding="utf-8"?>
-<p:sld xmlns:a="http://schemas.openxmlformats.org/drawingml/2006/main" xmlns:p="http://schemas.openxmlformats.org/presentationml/2006/main" xmlns:r="http://schemas.openxmlformats.org/officeDocument/2006/relationships">
-  <p:cSld>
-    <p:spTree>
-      <p:nvGrpSpPr>
-        <p:cNvPr id="1" name=""/>
-        <p:cNvGrpSpPr/>
-        <p:nvPr/>
-      </p:nvGrpSpPr>
-      <p:grpSpPr/>
-      <p:sp>
-        <p:nvSpPr>
-          <p:cNvPr id="2" name="TextBox 1"/>
-          <p:cNvSpPr txBox="1"/>
-          <p:nvPr/>
-        </p:nvSpPr>
-        <p:spPr>
-          <a:xfrm>
-            <a:off x="411480" y="201168"/>
-            <a:ext cx="11368735" cy="914400"/>
-          </a:xfrm>
-          <a:prstGeom prst="rect">
-            <a:avLst/>
-          </a:prstGeom>
-          <a:noFill/>
-        </p:spPr>
-        <p:txBody>
-          <a:bodyPr wrap="square">
-            <a:spAutoFit/>
-          </a:bodyPr>
-          <a:lstStyle/>
-          <a:p>
-            <a:pPr>
-              <a:spcAft>
-                <a:spcPts val="400"/>
-              </a:spcAft>
-            </a:pPr>
-            <a:r>
-              <a:rPr sz="2400" b="1">
-                <a:solidFill>
-                  <a:srgbClr val="1F4E79"/>
-                </a:solidFill>
-                <a:latin typeface="Arial"/>
-              </a:rPr>
-              <a:t>Focal ratio: why f/25.4 and not f/12–20</a:t>
-            </a:r>
-          </a:p>
-          <a:p>
-            <a:pPr>
-              <a:spcAft>
-                <a:spcPts val="0"/>
-              </a:spcAft>
-            </a:pPr>
-            <a:r>
-              <a:rPr sz="1250" b="0">
-                <a:solidFill>
-                  <a:srgbClr val="6E6E6E"/>
-                </a:solidFill>
-                <a:latin typeface="Arial"/>
-              </a:rPr>
-              <a:t>The corrected focal ratio is not a continuous function of the layout</a:t>
-            </a:r>
-          </a:p>
-        </p:txBody>
-      </p:sp>
-      <p:sp>
-        <p:nvSpPr>
-          <p:cNvPr id="3" name="Rectangle 2"/>
-          <p:cNvSpPr/>
-          <p:nvPr/>
-        </p:nvSpPr>
-        <p:spPr>
-          <a:xfrm>
-            <a:off x="411480" y="1133856"/>
-            <a:ext cx="11368735" cy="20320"/>
-          </a:xfrm>
-          <a:prstGeom prst="rect">
-            <a:avLst/>
-          </a:prstGeom>
-          <a:solidFill>
-            <a:srgbClr val="B8C6D4"/>
-          </a:solidFill>
-          <a:ln>
-            <a:noFill/>
-          </a:ln>
-          <a:effectLst/>
-        </p:spPr>
-        <p:style>
-          <a:lnRef idx="1">
-            <a:schemeClr val="accent1"/>
-          </a:lnRef>
-          <a:fillRef idx="3">
-            <a:schemeClr val="accent1"/>
-          </a:fillRef>
-          <a:effectRef idx="2">
-            <a:schemeClr val="accent1"/>
-          </a:effectRef>
-          <a:fontRef idx="minor">
-            <a:schemeClr val="lt1"/>
-          </a:fontRef>
-        </p:style>
-        <p:txBody>
-          <a:bodyPr rtlCol="0" anchor="ctr"/>
-          <a:lstStyle/>
-          <a:p>
-            <a:pPr algn="ctr"/>
-          </a:p>
-        </p:txBody>
-      </p:sp>
-      <p:sp>
-        <p:nvSpPr>
-          <p:cNvPr id="4" name="TextBox 3"/>
-          <p:cNvSpPr txBox="1"/>
-          <p:nvPr/>
-        </p:nvSpPr>
-        <p:spPr>
-          <a:xfrm>
-            <a:off x="411480" y="1298448"/>
-            <a:ext cx="11368735" cy="274320"/>
-          </a:xfrm>
-          <a:prstGeom prst="rect">
-            <a:avLst/>
-          </a:prstGeom>
-          <a:noFill/>
-        </p:spPr>
-        <p:txBody>
-          <a:bodyPr wrap="square">
-            <a:spAutoFit/>
-          </a:bodyPr>
-          <a:lstStyle/>
-          <a:p>
-            <a:pPr>
-              <a:spcAft>
-                <a:spcPts val="600"/>
-              </a:spcAft>
-            </a:pPr>
-            <a:r>
-              <a:rPr sz="1200" b="0">
-                <a:solidFill>
-                  <a:srgbClr val="282828"/>
-                </a:solidFill>
-                <a:latin typeface="Arial"/>
-              </a:rPr>
-              <a:t>•  The surface-figure solve spends optical power, so the focal ratio must be read on the corrected system; a search on the tertiary radius lands in different solve basins and refuses to steer continuously (f/15.5 and f/25.7 at layouts 0.36% apart).</a:t>
-            </a:r>
-          </a:p>
-          <a:p>
-            <a:pPr>
-              <a:spcAft>
-                <a:spcPts val="600"/>
-              </a:spcAft>
-            </a:pPr>
-            <a:r>
-              <a:rPr sz="1200" b="0">
-                <a:solidFill>
-                  <a:srgbClr val="282828"/>
-                </a:solidFill>
-                <a:latin typeface="Arial"/>
-              </a:rPr>
-              <a:t>•  </a:t>
-            </a:r>
-            <a:r>
-              <a:rPr sz="1200" b="1">
-                <a:solidFill>
-                  <a:srgbClr val="282828"/>
-                </a:solidFill>
-                <a:latin typeface="Arial"/>
-              </a:rPr>
-              <a:t>The design point was chosen on wavefront</a:t>
-            </a:r>
-            <a:r>
-              <a:rPr sz="1200" b="0">
-                <a:solidFill>
-                  <a:srgbClr val="282828"/>
-                </a:solidFill>
-                <a:latin typeface="Arial"/>
-              </a:rPr>
-              <a:t>, which it meets; the slower focal ratio also puts more λ/D on the focal-plane mask, easing its fabrication.</a:t>
             </a:r>
           </a:p>
         </p:txBody>
@@ -8900,7 +9127,7 @@
                 </a:solidFill>
                 <a:latin typeface="Arial"/>
               </a:rPr>
-              <a:t>What an apodizer alone does not buy back</a:t>
+              <a:t>Packaging the longer relay</a:t>
             </a:r>
           </a:p>
           <a:p>
@@ -8916,7 +9143,7 @@
                 </a:solidFill>
                 <a:latin typeface="Arial"/>
               </a:rPr>
-              <a:t>The round-1 negative result stands</a:t>
+              <a:t>Fold side is a stability choice, not a taste choice</a:t>
             </a:r>
           </a:p>
         </p:txBody>
@@ -8999,7 +9226,7 @@
                 </a:solidFill>
                 <a:latin typeface="Arial"/>
               </a:rPr>
-              <a:t>•  Redesigning the apodizer for the segmented pupil — a linear-program optimum and an aperture-specific eigenfunction — recovered essentially nothing: the gaps scatter light no transmission profile removes.</a:t>
+              <a:t>•  A near-normal fold turns the chief by 180° − 2·AOI, and the beam direction reverses at each mirror.</a:t>
             </a:r>
           </a:p>
           <a:p>
@@ -9015,7 +9242,7 @@
                 </a:solidFill>
                 <a:latin typeface="Arial"/>
               </a:rPr>
-              <a:t>•  The optimizer's design model (a single Fourier transform) floors five times above what the engine already reaches, and the disagreement </a:t>
+              <a:t>•  </a:t>
             </a:r>
             <a:r>
               <a:rPr sz="1200" b="1">
@@ -9024,16 +9251,16 @@
                 </a:solidFill>
                 <a:latin typeface="Arial"/>
               </a:rPr>
-              <a:t>grows</a:t>
-            </a:r>
-            <a:r>
-              <a:rPr sz="1200" b="0">
-                <a:solidFill>
-                  <a:srgbClr val="282828"/>
-                </a:solidFill>
-                <a:latin typeface="Arial"/>
-              </a:rPr>
-              <a:t> the harder the optimizer is pushed — the signature of an optimizer mining its model, worth reusing as a diagnostic anywhere a design model is cheaper than the simulator it feeds.</a:t>
+              <a:t>Alternating the fold side</a:t>
+            </a:r>
+            <a:r>
+              <a:rPr sz="1200" b="0">
+                <a:solidFill>
+                  <a:srgbClr val="282828"/>
+                </a:solidFill>
+                <a:latin typeface="Arial"/>
+              </a:rPr>
+              <a:t> — fine for the five folds of the shorter round-1 relay — adds −2·AOI of net rotation per fold: over this chain's ten folds the accordion fans ~120° and walks to a 10.33 m shroud diameter.  Measured, with the element positions in the record.</a:t>
             </a:r>
           </a:p>
           <a:p>
@@ -9049,7 +9276,25 @@
                 </a:solidFill>
                 <a:latin typeface="Arial"/>
               </a:rPr>
-              <a:t>•  The round-2 answer is the deformable mirrors: measured against the engine, they dig the segmented floor 4.6e-07 → 1.9e-07 and hold it under drift.</a:t>
+              <a:t>•  </a:t>
+            </a:r>
+            <a:r>
+              <a:rPr sz="1200" b="1">
+                <a:solidFill>
+                  <a:srgbClr val="282828"/>
+                </a:solidFill>
+                <a:latin typeface="Arial"/>
+              </a:rPr>
+              <a:t>Keeping the same side every fold</a:t>
+            </a:r>
+            <a:r>
+              <a:rPr sz="1200" b="0">
+                <a:solidFill>
+                  <a:srgbClr val="282828"/>
+                </a:solidFill>
+                <a:latin typeface="Arial"/>
+              </a:rPr>
+              <a:t> ping-pongs the beam between two fixed directions and packs the chain into a leg-sized pocket: 7.451 m, identical to the primary-set envelope.  The DM-bearing back end costs nothing in shroud diameter.</a:t>
             </a:r>
           </a:p>
         </p:txBody>
@@ -9106,7 +9351,7 @@
                 </a:solidFill>
                 <a:latin typeface="Arial"/>
               </a:rPr>
-              <a:t>What is not in this model</a:t>
+              <a:t>Focal ratio: why f/25.4 and not f/12–20</a:t>
             </a:r>
           </a:p>
           <a:p>
@@ -9122,7 +9367,7 @@
                 </a:solidFill>
                 <a:latin typeface="Arial"/>
               </a:rPr>
-              <a:t>Stated, not omitted</a:t>
+              <a:t>The corrected focal ratio is not a continuous function of the layout</a:t>
             </a:r>
           </a:p>
         </p:txBody>
@@ -9205,6 +9450,22 @@
                 </a:solidFill>
                 <a:latin typeface="Arial"/>
               </a:rPr>
+              <a:t>•  The surface-figure solve spends optical power, so the focal ratio must be read on the corrected system; a search on the tertiary radius lands in different solve basins and refuses to steer continuously (f/15.5 and f/25.7 at layouts 0.36% apart).</a:t>
+            </a:r>
+          </a:p>
+          <a:p>
+            <a:pPr>
+              <a:spcAft>
+                <a:spcPts val="600"/>
+              </a:spcAft>
+            </a:pPr>
+            <a:r>
+              <a:rPr sz="1200" b="0">
+                <a:solidFill>
+                  <a:srgbClr val="282828"/>
+                </a:solidFill>
+                <a:latin typeface="Arial"/>
+              </a:rPr>
               <a:t>•  </a:t>
             </a:r>
             <a:r>
@@ -9214,118 +9475,16 @@
                 </a:solidFill>
                 <a:latin typeface="Arial"/>
               </a:rPr>
-              <a:t>The coronagraph masks are clear-pupil designs.</a:t>
-            </a:r>
-            <a:r>
-              <a:rPr sz="1200" b="0">
-                <a:solidFill>
-                  <a:srgbClr val="282828"/>
-                </a:solidFill>
-                <a:latin typeface="Arial"/>
-              </a:rPr>
-              <a:t>  Co-optimising apodizer, occulter and Lyot for the segmented aperture is known, separate work; the open-loop 1298× is the size of that prize.</a:t>
-            </a:r>
-          </a:p>
-          <a:p>
-            <a:pPr>
-              <a:spcAft>
-                <a:spcPts val="600"/>
-              </a:spcAft>
-            </a:pPr>
-            <a:r>
-              <a:rPr sz="1200" b="0">
-                <a:solidFill>
-                  <a:srgbClr val="282828"/>
-                </a:solidFill>
-                <a:latin typeface="Arial"/>
-              </a:rPr>
-              <a:t>•  </a:t>
-            </a:r>
-            <a:r>
-              <a:rPr sz="1200" b="1">
-                <a:solidFill>
-                  <a:srgbClr val="282828"/>
-                </a:solidFill>
-                <a:latin typeface="Arial"/>
-              </a:rPr>
-              <a:t>Monochromatic, at 500 nm.</a:t>
-            </a:r>
-            <a:r>
-              <a:rPr sz="1200" b="0">
-                <a:solidFill>
-                  <a:srgbClr val="282828"/>
-                </a:solidFill>
-                <a:latin typeface="Arial"/>
-              </a:rPr>
-              <a:t>  The bandwidth and polarization layers exist on the testbed substrate and are configuration away, not new machinery.</a:t>
-            </a:r>
-          </a:p>
-          <a:p>
-            <a:pPr>
-              <a:spcAft>
-                <a:spcPts val="600"/>
-              </a:spcAft>
-            </a:pPr>
-            <a:r>
-              <a:rPr sz="1200" b="0">
-                <a:solidFill>
-                  <a:srgbClr val="282828"/>
-                </a:solidFill>
-                <a:latin typeface="Arial"/>
-              </a:rPr>
-              <a:t>•  </a:t>
-            </a:r>
-            <a:r>
-              <a:rPr sz="1200" b="1">
-                <a:solidFill>
-                  <a:srgbClr val="282828"/>
-                </a:solidFill>
-                <a:latin typeface="Arial"/>
-              </a:rPr>
-              <a:t>The metrology measurement is simulated from its validated linear model</a:t>
-            </a:r>
-            <a:r>
-              <a:rPr sz="1200" b="0">
-                <a:solidFill>
-                  <a:srgbClr val="282828"/>
-                </a:solidFill>
-                <a:latin typeface="Arial"/>
-              </a:rPr>
-              <a:t> plus noise, not a second engine trace of the truss; the engine holds the truss points rigid, so the model is the only figure source either way.</a:t>
-            </a:r>
-          </a:p>
-          <a:p>
-            <a:pPr>
-              <a:spcAft>
-                <a:spcPts val="600"/>
-              </a:spcAft>
-            </a:pPr>
-            <a:r>
-              <a:rPr sz="1200" b="0">
-                <a:solidFill>
-                  <a:srgbClr val="282828"/>
-                </a:solidFill>
-                <a:latin typeface="Arial"/>
-              </a:rPr>
-              <a:t>•  </a:t>
-            </a:r>
-            <a:r>
-              <a:rPr sz="1200" b="1">
-                <a:solidFill>
-                  <a:srgbClr val="282828"/>
-                </a:solidFill>
-                <a:latin typeface="Arial"/>
-              </a:rPr>
-              <a:t>DM spacing</a:t>
-            </a:r>
-            <a:r>
-              <a:rPr sz="1200" b="0">
-                <a:solidFill>
-                  <a:srgbClr val="282828"/>
-                </a:solidFill>
-                <a:latin typeface="Arial"/>
-              </a:rPr>
-              <a:t> (47 mm pupil, 0.15 m apart) limits amplitude-speckle authority; the testbed's wider spacing is the knob, and re-running the chain at another spacing is parameter work.</a:t>
+              <a:t>The design point was chosen on wavefront</a:t>
+            </a:r>
+            <a:r>
+              <a:rPr sz="1200" b="0">
+                <a:solidFill>
+                  <a:srgbClr val="282828"/>
+                </a:solidFill>
+                <a:latin typeface="Arial"/>
+              </a:rPr>
+              <a:t>, which it meets; the slower focal ratio also puts more λ/D on the focal-plane mask, easing its fabrication.</a:t>
             </a:r>
           </a:p>
         </p:txBody>
@@ -9382,7 +9541,7 @@
                 </a:solidFill>
                 <a:latin typeface="Arial"/>
               </a:rPr>
-              <a:t>How to reproduce</a:t>
+              <a:t>What an apodizer alone does not buy back</a:t>
             </a:r>
           </a:p>
           <a:p>
@@ -9398,7 +9557,7 @@
                 </a:solidFill>
                 <a:latin typeface="Arial"/>
               </a:rPr>
-              <a:t>Every number on these slides comes from these runs</a:t>
+              <a:t>The round-1 negative result stands</a:t>
             </a:r>
           </a:p>
         </p:txBody>
@@ -9481,6 +9640,488 @@
                 </a:solidFill>
                 <a:latin typeface="Arial"/>
               </a:rPr>
+              <a:t>•  Redesigning the apodizer for the segmented pupil — a linear-program optimum and an aperture-specific eigenfunction — recovered essentially nothing: the gaps scatter light no transmission profile removes.</a:t>
+            </a:r>
+          </a:p>
+          <a:p>
+            <a:pPr>
+              <a:spcAft>
+                <a:spcPts val="600"/>
+              </a:spcAft>
+            </a:pPr>
+            <a:r>
+              <a:rPr sz="1200" b="0">
+                <a:solidFill>
+                  <a:srgbClr val="282828"/>
+                </a:solidFill>
+                <a:latin typeface="Arial"/>
+              </a:rPr>
+              <a:t>•  The optimizer's design model (a single Fourier transform) floors five times above what the engine already reaches, and the disagreement </a:t>
+            </a:r>
+            <a:r>
+              <a:rPr sz="1200" b="1">
+                <a:solidFill>
+                  <a:srgbClr val="282828"/>
+                </a:solidFill>
+                <a:latin typeface="Arial"/>
+              </a:rPr>
+              <a:t>grows</a:t>
+            </a:r>
+            <a:r>
+              <a:rPr sz="1200" b="0">
+                <a:solidFill>
+                  <a:srgbClr val="282828"/>
+                </a:solidFill>
+                <a:latin typeface="Arial"/>
+              </a:rPr>
+              <a:t> the harder the optimizer is pushed — the signature of an optimizer mining its model, worth reusing as a diagnostic anywhere a design model is cheaper than the simulator it feeds.</a:t>
+            </a:r>
+          </a:p>
+          <a:p>
+            <a:pPr>
+              <a:spcAft>
+                <a:spcPts val="600"/>
+              </a:spcAft>
+            </a:pPr>
+            <a:r>
+              <a:rPr sz="1200" b="0">
+                <a:solidFill>
+                  <a:srgbClr val="282828"/>
+                </a:solidFill>
+                <a:latin typeface="Arial"/>
+              </a:rPr>
+              <a:t>•  The round-2 answer is the deformable mirrors: measured against the engine, they dig the segmented floor 4.6e-07 → 1.9e-07 and hold it under drift.</a:t>
+            </a:r>
+          </a:p>
+        </p:txBody>
+      </p:sp>
+    </p:spTree>
+  </p:cSld>
+  <p:clrMapOvr>
+    <a:masterClrMapping/>
+  </p:clrMapOvr>
+</p:sld>
+</file>
+
+<file path=ppt/slides/slide28.xml><?xml version="1.0" encoding="utf-8"?>
+<p:sld xmlns:a="http://schemas.openxmlformats.org/drawingml/2006/main" xmlns:p="http://schemas.openxmlformats.org/presentationml/2006/main" xmlns:r="http://schemas.openxmlformats.org/officeDocument/2006/relationships">
+  <p:cSld>
+    <p:spTree>
+      <p:nvGrpSpPr>
+        <p:cNvPr id="1" name=""/>
+        <p:cNvGrpSpPr/>
+        <p:nvPr/>
+      </p:nvGrpSpPr>
+      <p:grpSpPr/>
+      <p:sp>
+        <p:nvSpPr>
+          <p:cNvPr id="2" name="TextBox 1"/>
+          <p:cNvSpPr txBox="1"/>
+          <p:nvPr/>
+        </p:nvSpPr>
+        <p:spPr>
+          <a:xfrm>
+            <a:off x="411480" y="201168"/>
+            <a:ext cx="11368735" cy="914400"/>
+          </a:xfrm>
+          <a:prstGeom prst="rect">
+            <a:avLst/>
+          </a:prstGeom>
+          <a:noFill/>
+        </p:spPr>
+        <p:txBody>
+          <a:bodyPr wrap="square">
+            <a:spAutoFit/>
+          </a:bodyPr>
+          <a:lstStyle/>
+          <a:p>
+            <a:pPr>
+              <a:spcAft>
+                <a:spcPts val="400"/>
+              </a:spcAft>
+            </a:pPr>
+            <a:r>
+              <a:rPr sz="2400" b="1">
+                <a:solidFill>
+                  <a:srgbClr val="1F4E79"/>
+                </a:solidFill>
+                <a:latin typeface="Arial"/>
+              </a:rPr>
+              <a:t>What is not in this model</a:t>
+            </a:r>
+          </a:p>
+          <a:p>
+            <a:pPr>
+              <a:spcAft>
+                <a:spcPts val="0"/>
+              </a:spcAft>
+            </a:pPr>
+            <a:r>
+              <a:rPr sz="1250" b="0">
+                <a:solidFill>
+                  <a:srgbClr val="6E6E6E"/>
+                </a:solidFill>
+                <a:latin typeface="Arial"/>
+              </a:rPr>
+              <a:t>Stated, not omitted</a:t>
+            </a:r>
+          </a:p>
+        </p:txBody>
+      </p:sp>
+      <p:sp>
+        <p:nvSpPr>
+          <p:cNvPr id="3" name="Rectangle 2"/>
+          <p:cNvSpPr/>
+          <p:nvPr/>
+        </p:nvSpPr>
+        <p:spPr>
+          <a:xfrm>
+            <a:off x="411480" y="1133856"/>
+            <a:ext cx="11368735" cy="20320"/>
+          </a:xfrm>
+          <a:prstGeom prst="rect">
+            <a:avLst/>
+          </a:prstGeom>
+          <a:solidFill>
+            <a:srgbClr val="B8C6D4"/>
+          </a:solidFill>
+          <a:ln>
+            <a:noFill/>
+          </a:ln>
+          <a:effectLst/>
+        </p:spPr>
+        <p:style>
+          <a:lnRef idx="1">
+            <a:schemeClr val="accent1"/>
+          </a:lnRef>
+          <a:fillRef idx="3">
+            <a:schemeClr val="accent1"/>
+          </a:fillRef>
+          <a:effectRef idx="2">
+            <a:schemeClr val="accent1"/>
+          </a:effectRef>
+          <a:fontRef idx="minor">
+            <a:schemeClr val="lt1"/>
+          </a:fontRef>
+        </p:style>
+        <p:txBody>
+          <a:bodyPr rtlCol="0" anchor="ctr"/>
+          <a:lstStyle/>
+          <a:p>
+            <a:pPr algn="ctr"/>
+          </a:p>
+        </p:txBody>
+      </p:sp>
+      <p:sp>
+        <p:nvSpPr>
+          <p:cNvPr id="4" name="TextBox 3"/>
+          <p:cNvSpPr txBox="1"/>
+          <p:nvPr/>
+        </p:nvSpPr>
+        <p:spPr>
+          <a:xfrm>
+            <a:off x="411480" y="1298448"/>
+            <a:ext cx="11368735" cy="274320"/>
+          </a:xfrm>
+          <a:prstGeom prst="rect">
+            <a:avLst/>
+          </a:prstGeom>
+          <a:noFill/>
+        </p:spPr>
+        <p:txBody>
+          <a:bodyPr wrap="square">
+            <a:spAutoFit/>
+          </a:bodyPr>
+          <a:lstStyle/>
+          <a:p>
+            <a:pPr>
+              <a:spcAft>
+                <a:spcPts val="600"/>
+              </a:spcAft>
+            </a:pPr>
+            <a:r>
+              <a:rPr sz="1200" b="0">
+                <a:solidFill>
+                  <a:srgbClr val="282828"/>
+                </a:solidFill>
+                <a:latin typeface="Arial"/>
+              </a:rPr>
+              <a:t>•  </a:t>
+            </a:r>
+            <a:r>
+              <a:rPr sz="1200" b="1">
+                <a:solidFill>
+                  <a:srgbClr val="282828"/>
+                </a:solidFill>
+                <a:latin typeface="Arial"/>
+              </a:rPr>
+              <a:t>The coronagraph masks are clear-pupil designs.</a:t>
+            </a:r>
+            <a:r>
+              <a:rPr sz="1200" b="0">
+                <a:solidFill>
+                  <a:srgbClr val="282828"/>
+                </a:solidFill>
+                <a:latin typeface="Arial"/>
+              </a:rPr>
+              <a:t>  Co-optimising apodizer, occulter and Lyot for the segmented aperture is known, separate work; the open-loop 1298× is the size of that prize.</a:t>
+            </a:r>
+          </a:p>
+          <a:p>
+            <a:pPr>
+              <a:spcAft>
+                <a:spcPts val="600"/>
+              </a:spcAft>
+            </a:pPr>
+            <a:r>
+              <a:rPr sz="1200" b="0">
+                <a:solidFill>
+                  <a:srgbClr val="282828"/>
+                </a:solidFill>
+                <a:latin typeface="Arial"/>
+              </a:rPr>
+              <a:t>•  </a:t>
+            </a:r>
+            <a:r>
+              <a:rPr sz="1200" b="1">
+                <a:solidFill>
+                  <a:srgbClr val="282828"/>
+                </a:solidFill>
+                <a:latin typeface="Arial"/>
+              </a:rPr>
+              <a:t>Monochromatic, at 500 nm.</a:t>
+            </a:r>
+            <a:r>
+              <a:rPr sz="1200" b="0">
+                <a:solidFill>
+                  <a:srgbClr val="282828"/>
+                </a:solidFill>
+                <a:latin typeface="Arial"/>
+              </a:rPr>
+              <a:t>  The bandwidth and polarization layers exist on the testbed substrate and are configuration away, not new machinery.</a:t>
+            </a:r>
+          </a:p>
+          <a:p>
+            <a:pPr>
+              <a:spcAft>
+                <a:spcPts val="600"/>
+              </a:spcAft>
+            </a:pPr>
+            <a:r>
+              <a:rPr sz="1200" b="0">
+                <a:solidFill>
+                  <a:srgbClr val="282828"/>
+                </a:solidFill>
+                <a:latin typeface="Arial"/>
+              </a:rPr>
+              <a:t>•  </a:t>
+            </a:r>
+            <a:r>
+              <a:rPr sz="1200" b="1">
+                <a:solidFill>
+                  <a:srgbClr val="282828"/>
+                </a:solidFill>
+                <a:latin typeface="Arial"/>
+              </a:rPr>
+              <a:t>The metrology measurement is simulated from its validated linear model</a:t>
+            </a:r>
+            <a:r>
+              <a:rPr sz="1200" b="0">
+                <a:solidFill>
+                  <a:srgbClr val="282828"/>
+                </a:solidFill>
+                <a:latin typeface="Arial"/>
+              </a:rPr>
+              <a:t> plus noise, not a second engine trace of the truss; the engine holds the truss points rigid, so the model is the only figure source either way.</a:t>
+            </a:r>
+          </a:p>
+          <a:p>
+            <a:pPr>
+              <a:spcAft>
+                <a:spcPts val="600"/>
+              </a:spcAft>
+            </a:pPr>
+            <a:r>
+              <a:rPr sz="1200" b="0">
+                <a:solidFill>
+                  <a:srgbClr val="282828"/>
+                </a:solidFill>
+                <a:latin typeface="Arial"/>
+              </a:rPr>
+              <a:t>•  </a:t>
+            </a:r>
+            <a:r>
+              <a:rPr sz="1200" b="1">
+                <a:solidFill>
+                  <a:srgbClr val="282828"/>
+                </a:solidFill>
+                <a:latin typeface="Arial"/>
+              </a:rPr>
+              <a:t>DM spacing</a:t>
+            </a:r>
+            <a:r>
+              <a:rPr sz="1200" b="0">
+                <a:solidFill>
+                  <a:srgbClr val="282828"/>
+                </a:solidFill>
+                <a:latin typeface="Arial"/>
+              </a:rPr>
+              <a:t> (47 mm pupil, 0.15 m apart) limits amplitude-speckle authority; the testbed's wider spacing is the knob, and re-running the chain at another spacing is parameter work.</a:t>
+            </a:r>
+          </a:p>
+        </p:txBody>
+      </p:sp>
+    </p:spTree>
+  </p:cSld>
+  <p:clrMapOvr>
+    <a:masterClrMapping/>
+  </p:clrMapOvr>
+</p:sld>
+</file>
+
+<file path=ppt/slides/slide29.xml><?xml version="1.0" encoding="utf-8"?>
+<p:sld xmlns:a="http://schemas.openxmlformats.org/drawingml/2006/main" xmlns:p="http://schemas.openxmlformats.org/presentationml/2006/main" xmlns:r="http://schemas.openxmlformats.org/officeDocument/2006/relationships">
+  <p:cSld>
+    <p:spTree>
+      <p:nvGrpSpPr>
+        <p:cNvPr id="1" name=""/>
+        <p:cNvGrpSpPr/>
+        <p:nvPr/>
+      </p:nvGrpSpPr>
+      <p:grpSpPr/>
+      <p:sp>
+        <p:nvSpPr>
+          <p:cNvPr id="2" name="TextBox 1"/>
+          <p:cNvSpPr txBox="1"/>
+          <p:nvPr/>
+        </p:nvSpPr>
+        <p:spPr>
+          <a:xfrm>
+            <a:off x="411480" y="201168"/>
+            <a:ext cx="11368735" cy="914400"/>
+          </a:xfrm>
+          <a:prstGeom prst="rect">
+            <a:avLst/>
+          </a:prstGeom>
+          <a:noFill/>
+        </p:spPr>
+        <p:txBody>
+          <a:bodyPr wrap="square">
+            <a:spAutoFit/>
+          </a:bodyPr>
+          <a:lstStyle/>
+          <a:p>
+            <a:pPr>
+              <a:spcAft>
+                <a:spcPts val="400"/>
+              </a:spcAft>
+            </a:pPr>
+            <a:r>
+              <a:rPr sz="2400" b="1">
+                <a:solidFill>
+                  <a:srgbClr val="1F4E79"/>
+                </a:solidFill>
+                <a:latin typeface="Arial"/>
+              </a:rPr>
+              <a:t>How to reproduce</a:t>
+            </a:r>
+          </a:p>
+          <a:p>
+            <a:pPr>
+              <a:spcAft>
+                <a:spcPts val="0"/>
+              </a:spcAft>
+            </a:pPr>
+            <a:r>
+              <a:rPr sz="1250" b="0">
+                <a:solidFill>
+                  <a:srgbClr val="6E6E6E"/>
+                </a:solidFill>
+                <a:latin typeface="Arial"/>
+              </a:rPr>
+              <a:t>Every number on these slides comes from these runs</a:t>
+            </a:r>
+          </a:p>
+        </p:txBody>
+      </p:sp>
+      <p:sp>
+        <p:nvSpPr>
+          <p:cNvPr id="3" name="Rectangle 2"/>
+          <p:cNvSpPr/>
+          <p:nvPr/>
+        </p:nvSpPr>
+        <p:spPr>
+          <a:xfrm>
+            <a:off x="411480" y="1133856"/>
+            <a:ext cx="11368735" cy="20320"/>
+          </a:xfrm>
+          <a:prstGeom prst="rect">
+            <a:avLst/>
+          </a:prstGeom>
+          <a:solidFill>
+            <a:srgbClr val="B8C6D4"/>
+          </a:solidFill>
+          <a:ln>
+            <a:noFill/>
+          </a:ln>
+          <a:effectLst/>
+        </p:spPr>
+        <p:style>
+          <a:lnRef idx="1">
+            <a:schemeClr val="accent1"/>
+          </a:lnRef>
+          <a:fillRef idx="3">
+            <a:schemeClr val="accent1"/>
+          </a:fillRef>
+          <a:effectRef idx="2">
+            <a:schemeClr val="accent1"/>
+          </a:effectRef>
+          <a:fontRef idx="minor">
+            <a:schemeClr val="lt1"/>
+          </a:fontRef>
+        </p:style>
+        <p:txBody>
+          <a:bodyPr rtlCol="0" anchor="ctr"/>
+          <a:lstStyle/>
+          <a:p>
+            <a:pPr algn="ctr"/>
+          </a:p>
+        </p:txBody>
+      </p:sp>
+      <p:sp>
+        <p:nvSpPr>
+          <p:cNvPr id="4" name="TextBox 3"/>
+          <p:cNvSpPr txBox="1"/>
+          <p:nvPr/>
+        </p:nvSpPr>
+        <p:spPr>
+          <a:xfrm>
+            <a:off x="411480" y="1298448"/>
+            <a:ext cx="11368735" cy="274320"/>
+          </a:xfrm>
+          <a:prstGeom prst="rect">
+            <a:avLst/>
+          </a:prstGeom>
+          <a:noFill/>
+        </p:spPr>
+        <p:txBody>
+          <a:bodyPr wrap="square">
+            <a:spAutoFit/>
+          </a:bodyPr>
+          <a:lstStyle/>
+          <a:p>
+            <a:pPr>
+              <a:spcAft>
+                <a:spcPts val="600"/>
+              </a:spcAft>
+            </a:pPr>
+            <a:r>
+              <a:rPr sz="1200" b="0">
+                <a:solidFill>
+                  <a:srgbClr val="282828"/>
+                </a:solidFill>
+                <a:latin typeface="Arial"/>
+              </a:rPr>
               <a:t>•  Round 1 (frozen): s1_layout_search, s1_telescope, s2_segmentation — the telescope and the segmented primary.</a:t>
             </a:r>
           </a:p>
@@ -9546,6 +10187,22 @@
                 <a:latin typeface="Arial"/>
               </a:rPr>
               <a:t>•  r4_timeseries — the closed-loop drift series.</a:t>
+            </a:r>
+          </a:p>
+          <a:p>
+            <a:pPr>
+              <a:spcAft>
+                <a:spcPts val="600"/>
+              </a:spcAft>
+            </a:pPr>
+            <a:r>
+              <a:rPr sz="1200" b="0">
+                <a:solidFill>
+                  <a:srgbClr val="282828"/>
+                </a:solidFill>
+                <a:latin typeface="Arial"/>
+              </a:rPr>
+              <a:t>•  cf_chain + cf1_families..cf4_physics — the coronagraph-family campaign; cf3d_deepdig + cf3d_stations — the restart ladder and its station graphics.</a:t>
             </a:r>
           </a:p>
           <a:p>
@@ -9574,7 +10231,7 @@
         </p:nvSpPr>
         <p:spPr>
           <a:xfrm>
-            <a:off x="411480" y="3364992"/>
+            <a:off x="411480" y="3901440"/>
             <a:ext cx="11368735" cy="274320"/>
           </a:xfrm>
           <a:prstGeom prst="rect">

</xml_diff>

<commit_message>
e2e6m CF5b: JWST-class drift on the dug state -- open decays 4.5 decades/day, loop holds 2e-9; CF3e (unapodized d=1.10) launched
Gate: frame-1 closed contrast reproduces the CF3d floor to 1.001x.
RBCS holds state 1.2 nm vs 23 nm drift; guarded EFC hold 25/25 steps.
CF3e: apod none, circular stop asserted at the apodizer plane, thru
0.745 vs apl 0.091 (8.2x) -- ladder running detached.

Co-Authored-By: Claude Fable 5 <noreply@anthropic.com>
</commit_message>
<xml_diff>
--- a/mmacos/templates/80_end_to_end/e2e6m_r2/deck_e2e6m_r2.pptx
+++ b/mmacos/templates/80_end_to_end/e2e6m_r2/deck_e2e6m_r2.pptx
@@ -5937,7 +5937,7 @@
                 </a:solidFill>
                 <a:latin typeface="Arial"/>
               </a:rPr>
-              <a:t>The loop closes</a:t>
+              <a:t>The restart ladder</a:t>
             </a:r>
           </a:p>
           <a:p>
@@ -5953,7 +5953,7 @@
                 </a:solidFill>
                 <a:latin typeface="Arial"/>
               </a:rPr>
-              <a:t>The dark zone held under drift: 2.5e-07 against 1.7e-06 open-loop</a:t>
+              <a:t>The controller was the bottleneck: 1.2e-06 → 1.13e-09 at d = 1.10 m, with the substrate still pricing 3.5e-11</a:t>
             </a:r>
           </a:p>
         </p:txBody>
@@ -6045,16 +6045,16 @@
                 </a:solidFill>
                 <a:latin typeface="Arial"/>
               </a:rPr>
-              <a:t>The drift.</a:t>
-            </a:r>
-            <a:r>
-              <a:rPr sz="1200" b="0">
-                <a:solidFill>
-                  <a:srgbClr val="282828"/>
-                </a:solidFill>
-                <a:latin typeface="Arial"/>
-              </a:rPr>
-              <a:t> 41 frames over 7 minutes: random walk plus correlated drift on every freedom of all 19 segments, played through the engine on the full train.</a:t>
+              <a:t>The recipe (rinse and repeat):</a:t>
+            </a:r>
+            <a:r>
+              <a:rPr sz="1200" b="0">
+                <a:solidFill>
+                  <a:srgbClr val="282828"/>
+                </a:solidFill>
+                <a:latin typeface="Arial"/>
+              </a:rPr>
+              <a:t> EFC to a floor, relinearize about the dug state, restart at that floor.  10 digging rounds over 4.6 h unattended; 3 stall rounds then prove the plateau — no accepted step at any Tikhonov α down to 1e-10, and two independent G measurements at the unchanged state agree to four digits.</a:t>
             </a:r>
           </a:p>
           <a:p>
@@ -6079,16 +6079,16 @@
                 </a:solidFill>
                 <a:latin typeface="Arial"/>
               </a:rPr>
-              <a:t>The rigid-body loop.</a:t>
-            </a:r>
-            <a:r>
-              <a:rPr sz="1200" b="0">
-                <a:solidFill>
-                  <a:srgbClr val="282828"/>
-                </a:solidFill>
-                <a:latin typeface="Arial"/>
-              </a:rPr>
-              <a:t> Edge and gauge readings, a weighted least-squares estimate, an integrating controller on all six freedoms of every segment: the state residual holds at 0.36 nm while the open-loop drift grows to 2.9 nm.</a:t>
+              <a:t>What it removed:</a:t>
+            </a:r>
+            <a:r>
+              <a:rPr sz="1200" b="0">
+                <a:solidFill>
+                  <a:srgbClr val="282828"/>
+                </a:solidFill>
+                <a:latin typeface="Arial"/>
+              </a:rPr>
+              <a:t> the single-linearization stall at 9.0e-07 (the spacing sweep's d = 1.10 m entry) — four decades above the linear bound at this spacing.</a:t>
             </a:r>
           </a:p>
           <a:p>
@@ -6113,91 +6113,23 @@
                 </a:solidFill>
                 <a:latin typeface="Arial"/>
               </a:rPr>
-              <a:t>The DM loop.</a:t>
-            </a:r>
-            <a:r>
-              <a:rPr sz="1200" b="0">
-                <a:solidFill>
-                  <a:srgbClr val="282828"/>
-                </a:solidFill>
-                <a:latin typeface="Arial"/>
-              </a:rPr>
-              <a:t> The measured actuator Jacobian digs the dark zone 4.6e-07 → 1.9e-07, then a damped re-solve at each scored frame holds it: 1.91e-07 → 2.46e-07 closed, against 4.65e-07 → 1.72e-06 open.</a:t>
-            </a:r>
-          </a:p>
-          <a:p>
-            <a:pPr>
-              <a:spcAft>
-                <a:spcPts val="600"/>
-              </a:spcAft>
-            </a:pPr>
-            <a:r>
-              <a:rPr sz="1200" b="0">
-                <a:solidFill>
-                  <a:srgbClr val="282828"/>
-                </a:solidFill>
-                <a:latin typeface="Arial"/>
-              </a:rPr>
-              <a:t>•  </a:t>
-            </a:r>
-            <a:r>
-              <a:rPr sz="1200" b="1">
-                <a:solidFill>
-                  <a:srgbClr val="282828"/>
-                </a:solidFill>
-                <a:latin typeface="Arial"/>
-              </a:rPr>
-              <a:t>The honest line.</a:t>
-            </a:r>
-            <a:r>
-              <a:rPr sz="1200" b="0">
-                <a:solidFill>
-                  <a:srgbClr val="282828"/>
-                </a:solidFill>
-                <a:latin typeface="Arial"/>
-              </a:rPr>
-              <a:t> Closed-loop pupil wavefront is larger than uncorrected — that is the DM stroke the contrast is bought with, and the figure labels it as such.</a:t>
-            </a:r>
-          </a:p>
-          <a:p>
-            <a:pPr>
-              <a:spcAft>
-                <a:spcPts val="600"/>
-              </a:spcAft>
-            </a:pPr>
-            <a:r>
-              <a:rPr sz="1200" b="0">
-                <a:solidFill>
-                  <a:srgbClr val="282828"/>
-                </a:solidFill>
-                <a:latin typeface="Arial"/>
-              </a:rPr>
-              <a:t>•  </a:t>
-            </a:r>
-            <a:r>
-              <a:rPr sz="1200" b="1">
-                <a:solidFill>
-                  <a:srgbClr val="282828"/>
-                </a:solidFill>
-                <a:latin typeface="Arial"/>
-              </a:rPr>
-              <a:t>Toned down 10x (0.3 nm-class drift): the hold is the mechanization's.</a:t>
-            </a:r>
-            <a:r>
-              <a:rPr sz="1200" b="0">
-                <a:solidFill>
-                  <a:srgbClr val="282828"/>
-                </a:solidFill>
-                <a:latin typeface="Arial"/>
-              </a:rPr>
-              <a:t>  The open loop no longer degrades (4.65e-07 -&gt; 4.63e-07) while the closed loop holds 2.46e-07 — identical to the 3 nm hold: the ~2.5e-07 level is the loop's own noise-injection floor, and control cadence/gain becomes the knob at low drift (flagged, not retuned; the estimator still tracks at 7.2e-11 against 3.0e-10 of drift).</a:t>
+              <a:t>What remains, priced:</a:t>
+            </a:r>
+            <a:r>
+              <a:rPr sz="1200" b="0">
+                <a:solidFill>
+                  <a:srgbClr val="282828"/>
+                </a:solidFill>
+                <a:latin typeface="Arial"/>
+              </a:rPr>
+              <a:t> la(G) holds 2.0e-11–3.8e-11 at every dug state; the plateau at 1.13e-09 is the monotone full-Tikhonov step rule — the measured case for FALCO-grade step machinery.  Strokes end at 33 nm rms of the 50 nm bound.</a:t>
             </a:r>
           </a:p>
         </p:txBody>
       </p:sp>
       <p:pic>
         <p:nvPicPr>
-          <p:cNvPr id="5" name="Picture 4" descr="r4_series.png"/>
+          <p:cNvPr id="5" name="Picture 4" descr="cf3d_dig.png"/>
           <p:cNvPicPr>
             <a:picLocks noChangeAspect="1"/>
           </p:cNvPicPr>
@@ -6211,8 +6143,8 @@
         </p:blipFill>
         <p:spPr>
           <a:xfrm>
-            <a:off x="7066277" y="1298448"/>
-            <a:ext cx="4064004" cy="3903472"/>
+            <a:off x="6461474" y="1298448"/>
+            <a:ext cx="5273611" cy="3555492"/>
           </a:xfrm>
           <a:prstGeom prst="rect">
             <a:avLst/>
@@ -6227,8 +6159,8 @@
         </p:nvSpPr>
         <p:spPr>
           <a:xfrm>
-            <a:off x="6400800" y="5220208"/>
-            <a:ext cx="5394960" cy="394208"/>
+            <a:off x="6400800" y="4872228"/>
+            <a:ext cx="5394960" cy="559307"/>
           </a:xfrm>
           <a:prstGeom prst="rect">
             <a:avLst/>
@@ -6253,7 +6185,7 @@
                 </a:solidFill>
                 <a:latin typeface="Arial"/>
               </a:rPr>
-              <a:t>State, wavefront and contrast against time.  The contrast panel is the payoff: open loop degrades 3.7×; the closed loop holds.</a:t>
+              <a:t>The ladder: achieved floor by restart round against the linear-achievable substrate re-measured at every dug state.  The early linear claims (rounds 1–2) are flat-state optimism; they settle once the linearization is honest.</a:t>
             </a:r>
           </a:p>
         </p:txBody>
@@ -6310,7 +6242,7 @@
                 </a:solidFill>
                 <a:latin typeface="Arial"/>
               </a:rPr>
-              <a:t>The restart ladder</a:t>
+              <a:t>Inside the dig, station by station</a:t>
             </a:r>
           </a:p>
           <a:p>
@@ -6326,7 +6258,7 @@
                 </a:solidFill>
                 <a:latin typeface="Arial"/>
               </a:rPr>
-              <a:t>The controller was the bottleneck: 1.2e-06 → 1.13e-09 at d = 1.10 m, with the substrate still pricing 3.5e-11</a:t>
+              <a:t>The controller does the gap work: the DM commands imprint the hex-gap lattice</a:t>
             </a:r>
           </a:p>
         </p:txBody>
@@ -6375,134 +6307,9 @@
           </a:p>
         </p:txBody>
       </p:sp>
-      <p:sp>
-        <p:nvSpPr>
-          <p:cNvPr id="4" name="TextBox 3"/>
-          <p:cNvSpPr txBox="1"/>
-          <p:nvPr/>
-        </p:nvSpPr>
-        <p:spPr>
-          <a:xfrm>
-            <a:off x="411480" y="1298448"/>
-            <a:ext cx="5806440" cy="274320"/>
-          </a:xfrm>
-          <a:prstGeom prst="rect">
-            <a:avLst/>
-          </a:prstGeom>
-          <a:noFill/>
-        </p:spPr>
-        <p:txBody>
-          <a:bodyPr wrap="square">
-            <a:spAutoFit/>
-          </a:bodyPr>
-          <a:lstStyle/>
-          <a:p>
-            <a:pPr>
-              <a:spcAft>
-                <a:spcPts val="600"/>
-              </a:spcAft>
-            </a:pPr>
-            <a:r>
-              <a:rPr sz="1200" b="0">
-                <a:solidFill>
-                  <a:srgbClr val="282828"/>
-                </a:solidFill>
-                <a:latin typeface="Arial"/>
-              </a:rPr>
-              <a:t>•  </a:t>
-            </a:r>
-            <a:r>
-              <a:rPr sz="1200" b="1">
-                <a:solidFill>
-                  <a:srgbClr val="282828"/>
-                </a:solidFill>
-                <a:latin typeface="Arial"/>
-              </a:rPr>
-              <a:t>The recipe (rinse and repeat):</a:t>
-            </a:r>
-            <a:r>
-              <a:rPr sz="1200" b="0">
-                <a:solidFill>
-                  <a:srgbClr val="282828"/>
-                </a:solidFill>
-                <a:latin typeface="Arial"/>
-              </a:rPr>
-              <a:t> EFC to a floor, relinearize about the dug state, restart at that floor.  10 digging rounds over 4.6 h unattended; 3 stall rounds then prove the plateau — no accepted step at any Tikhonov α down to 1e-10, and two independent G measurements at the unchanged state agree to four digits.</a:t>
-            </a:r>
-          </a:p>
-          <a:p>
-            <a:pPr>
-              <a:spcAft>
-                <a:spcPts val="600"/>
-              </a:spcAft>
-            </a:pPr>
-            <a:r>
-              <a:rPr sz="1200" b="0">
-                <a:solidFill>
-                  <a:srgbClr val="282828"/>
-                </a:solidFill>
-                <a:latin typeface="Arial"/>
-              </a:rPr>
-              <a:t>•  </a:t>
-            </a:r>
-            <a:r>
-              <a:rPr sz="1200" b="1">
-                <a:solidFill>
-                  <a:srgbClr val="282828"/>
-                </a:solidFill>
-                <a:latin typeface="Arial"/>
-              </a:rPr>
-              <a:t>What it removed:</a:t>
-            </a:r>
-            <a:r>
-              <a:rPr sz="1200" b="0">
-                <a:solidFill>
-                  <a:srgbClr val="282828"/>
-                </a:solidFill>
-                <a:latin typeface="Arial"/>
-              </a:rPr>
-              <a:t> the single-linearization stall at 9.0e-07 (the spacing sweep's d = 1.10 m entry) — four decades above the linear bound at this spacing.</a:t>
-            </a:r>
-          </a:p>
-          <a:p>
-            <a:pPr>
-              <a:spcAft>
-                <a:spcPts val="600"/>
-              </a:spcAft>
-            </a:pPr>
-            <a:r>
-              <a:rPr sz="1200" b="0">
-                <a:solidFill>
-                  <a:srgbClr val="282828"/>
-                </a:solidFill>
-                <a:latin typeface="Arial"/>
-              </a:rPr>
-              <a:t>•  </a:t>
-            </a:r>
-            <a:r>
-              <a:rPr sz="1200" b="1">
-                <a:solidFill>
-                  <a:srgbClr val="282828"/>
-                </a:solidFill>
-                <a:latin typeface="Arial"/>
-              </a:rPr>
-              <a:t>What remains, priced:</a:t>
-            </a:r>
-            <a:r>
-              <a:rPr sz="1200" b="0">
-                <a:solidFill>
-                  <a:srgbClr val="282828"/>
-                </a:solidFill>
-                <a:latin typeface="Arial"/>
-              </a:rPr>
-              <a:t> la(G) holds 2.0e-11–3.8e-11 at every dug state; the plateau at 1.13e-09 is the monotone full-Tikhonov step rule — the measured case for FALCO-grade step machinery.  Strokes end at 33 nm rms of the 50 nm bound.</a:t>
-            </a:r>
-          </a:p>
-        </p:txBody>
-      </p:sp>
       <p:pic>
         <p:nvPicPr>
-          <p:cNvPr id="5" name="Picture 4" descr="cf3d_dig.png"/>
+          <p:cNvPr id="4" name="Picture 3" descr="cf3d_stations_wide.png"/>
           <p:cNvPicPr>
             <a:picLocks noChangeAspect="1"/>
           </p:cNvPicPr>
@@ -6516,8 +6323,8 @@
         </p:blipFill>
         <p:spPr>
           <a:xfrm>
-            <a:off x="6461474" y="1298448"/>
-            <a:ext cx="5273611" cy="3555492"/>
+            <a:off x="1728779" y="1298448"/>
+            <a:ext cx="8734135" cy="2166112"/>
           </a:xfrm>
           <a:prstGeom prst="rect">
             <a:avLst/>
@@ -6526,14 +6333,14 @@
       </p:pic>
       <p:sp>
         <p:nvSpPr>
-          <p:cNvPr id="6" name="TextBox 5"/>
+          <p:cNvPr id="5" name="TextBox 4"/>
           <p:cNvSpPr txBox="1"/>
           <p:nvPr/>
         </p:nvSpPr>
         <p:spPr>
           <a:xfrm>
-            <a:off x="6400800" y="4872228"/>
-            <a:ext cx="5394960" cy="559307"/>
+            <a:off x="411480" y="3482848"/>
+            <a:ext cx="11368735" cy="394208"/>
           </a:xfrm>
           <a:prstGeom prst="rect">
             <a:avLst/>
@@ -6558,7 +6365,161 @@
                 </a:solidFill>
                 <a:latin typeface="Arial"/>
               </a:rPr>
-              <a:t>The ladder: achieved floor by restart round against the linear-achievable substrate re-measured at every dug state.  The early linear claims (rounds 1–2) are flat-state optimism; they settle once the linearization is honest.</a:t>
+              <a:t>Seven planes, DMs flat against the dug state: pupil, apodizer, FPM before/after the occulter, Lyot before/after the stop, science-plane contrast.  The in-walk dark-zone means reproduce the scored record exactly (1.22e-06 / 1.13e-09).</a:t>
+            </a:r>
+          </a:p>
+        </p:txBody>
+      </p:sp>
+      <p:sp>
+        <p:nvSpPr>
+          <p:cNvPr id="6" name="TextBox 5"/>
+          <p:cNvSpPr txBox="1"/>
+          <p:nvPr/>
+        </p:nvSpPr>
+        <p:spPr>
+          <a:xfrm>
+            <a:off x="411480" y="3913632"/>
+            <a:ext cx="11368735" cy="274320"/>
+          </a:xfrm>
+          <a:prstGeom prst="rect">
+            <a:avLst/>
+          </a:prstGeom>
+          <a:noFill/>
+        </p:spPr>
+        <p:txBody>
+          <a:bodyPr wrap="square">
+            <a:spAutoFit/>
+          </a:bodyPr>
+          <a:lstStyle/>
+          <a:p>
+            <a:pPr>
+              <a:spcAft>
+                <a:spcPts val="600"/>
+              </a:spcAft>
+            </a:pPr>
+            <a:r>
+              <a:rPr sz="1200" b="0">
+                <a:solidFill>
+                  <a:srgbClr val="282828"/>
+                </a:solidFill>
+                <a:latin typeface="Arial"/>
+              </a:rPr>
+              <a:t>•  </a:t>
+            </a:r>
+            <a:r>
+              <a:rPr sz="1200" b="1">
+                <a:solidFill>
+                  <a:srgbClr val="282828"/>
+                </a:solidFill>
+                <a:latin typeface="Arial"/>
+              </a:rPr>
+              <a:t>Reading the strip:</a:t>
+            </a:r>
+            <a:r>
+              <a:rPr sz="1200" b="0">
+                <a:solidFill>
+                  <a:srgbClr val="282828"/>
+                </a:solidFill>
+                <a:latin typeface="Arial"/>
+              </a:rPr>
+              <a:t> the flat row's segment-lattice speckle becomes the dug row's sculpted field; the science panel shows the full 3–15 λ/D annular dark hole carved to the 1e-9 floor.</a:t>
+            </a:r>
+          </a:p>
+          <a:p>
+            <a:pPr>
+              <a:spcAft>
+                <a:spcPts val="600"/>
+              </a:spcAft>
+            </a:pPr>
+            <a:r>
+              <a:rPr sz="1200" b="0">
+                <a:solidFill>
+                  <a:srgbClr val="282828"/>
+                </a:solidFill>
+                <a:latin typeface="Arial"/>
+              </a:rPr>
+              <a:t>•  </a:t>
+            </a:r>
+            <a:r>
+              <a:rPr sz="1200" b="1">
+                <a:solidFill>
+                  <a:srgbClr val="282828"/>
+                </a:solidFill>
+                <a:latin typeface="Arial"/>
+              </a:rPr>
+              <a:t>Two measured readables:</a:t>
+            </a:r>
+            <a:r>
+              <a:rPr sz="1200" b="0">
+                <a:solidFill>
+                  <a:srgbClr val="282828"/>
+                </a:solidFill>
+                <a:latin typeface="Arial"/>
+              </a:rPr>
+              <a:t> DM1's command map carries the hex-gap lattice — the DMs are doing the gap work themselves (the no-apodizer A/B is the scoped follow-on); and the 0.90 Lyot stop removes only ~0.1% of the post-FPM energy — this train's rejected light is interior gap structure, not edge rings.</a:t>
+            </a:r>
+          </a:p>
+        </p:txBody>
+      </p:sp>
+      <p:pic>
+        <p:nvPicPr>
+          <p:cNvPr id="7" name="Picture 6" descr="cf3d_dm_state.png"/>
+          <p:cNvPicPr>
+            <a:picLocks noChangeAspect="1"/>
+          </p:cNvPicPr>
+          <p:nvPr/>
+        </p:nvPicPr>
+        <p:blipFill>
+          <a:blip r:embed="rId3"/>
+          <a:stretch>
+            <a:fillRect/>
+          </a:stretch>
+        </p:blipFill>
+        <p:spPr>
+          <a:xfrm>
+            <a:off x="4702699" y="5221224"/>
+            <a:ext cx="2786296" cy="1243075"/>
+          </a:xfrm>
+          <a:prstGeom prst="rect">
+            <a:avLst/>
+          </a:prstGeom>
+        </p:spPr>
+      </p:pic>
+      <p:sp>
+        <p:nvSpPr>
+          <p:cNvPr id="8" name="TextBox 7"/>
+          <p:cNvSpPr txBox="1"/>
+          <p:nvPr/>
+        </p:nvSpPr>
+        <p:spPr>
+          <a:xfrm>
+            <a:off x="411480" y="6482588"/>
+            <a:ext cx="11368735" cy="229107"/>
+          </a:xfrm>
+          <a:prstGeom prst="rect">
+            <a:avLst/>
+          </a:prstGeom>
+          <a:noFill/>
+        </p:spPr>
+        <p:txBody>
+          <a:bodyPr wrap="square">
+            <a:spAutoFit/>
+          </a:bodyPr>
+          <a:lstStyle/>
+          <a:p>
+            <a:pPr algn="ctr">
+              <a:spcAft>
+                <a:spcPts val="0"/>
+              </a:spcAft>
+            </a:pPr>
+            <a:r>
+              <a:rPr sz="1000" b="0">
+                <a:solidFill>
+                  <a:srgbClr val="6E6E6E"/>
+                </a:solidFill>
+                <a:latin typeface="Arial"/>
+              </a:rPr>
+              <a:t>The dug command state: DM1 imprints the gap lattice; strokes ~33 nm rms, peaks ~160 nm.</a:t>
             </a:r>
           </a:p>
         </p:txBody>
@@ -6615,7 +6576,7 @@
                 </a:solidFill>
                 <a:latin typeface="Arial"/>
               </a:rPr>
-              <a:t>Inside the dig, station by station</a:t>
+              <a:t>The loop closes</a:t>
             </a:r>
           </a:p>
           <a:p>
@@ -6631,7 +6592,7 @@
                 </a:solidFill>
                 <a:latin typeface="Arial"/>
               </a:rPr>
-              <a:t>The controller does the gap work: the DM commands imprint the hex-gap lattice</a:t>
+              <a:t>JWST-class drift on the dug dark hole: open loop decays 4.5 decades in a day; the loop holds 2.0e-09</a:t>
             </a:r>
           </a:p>
         </p:txBody>
@@ -6680,9 +6641,168 @@
           </a:p>
         </p:txBody>
       </p:sp>
+      <p:sp>
+        <p:nvSpPr>
+          <p:cNvPr id="4" name="TextBox 3"/>
+          <p:cNvSpPr txBox="1"/>
+          <p:nvPr/>
+        </p:nvSpPr>
+        <p:spPr>
+          <a:xfrm>
+            <a:off x="411480" y="1298448"/>
+            <a:ext cx="5806440" cy="274320"/>
+          </a:xfrm>
+          <a:prstGeom prst="rect">
+            <a:avLst/>
+          </a:prstGeom>
+          <a:noFill/>
+        </p:spPr>
+        <p:txBody>
+          <a:bodyPr wrap="square">
+            <a:spAutoFit/>
+          </a:bodyPr>
+          <a:lstStyle/>
+          <a:p>
+            <a:pPr>
+              <a:spcAft>
+                <a:spcPts val="600"/>
+              </a:spcAft>
+            </a:pPr>
+            <a:r>
+              <a:rPr sz="1200" b="0">
+                <a:solidFill>
+                  <a:srgbClr val="282828"/>
+                </a:solidFill>
+                <a:latin typeface="Arial"/>
+              </a:rPr>
+              <a:t>•  </a:t>
+            </a:r>
+            <a:r>
+              <a:rPr sz="1200" b="1">
+                <a:solidFill>
+                  <a:srgbClr val="282828"/>
+                </a:solidFill>
+                <a:latin typeface="Arial"/>
+              </a:rPr>
+              <a:t>The series starts at the new solution</a:t>
+            </a:r>
+            <a:r>
+              <a:rPr sz="1200" b="0">
+                <a:solidFill>
+                  <a:srgbClr val="282828"/>
+                </a:solidFill>
+                <a:latin typeface="Arial"/>
+              </a:rPr>
+              <a:t> — frame one reproduces the CF3d floor to 1.001× (a built-in gate) — and runs a JWST-experience disturbance: a 10 nm/hr correlated drift ramp plus a 0.5 nm/step walk, 24 hours at 30-minute frames, on the d = 1.10 m train.</a:t>
+            </a:r>
+          </a:p>
+          <a:p>
+            <a:pPr>
+              <a:spcAft>
+                <a:spcPts val="600"/>
+              </a:spcAft>
+            </a:pPr>
+            <a:r>
+              <a:rPr sz="1200" b="0">
+                <a:solidFill>
+                  <a:srgbClr val="282828"/>
+                </a:solidFill>
+                <a:latin typeface="Arial"/>
+              </a:rPr>
+              <a:t>•  </a:t>
+            </a:r>
+            <a:r>
+              <a:rPr sz="1200" b="1">
+                <a:solidFill>
+                  <a:srgbClr val="282828"/>
+                </a:solidFill>
+                <a:latin typeface="Arial"/>
+              </a:rPr>
+              <a:t>Open loop (DMs frozen dug):</a:t>
+            </a:r>
+            <a:r>
+              <a:rPr sz="1200" b="0">
+                <a:solidFill>
+                  <a:srgbClr val="282828"/>
+                </a:solidFill>
+                <a:latin typeface="Arial"/>
+              </a:rPr>
+              <a:t> 1.1e-09 → 3.9e-05.  The first decade is lost to the first nanometre of drift — at 1e-9, continuous control is not optional.</a:t>
+            </a:r>
+          </a:p>
+          <a:p>
+            <a:pPr>
+              <a:spcAft>
+                <a:spcPts val="600"/>
+              </a:spcAft>
+            </a:pPr>
+            <a:r>
+              <a:rPr sz="1200" b="0">
+                <a:solidFill>
+                  <a:srgbClr val="282828"/>
+                </a:solidFill>
+                <a:latin typeface="Arial"/>
+              </a:rPr>
+              <a:t>•  </a:t>
+            </a:r>
+            <a:r>
+              <a:rPr sz="1200" b="1">
+                <a:solidFill>
+                  <a:srgbClr val="282828"/>
+                </a:solidFill>
+                <a:latin typeface="Arial"/>
+              </a:rPr>
+              <a:t>Closed loop:</a:t>
+            </a:r>
+            <a:r>
+              <a:rPr sz="1200" b="0">
+                <a:solidFill>
+                  <a:srgbClr val="282828"/>
+                </a:solidFill>
+                <a:latin typeface="Arial"/>
+              </a:rPr>
+              <a:t> the RBCS loop (BLUE + ridge, gain 0.5, six DOFs) holds the segment state at 1.2 nm against 23 nm of drift; a guarded EFC hold (one damped step per hour about the dug-state G; 25 steps taken, 0 reverted) keeps the dark zone at 2.0e-09 for the full day.</a:t>
+            </a:r>
+          </a:p>
+          <a:p>
+            <a:pPr>
+              <a:spcAft>
+                <a:spcPts val="600"/>
+              </a:spcAft>
+            </a:pPr>
+            <a:r>
+              <a:rPr sz="1200" b="0">
+                <a:solidFill>
+                  <a:srgbClr val="282828"/>
+                </a:solidFill>
+                <a:latin typeface="Arial"/>
+              </a:rPr>
+              <a:t>•  </a:t>
+            </a:r>
+            <a:r>
+              <a:rPr sz="1200" b="1">
+                <a:solidFill>
+                  <a:srgbClr val="282828"/>
+                </a:solidFill>
+                <a:latin typeface="Arial"/>
+              </a:rPr>
+              <a:t>Mechanization pedigree (the 3 nm series, kept in the record):</a:t>
+            </a:r>
+            <a:r>
+              <a:rPr sz="1200" b="0">
+                <a:solidFill>
+                  <a:srgbClr val="282828"/>
+                </a:solidFill>
+                <a:latin typeface="Arial"/>
+              </a:rPr>
+              <a:t> the held one-shot and the sliced-MMSE gain both fail measured (noise injection; spectral radius 1.154); BLUE + ridge + integrator is the loop that survives — and at 0.3 nm-class drift the ~2.5e-07 hold on the d = 0.15 train was the loop's own noise floor, which is why this series holds 100× deeper: it starts deeper, drifts slower, and the EFC hold is guarded.</a:t>
+            </a:r>
+          </a:p>
+        </p:txBody>
+      </p:sp>
       <p:pic>
         <p:nvPicPr>
-          <p:cNvPr id="4" name="Picture 3" descr="cf3d_stations_wide.png"/>
+          <p:cNvPr id="5" name="Picture 4" descr="cf5b_jwst.png"/>
           <p:cNvPicPr>
             <a:picLocks noChangeAspect="1"/>
           </p:cNvPicPr>
@@ -6696,8 +6816,8 @@
         </p:blipFill>
         <p:spPr>
           <a:xfrm>
-            <a:off x="1728779" y="1298448"/>
-            <a:ext cx="8734135" cy="2166112"/>
+            <a:off x="7085992" y="1298448"/>
+            <a:ext cx="4024575" cy="3903472"/>
           </a:xfrm>
           <a:prstGeom prst="rect">
             <a:avLst/>
@@ -6706,14 +6826,14 @@
       </p:pic>
       <p:sp>
         <p:nvSpPr>
-          <p:cNvPr id="5" name="TextBox 4"/>
+          <p:cNvPr id="6" name="TextBox 5"/>
           <p:cNvSpPr txBox="1"/>
           <p:nvPr/>
         </p:nvSpPr>
         <p:spPr>
           <a:xfrm>
-            <a:off x="411480" y="3482848"/>
-            <a:ext cx="11368735" cy="394208"/>
+            <a:off x="6400800" y="5220208"/>
+            <a:ext cx="5394960" cy="394208"/>
           </a:xfrm>
           <a:prstGeom prst="rect">
             <a:avLst/>
@@ -6738,161 +6858,7 @@
                 </a:solidFill>
                 <a:latin typeface="Arial"/>
               </a:rPr>
-              <a:t>Seven planes, DMs flat against the dug state: pupil, apodizer, FPM before/after the occulter, Lyot before/after the stop, science-plane contrast.  The in-walk dark-zone means reproduce the scored record exactly (1.22e-06 / 1.13e-09).</a:t>
-            </a:r>
-          </a:p>
-        </p:txBody>
-      </p:sp>
-      <p:sp>
-        <p:nvSpPr>
-          <p:cNvPr id="6" name="TextBox 5"/>
-          <p:cNvSpPr txBox="1"/>
-          <p:nvPr/>
-        </p:nvSpPr>
-        <p:spPr>
-          <a:xfrm>
-            <a:off x="411480" y="3913632"/>
-            <a:ext cx="11368735" cy="274320"/>
-          </a:xfrm>
-          <a:prstGeom prst="rect">
-            <a:avLst/>
-          </a:prstGeom>
-          <a:noFill/>
-        </p:spPr>
-        <p:txBody>
-          <a:bodyPr wrap="square">
-            <a:spAutoFit/>
-          </a:bodyPr>
-          <a:lstStyle/>
-          <a:p>
-            <a:pPr>
-              <a:spcAft>
-                <a:spcPts val="600"/>
-              </a:spcAft>
-            </a:pPr>
-            <a:r>
-              <a:rPr sz="1200" b="0">
-                <a:solidFill>
-                  <a:srgbClr val="282828"/>
-                </a:solidFill>
-                <a:latin typeface="Arial"/>
-              </a:rPr>
-              <a:t>•  </a:t>
-            </a:r>
-            <a:r>
-              <a:rPr sz="1200" b="1">
-                <a:solidFill>
-                  <a:srgbClr val="282828"/>
-                </a:solidFill>
-                <a:latin typeface="Arial"/>
-              </a:rPr>
-              <a:t>Reading the strip:</a:t>
-            </a:r>
-            <a:r>
-              <a:rPr sz="1200" b="0">
-                <a:solidFill>
-                  <a:srgbClr val="282828"/>
-                </a:solidFill>
-                <a:latin typeface="Arial"/>
-              </a:rPr>
-              <a:t> the flat row's segment-lattice speckle becomes the dug row's sculpted field; the science panel shows the full 3–15 λ/D annular dark hole carved to the 1e-9 floor.</a:t>
-            </a:r>
-          </a:p>
-          <a:p>
-            <a:pPr>
-              <a:spcAft>
-                <a:spcPts val="600"/>
-              </a:spcAft>
-            </a:pPr>
-            <a:r>
-              <a:rPr sz="1200" b="0">
-                <a:solidFill>
-                  <a:srgbClr val="282828"/>
-                </a:solidFill>
-                <a:latin typeface="Arial"/>
-              </a:rPr>
-              <a:t>•  </a:t>
-            </a:r>
-            <a:r>
-              <a:rPr sz="1200" b="1">
-                <a:solidFill>
-                  <a:srgbClr val="282828"/>
-                </a:solidFill>
-                <a:latin typeface="Arial"/>
-              </a:rPr>
-              <a:t>Two measured readables:</a:t>
-            </a:r>
-            <a:r>
-              <a:rPr sz="1200" b="0">
-                <a:solidFill>
-                  <a:srgbClr val="282828"/>
-                </a:solidFill>
-                <a:latin typeface="Arial"/>
-              </a:rPr>
-              <a:t> DM1's command map carries the hex-gap lattice — the DMs are doing the gap work themselves (the no-apodizer A/B is the scoped follow-on); and the 0.90 Lyot stop removes only ~0.1% of the post-FPM energy — this train's rejected light is interior gap structure, not edge rings.</a:t>
-            </a:r>
-          </a:p>
-        </p:txBody>
-      </p:sp>
-      <p:pic>
-        <p:nvPicPr>
-          <p:cNvPr id="7" name="Picture 6" descr="cf3d_dm_state.png"/>
-          <p:cNvPicPr>
-            <a:picLocks noChangeAspect="1"/>
-          </p:cNvPicPr>
-          <p:nvPr/>
-        </p:nvPicPr>
-        <p:blipFill>
-          <a:blip r:embed="rId3"/>
-          <a:stretch>
-            <a:fillRect/>
-          </a:stretch>
-        </p:blipFill>
-        <p:spPr>
-          <a:xfrm>
-            <a:off x="4702699" y="5221224"/>
-            <a:ext cx="2786296" cy="1243075"/>
-          </a:xfrm>
-          <a:prstGeom prst="rect">
-            <a:avLst/>
-          </a:prstGeom>
-        </p:spPr>
-      </p:pic>
-      <p:sp>
-        <p:nvSpPr>
-          <p:cNvPr id="8" name="TextBox 7"/>
-          <p:cNvSpPr txBox="1"/>
-          <p:nvPr/>
-        </p:nvSpPr>
-        <p:spPr>
-          <a:xfrm>
-            <a:off x="411480" y="6482588"/>
-            <a:ext cx="11368735" cy="229107"/>
-          </a:xfrm>
-          <a:prstGeom prst="rect">
-            <a:avLst/>
-          </a:prstGeom>
-          <a:noFill/>
-        </p:spPr>
-        <p:txBody>
-          <a:bodyPr wrap="square">
-            <a:spAutoFit/>
-          </a:bodyPr>
-          <a:lstStyle/>
-          <a:p>
-            <a:pPr algn="ctr">
-              <a:spcAft>
-                <a:spcPts val="0"/>
-              </a:spcAft>
-            </a:pPr>
-            <a:r>
-              <a:rPr sz="1000" b="0">
-                <a:solidFill>
-                  <a:srgbClr val="6E6E6E"/>
-                </a:solidFill>
-                <a:latin typeface="Arial"/>
-              </a:rPr>
-              <a:t>The dug command state: DM1 imprints the gap lattice; strokes ~33 nm rms, peaks ~160 nm.</a:t>
+              <a:t>Twenty-four hours under JWST-class drift, both passes starting at the dug dark hole: segment state, exit-pupil wavefront, science-plane contrast.</a:t>
             </a:r>
           </a:p>
         </p:txBody>
@@ -7502,7 +7468,7 @@
                 </a:solidFill>
                 <a:latin typeface="Arial"/>
               </a:rPr>
-              <a:t> — 1298× open loop — and the control loop that answers it is measured too: 1.7e-06 open against 2.5e-07 closed at the end of the soak.</a:t>
+              <a:t> — 1298× open loop — and the control loop that answers it is measured too: under JWST-class drift the open loop decays to 3.9e-05 in a day while the closed loop holds 2.0e-09 — starting from, and keeping, the dug dark hole.</a:t>
             </a:r>
           </a:p>
           <a:p>
@@ -10202,7 +10168,7 @@
                 </a:solidFill>
                 <a:latin typeface="Arial"/>
               </a:rPr>
-              <a:t>•  cf_chain + cf1_families..cf4_physics — the coronagraph-family campaign; cf3d_deepdig + cf3d_stations — the restart ladder and its station graphics.</a:t>
+              <a:t>•  cf_chain + cf1_families..cf4_physics — the coronagraph-family campaign; cf3d_deepdig + cf3d_stations — the restart ladder and its station graphics; cf5b_jwst_series — the JWST-class drift series on the dug state.</a:t>
             </a:r>
           </a:p>
           <a:p>

</xml_diff>